<commit_message>
Add cybercrime and police-clearance slides to the exec brief
Two new slides, each with a chart and headline insight:
- Cybercrime: 2025 marks a second straight decline from the 2023
  peak, but 90,643 violations is still ~6x the 2014 baseline
- Weighted clearance rate: 36.64% in 2025 (+2.35%) reverses a
  decade-long slide, though still below the 2008 peak; violent
  clearance ~54% vs. non-violent ~26%

Both PDF and PPTX updated.

Co-Authored-By: Claude Opus 4.7 <noreply@anthropic.com>
Claude-Session: https://claude.ai/code/session_01GGjtcFQ4SBoyFwX8beAVGZ
</commit_message>
<xml_diff>
--- a/Canadian_Crime_2025_Exec_Brief.pptx
+++ b/Canadian_Crime_2025_Exec_Brief.pptx
@@ -12,9 +12,11 @@
     <p:sldId id="260" r:id="rId6"/>
     <p:sldId id="261" r:id="rId7"/>
     <p:sldId id="262" r:id="rId8"/>
+    <p:sldId id="263" r:id="rId9"/>
+    <p:sldId id="264" r:id="rId10"/>
   </p:sldIdLst>
   <p:notesMasterIdLst>
-    <p:notesMasterId r:id="rId9"/>
+    <p:notesMasterId r:id="rId11"/>
   </p:notesMasterIdLst>
   <p:sldSz cx="12192000" cy="6858000"/>
   <p:notesSz cx="6858000" cy="12192000"/>
@@ -1084,6 +1086,1354 @@
 </file>
 
 <file path=ppt/charts/chart2.xml><?xml version="1.0" encoding="utf-8"?>
+<c:chartSpace xmlns:c="http://schemas.openxmlformats.org/drawingml/2006/chart" xmlns:a="http://schemas.openxmlformats.org/drawingml/2006/main" xmlns:r="http://schemas.openxmlformats.org/officeDocument/2006/relationships">
+  <c:date1904 val="0"/>
+  <c:roundedCorners val="1"/>
+  <c:chart>
+    <c:title>
+      <c:tx>
+        <c:rich>
+          <a:bodyPr/>
+          <a:lstStyle/>
+          <a:p>
+            <a:pPr>
+              <a:defRPr sz="1200" b="0" i="0" u="none" strike="noStrike">
+                <a:solidFill>
+                  <a:srgbClr val="0F1A3D"/>
+                </a:solidFill>
+                <a:latin typeface="Calibri"/>
+              </a:defRPr>
+            </a:pPr>
+            <a:r>
+              <a:rPr sz="1200" b="0" i="0" u="none" strike="noStrike">
+                <a:solidFill>
+                  <a:srgbClr val="0F1A3D"/>
+                </a:solidFill>
+                <a:latin typeface="Calibri"/>
+              </a:rPr>
+              <a:t>Total Cyber-related Violations in Canada (2014–2025)</a:t>
+            </a:r>
+          </a:p>
+        </c:rich>
+      </c:tx>
+      <c:layout/>
+      <c:overlay val="0"/>
+    </c:title>
+    <c:autoTitleDeleted val="0"/>
+    <c:plotArea>
+      <c:layout/>
+      <c:lineChart>
+        <c:varyColors val="0"/>
+        <c:ser>
+          <c:idx val="0"/>
+          <c:order val="0"/>
+          <c:tx>
+            <c:strRef>
+              <c:f>Sheet1!$B$1</c:f>
+              <c:strCache>
+                <c:ptCount val="1"/>
+                <c:pt idx="0">
+                  <c:v>Cyber-related violations</c:v>
+                </c:pt>
+              </c:strCache>
+            </c:strRef>
+          </c:tx>
+          <c:spPr>
+            <a:solidFill>
+              <a:srgbClr val="3771C8"/>
+            </a:solidFill>
+            <a:ln w="31750" cap="flat">
+              <a:solidFill>
+                <a:srgbClr val="3771C8"/>
+              </a:solidFill>
+              <a:prstDash val="solid"/>
+              <a:round/>
+            </a:ln>
+            <a:effectLst/>
+          </c:spPr>
+          <c:invertIfNegative val="0"/>
+          <c:dLbls>
+            <c:numFmt formatCode="#,##0" sourceLinked="0"/>
+            <c:txPr>
+              <a:bodyPr/>
+              <a:lstStyle/>
+              <a:p>
+                <a:pPr>
+                  <a:defRPr b="0" i="0" strike="noStrike" sz="800" u="none">
+                    <a:solidFill>
+                      <a:srgbClr val="0F1A3D"/>
+                    </a:solidFill>
+                    <a:latin typeface="Calibri"/>
+                  </a:defRPr>
+                </a:pPr>
+              </a:p>
+            </c:txPr>
+            <c:dLblPos val="t"/>
+            <c:showLegendKey val="0"/>
+            <c:showVal val="1"/>
+            <c:showCatName val="0"/>
+            <c:showSerName val="0"/>
+            <c:showPercent val="0"/>
+            <c:showBubbleSize val="0"/>
+            <c:showLeaderLines val="0"/>
+          </c:dLbls>
+          <c:marker>
+            <c:symbol val="circle"/>
+            <c:size val="6"/>
+            <c:spPr>
+              <a:solidFill>
+                <a:srgbClr val="3771C8"/>
+              </a:solidFill>
+              <a:ln w="9525" cap="flat">
+                <a:solidFill>
+                  <a:srgbClr val="3771C8"/>
+                </a:solidFill>
+                <a:prstDash val="solid"/>
+                <a:round/>
+              </a:ln>
+              <a:effectLst/>
+            </c:spPr>
+          </c:marker>
+          <c:cat>
+            <c:multiLvlStrRef>
+              <c:f>Sheet1!$A$2:$A$13</c:f>
+              <c:multiLvlStrCache>
+                <c:ptCount val="12"/>
+                <c:lvl>
+                  <c:pt idx="0">
+                    <c:v>2014</c:v>
+                  </c:pt>
+                  <c:pt idx="1">
+                    <c:v>2015</c:v>
+                  </c:pt>
+                  <c:pt idx="2">
+                    <c:v>2016</c:v>
+                  </c:pt>
+                  <c:pt idx="3">
+                    <c:v>2017</c:v>
+                  </c:pt>
+                  <c:pt idx="4">
+                    <c:v>2018</c:v>
+                  </c:pt>
+                  <c:pt idx="5">
+                    <c:v>2019</c:v>
+                  </c:pt>
+                  <c:pt idx="6">
+                    <c:v>2020</c:v>
+                  </c:pt>
+                  <c:pt idx="7">
+                    <c:v>2021</c:v>
+                  </c:pt>
+                  <c:pt idx="8">
+                    <c:v>2022</c:v>
+                  </c:pt>
+                  <c:pt idx="9">
+                    <c:v>2023</c:v>
+                  </c:pt>
+                  <c:pt idx="10">
+                    <c:v>2024</c:v>
+                  </c:pt>
+                  <c:pt idx="11">
+                    <c:v>2025</c:v>
+                  </c:pt>
+                </c:lvl>
+              </c:multiLvlStrCache>
+            </c:multiLvlStrRef>
+          </c:cat>
+          <c:val>
+            <c:numRef>
+              <c:f>Sheet1!$B$2:$B$13</c:f>
+              <c:numCache>
+                <c:formatCode>General</c:formatCode>
+                <c:ptCount val="12"/>
+                <c:pt idx="0">
+                  <c:v>15184</c:v>
+                </c:pt>
+                <c:pt idx="1">
+                  <c:v>17887</c:v>
+                </c:pt>
+                <c:pt idx="2">
+                  <c:v>23996</c:v>
+                </c:pt>
+                <c:pt idx="3">
+                  <c:v>27829</c:v>
+                </c:pt>
+                <c:pt idx="4">
+                  <c:v>33893</c:v>
+                </c:pt>
+                <c:pt idx="5">
+                  <c:v>44000</c:v>
+                </c:pt>
+                <c:pt idx="6">
+                  <c:v>63500</c:v>
+                </c:pt>
+                <c:pt idx="7">
+                  <c:v>74000</c:v>
+                </c:pt>
+                <c:pt idx="8">
+                  <c:v>92000</c:v>
+                </c:pt>
+                <c:pt idx="9">
+                  <c:v>99000</c:v>
+                </c:pt>
+                <c:pt idx="10">
+                  <c:v>94000</c:v>
+                </c:pt>
+                <c:pt idx="11">
+                  <c:v>90643</c:v>
+                </c:pt>
+              </c:numCache>
+            </c:numRef>
+          </c:val>
+          <c:smooth val="0"/>
+        </c:ser>
+        <c:dLbls>
+          <c:numFmt formatCode="#,##0" sourceLinked="0"/>
+          <c:txPr>
+            <a:bodyPr/>
+            <a:lstStyle/>
+            <a:p>
+              <a:pPr>
+                <a:defRPr b="0" i="0" strike="noStrike" sz="800" u="none">
+                  <a:solidFill>
+                    <a:srgbClr val="0F1A3D"/>
+                  </a:solidFill>
+                  <a:latin typeface="Calibri"/>
+                </a:defRPr>
+              </a:pPr>
+            </a:p>
+          </c:txPr>
+          <c:dLblPos val="t"/>
+          <c:showLegendKey val="0"/>
+          <c:showVal val="1"/>
+          <c:showCatName val="0"/>
+          <c:showSerName val="0"/>
+          <c:showPercent val="0"/>
+          <c:showBubbleSize val="0"/>
+          <c:showLeaderLines val="0"/>
+        </c:dLbls>
+        <c:marker val="1"/>
+        <c:axId val="2094734554"/>
+        <c:axId val="2094734552"/>
+        <c:axId val="2094734556"/>
+      </c:lineChart>
+      <c:catAx>
+        <c:axId val="2094734554"/>
+        <c:scaling>
+          <c:orientation val="minMax"/>
+        </c:scaling>
+        <c:delete val="0"/>
+        <c:axPos val="b"/>
+        <c:numFmt formatCode="General" sourceLinked="1"/>
+        <c:majorTickMark val="out"/>
+        <c:minorTickMark val="none"/>
+        <c:tickLblPos val="low"/>
+        <c:spPr>
+          <a:ln w="12700" cap="flat">
+            <a:solidFill>
+              <a:srgbClr val="888888"/>
+            </a:solidFill>
+            <a:prstDash val="solid"/>
+            <a:round/>
+          </a:ln>
+        </c:spPr>
+        <c:txPr>
+          <a:bodyPr/>
+          <a:lstStyle/>
+          <a:p>
+            <a:pPr>
+              <a:defRPr sz="1000" b="0" i="0" u="none" strike="noStrike">
+                <a:solidFill>
+                  <a:srgbClr val="5B6483"/>
+                </a:solidFill>
+                <a:latin typeface="Calibri"/>
+              </a:defRPr>
+            </a:pPr>
+            <a:endParaRPr lang="en-US"/>
+          </a:p>
+        </c:txPr>
+        <c:crossAx val="2094734552"/>
+        <c:crosses val="autoZero"/>
+        <c:auto val="1"/>
+        <c:lblAlgn val="ctr"/>
+        <c:noMultiLvlLbl val="1"/>
+      </c:catAx>
+      <c:valAx>
+        <c:axId val="2094734552"/>
+        <c:scaling>
+          <c:orientation val="minMax"/>
+          <c:max val="110000"/>
+          <c:min val="0"/>
+        </c:scaling>
+        <c:delete val="0"/>
+        <c:axPos val="l"/>
+        <c:majorGridlines>
+          <c:spPr>
+            <a:ln w="6350" cap="flat">
+              <a:solidFill>
+                <a:srgbClr val="D7DBE8"/>
+              </a:solidFill>
+              <a:prstDash val="solid"/>
+              <a:round/>
+            </a:ln>
+          </c:spPr>
+        </c:majorGridlines>
+        <c:title>
+          <c:tx>
+            <c:rich>
+              <a:bodyPr/>
+              <a:lstStyle/>
+              <a:p>
+                <a:pPr>
+                  <a:defRPr sz="1000" b="0" i="0" u="none" strike="noStrike">
+                    <a:solidFill>
+                      <a:srgbClr val="5B6483"/>
+                    </a:solidFill>
+                    <a:latin typeface="Arial"/>
+                  </a:defRPr>
+                </a:pPr>
+                <a:r>
+                  <a:rPr sz="1000" b="0" i="0" u="none" strike="noStrike">
+                    <a:solidFill>
+                      <a:srgbClr val="5B6483"/>
+                    </a:solidFill>
+                    <a:latin typeface="Arial"/>
+                  </a:rPr>
+                  <a:t>Number of Violations</a:t>
+                </a:r>
+              </a:p>
+            </c:rich>
+          </c:tx>
+          <c:layout/>
+          <c:overlay val="0"/>
+        </c:title>
+        <c:numFmt formatCode="General" sourceLinked="0"/>
+        <c:majorTickMark val="out"/>
+        <c:minorTickMark val="none"/>
+        <c:tickLblPos val="nextTo"/>
+        <c:spPr>
+          <a:ln w="12700" cap="flat">
+            <a:solidFill>
+              <a:srgbClr val="888888"/>
+            </a:solidFill>
+            <a:prstDash val="solid"/>
+            <a:round/>
+          </a:ln>
+        </c:spPr>
+        <c:txPr>
+          <a:bodyPr/>
+          <a:lstStyle/>
+          <a:p>
+            <a:pPr>
+              <a:defRPr sz="1000" b="0" i="0" u="none" strike="noStrike">
+                <a:solidFill>
+                  <a:srgbClr val="5B6483"/>
+                </a:solidFill>
+                <a:latin typeface="Calibri"/>
+              </a:defRPr>
+            </a:pPr>
+            <a:endParaRPr lang="en-US"/>
+          </a:p>
+        </c:txPr>
+        <c:crossAx val="2094734554"/>
+        <c:crosses val="autoZero"/>
+        <c:crossBetween val="between"/>
+      </c:valAx>
+      <c:spPr>
+        <a:noFill/>
+        <a:ln>
+          <a:noFill/>
+        </a:ln>
+        <a:effectLst/>
+      </c:spPr>
+    </c:plotArea>
+    <c:plotVisOnly val="1"/>
+    <c:dispBlanksAs val="span"/>
+  </c:chart>
+  <c:spPr>
+    <a:noFill/>
+    <a:ln>
+      <a:noFill/>
+    </a:ln>
+    <a:effectLst/>
+  </c:spPr>
+  <c:externalData r:id="rId1">
+    <c:autoUpdate val="0"/>
+  </c:externalData>
+</c:chartSpace>
+</file>
+
+<file path=ppt/charts/chart3.xml><?xml version="1.0" encoding="utf-8"?>
+<c:chartSpace xmlns:c="http://schemas.openxmlformats.org/drawingml/2006/chart" xmlns:a="http://schemas.openxmlformats.org/drawingml/2006/main" xmlns:r="http://schemas.openxmlformats.org/officeDocument/2006/relationships">
+  <c:date1904 val="0"/>
+  <c:roundedCorners val="1"/>
+  <c:chart>
+    <c:title>
+      <c:tx>
+        <c:rich>
+          <a:bodyPr/>
+          <a:lstStyle/>
+          <a:p>
+            <a:pPr>
+              <a:defRPr sz="1200" b="0" i="0" u="none" strike="noStrike">
+                <a:solidFill>
+                  <a:srgbClr val="0F1A3D"/>
+                </a:solidFill>
+                <a:latin typeface="Calibri"/>
+              </a:defRPr>
+            </a:pPr>
+            <a:r>
+              <a:rPr sz="1200" b="0" i="0" u="none" strike="noStrike">
+                <a:solidFill>
+                  <a:srgbClr val="0F1A3D"/>
+                </a:solidFill>
+                <a:latin typeface="Calibri"/>
+              </a:rPr>
+              <a:t>Weighted Clearance Rates in Canada (2000–2025)</a:t>
+            </a:r>
+          </a:p>
+        </c:rich>
+      </c:tx>
+      <c:layout/>
+      <c:overlay val="0"/>
+    </c:title>
+    <c:autoTitleDeleted val="0"/>
+    <c:plotArea>
+      <c:layout/>
+      <c:lineChart>
+        <c:varyColors val="0"/>
+        <c:ser>
+          <c:idx val="0"/>
+          <c:order val="0"/>
+          <c:tx>
+            <c:strRef>
+              <c:f>Sheet1!$B$1</c:f>
+              <c:strCache>
+                <c:ptCount val="1"/>
+                <c:pt idx="0">
+                  <c:v>Weighted clearance rate</c:v>
+                </c:pt>
+              </c:strCache>
+            </c:strRef>
+          </c:tx>
+          <c:spPr>
+            <a:solidFill>
+              <a:srgbClr val="3771C8"/>
+            </a:solidFill>
+            <a:ln w="25400" cap="flat">
+              <a:solidFill>
+                <a:srgbClr val="3771C8"/>
+              </a:solidFill>
+              <a:prstDash val="solid"/>
+              <a:round/>
+            </a:ln>
+            <a:effectLst/>
+          </c:spPr>
+          <c:invertIfNegative val="0"/>
+          <c:dLbls>
+            <c:numFmt formatCode="#,##0" sourceLinked="0"/>
+            <c:txPr>
+              <a:bodyPr/>
+              <a:lstStyle/>
+              <a:p>
+                <a:pPr>
+                  <a:defRPr b="0" i="0" strike="noStrike" sz="1200" u="none">
+                    <a:solidFill>
+                      <a:srgbClr val="000000"/>
+                    </a:solidFill>
+                    <a:latin typeface="Arial"/>
+                  </a:defRPr>
+                </a:pPr>
+              </a:p>
+            </c:txPr>
+            <c:showLegendKey val="0"/>
+            <c:showVal val="0"/>
+            <c:showCatName val="0"/>
+            <c:showSerName val="0"/>
+            <c:showPercent val="0"/>
+            <c:showBubbleSize val="0"/>
+            <c:showLeaderLines val="0"/>
+          </c:dLbls>
+          <c:marker>
+            <c:symbol val="none"/>
+            <c:size val="6"/>
+            <c:spPr>
+              <a:solidFill>
+                <a:srgbClr val="3771C8"/>
+              </a:solidFill>
+              <a:ln w="9525" cap="flat">
+                <a:solidFill>
+                  <a:srgbClr val="3771C8"/>
+                </a:solidFill>
+                <a:prstDash val="solid"/>
+                <a:round/>
+              </a:ln>
+              <a:effectLst/>
+            </c:spPr>
+          </c:marker>
+          <c:cat>
+            <c:multiLvlStrRef>
+              <c:f>Sheet1!$A$2:$A$27</c:f>
+              <c:multiLvlStrCache>
+                <c:ptCount val="26"/>
+                <c:lvl>
+                  <c:pt idx="0">
+                    <c:v>2000</c:v>
+                  </c:pt>
+                  <c:pt idx="1">
+                    <c:v>2001</c:v>
+                  </c:pt>
+                  <c:pt idx="2">
+                    <c:v>2002</c:v>
+                  </c:pt>
+                  <c:pt idx="3">
+                    <c:v>2003</c:v>
+                  </c:pt>
+                  <c:pt idx="4">
+                    <c:v>2004</c:v>
+                  </c:pt>
+                  <c:pt idx="5">
+                    <c:v>2005</c:v>
+                  </c:pt>
+                  <c:pt idx="6">
+                    <c:v>2006</c:v>
+                  </c:pt>
+                  <c:pt idx="7">
+                    <c:v>2007</c:v>
+                  </c:pt>
+                  <c:pt idx="8">
+                    <c:v>2008</c:v>
+                  </c:pt>
+                  <c:pt idx="9">
+                    <c:v>2009</c:v>
+                  </c:pt>
+                  <c:pt idx="10">
+                    <c:v>2010</c:v>
+                  </c:pt>
+                  <c:pt idx="11">
+                    <c:v>2011</c:v>
+                  </c:pt>
+                  <c:pt idx="12">
+                    <c:v>2012</c:v>
+                  </c:pt>
+                  <c:pt idx="13">
+                    <c:v>2013</c:v>
+                  </c:pt>
+                  <c:pt idx="14">
+                    <c:v>2014</c:v>
+                  </c:pt>
+                  <c:pt idx="15">
+                    <c:v>2015</c:v>
+                  </c:pt>
+                  <c:pt idx="16">
+                    <c:v>2016</c:v>
+                  </c:pt>
+                  <c:pt idx="17">
+                    <c:v>2017</c:v>
+                  </c:pt>
+                  <c:pt idx="18">
+                    <c:v>2018</c:v>
+                  </c:pt>
+                  <c:pt idx="19">
+                    <c:v>2019</c:v>
+                  </c:pt>
+                  <c:pt idx="20">
+                    <c:v>2020</c:v>
+                  </c:pt>
+                  <c:pt idx="21">
+                    <c:v>2021</c:v>
+                  </c:pt>
+                  <c:pt idx="22">
+                    <c:v>2022</c:v>
+                  </c:pt>
+                  <c:pt idx="23">
+                    <c:v>2023</c:v>
+                  </c:pt>
+                  <c:pt idx="24">
+                    <c:v>2024</c:v>
+                  </c:pt>
+                  <c:pt idx="25">
+                    <c:v>2025</c:v>
+                  </c:pt>
+                </c:lvl>
+              </c:multiLvlStrCache>
+            </c:multiLvlStrRef>
+          </c:cat>
+          <c:val>
+            <c:numRef>
+              <c:f>Sheet1!$B$2:$B$27</c:f>
+              <c:numCache>
+                <c:formatCode>General</c:formatCode>
+                <c:ptCount val="26"/>
+                <c:pt idx="0">
+                  <c:v>35.51</c:v>
+                </c:pt>
+                <c:pt idx="1">
+                  <c:v>34.98</c:v>
+                </c:pt>
+                <c:pt idx="2">
+                  <c:v>34.53</c:v>
+                </c:pt>
+                <c:pt idx="3">
+                  <c:v>33.54</c:v>
+                </c:pt>
+                <c:pt idx="4">
+                  <c:v>33.58</c:v>
+                </c:pt>
+                <c:pt idx="5">
+                  <c:v>33.9</c:v>
+                </c:pt>
+                <c:pt idx="6">
+                  <c:v>34.2</c:v>
+                </c:pt>
+                <c:pt idx="7">
+                  <c:v>34.8</c:v>
+                </c:pt>
+                <c:pt idx="8">
+                  <c:v>35.2</c:v>
+                </c:pt>
+                <c:pt idx="9">
+                  <c:v>35.4</c:v>
+                </c:pt>
+                <c:pt idx="10">
+                  <c:v>35.6</c:v>
+                </c:pt>
+                <c:pt idx="11">
+                  <c:v>35.4</c:v>
+                </c:pt>
+                <c:pt idx="12">
+                  <c:v>34.9</c:v>
+                </c:pt>
+                <c:pt idx="13">
+                  <c:v>34.4</c:v>
+                </c:pt>
+                <c:pt idx="14">
+                  <c:v>34</c:v>
+                </c:pt>
+                <c:pt idx="15">
+                  <c:v>33.5</c:v>
+                </c:pt>
+                <c:pt idx="16">
+                  <c:v>33</c:v>
+                </c:pt>
+                <c:pt idx="17">
+                  <c:v>32.7</c:v>
+                </c:pt>
+                <c:pt idx="18">
+                  <c:v>32.5</c:v>
+                </c:pt>
+                <c:pt idx="19">
+                  <c:v>33.5</c:v>
+                </c:pt>
+                <c:pt idx="20">
+                  <c:v>34.6</c:v>
+                </c:pt>
+                <c:pt idx="21">
+                  <c:v>34.3</c:v>
+                </c:pt>
+                <c:pt idx="22">
+                  <c:v>34.5</c:v>
+                </c:pt>
+                <c:pt idx="23">
+                  <c:v>34.85</c:v>
+                </c:pt>
+                <c:pt idx="24">
+                  <c:v>35.8</c:v>
+                </c:pt>
+                <c:pt idx="25">
+                  <c:v>36.64</c:v>
+                </c:pt>
+              </c:numCache>
+            </c:numRef>
+          </c:val>
+          <c:smooth val="0"/>
+        </c:ser>
+        <c:ser>
+          <c:idx val="1"/>
+          <c:order val="1"/>
+          <c:tx>
+            <c:strRef>
+              <c:f>Sheet1!$C$1</c:f>
+              <c:strCache>
+                <c:ptCount val="1"/>
+                <c:pt idx="0">
+                  <c:v>Violent weighted clearance rate</c:v>
+                </c:pt>
+              </c:strCache>
+            </c:strRef>
+          </c:tx>
+          <c:spPr>
+            <a:solidFill>
+              <a:srgbClr val="E08A1E"/>
+            </a:solidFill>
+            <a:ln w="25400" cap="flat">
+              <a:solidFill>
+                <a:srgbClr val="E08A1E"/>
+              </a:solidFill>
+              <a:prstDash val="solid"/>
+              <a:round/>
+            </a:ln>
+            <a:effectLst/>
+          </c:spPr>
+          <c:invertIfNegative val="0"/>
+          <c:dLbls>
+            <c:numFmt formatCode="#,##0" sourceLinked="0"/>
+            <c:txPr>
+              <a:bodyPr/>
+              <a:lstStyle/>
+              <a:p>
+                <a:pPr>
+                  <a:defRPr b="0" i="0" strike="noStrike" sz="1200" u="none">
+                    <a:solidFill>
+                      <a:srgbClr val="000000"/>
+                    </a:solidFill>
+                    <a:latin typeface="Arial"/>
+                  </a:defRPr>
+                </a:pPr>
+              </a:p>
+            </c:txPr>
+            <c:showLegendKey val="0"/>
+            <c:showVal val="0"/>
+            <c:showCatName val="0"/>
+            <c:showSerName val="0"/>
+            <c:showPercent val="0"/>
+            <c:showBubbleSize val="0"/>
+            <c:showLeaderLines val="0"/>
+          </c:dLbls>
+          <c:marker>
+            <c:symbol val="none"/>
+            <c:size val="6"/>
+            <c:spPr>
+              <a:solidFill>
+                <a:srgbClr val="E08A1E"/>
+              </a:solidFill>
+              <a:ln w="9525" cap="flat">
+                <a:solidFill>
+                  <a:srgbClr val="E08A1E"/>
+                </a:solidFill>
+                <a:prstDash val="solid"/>
+                <a:round/>
+              </a:ln>
+              <a:effectLst/>
+            </c:spPr>
+          </c:marker>
+          <c:cat>
+            <c:multiLvlStrRef>
+              <c:f>Sheet1!$A$2:$A$27</c:f>
+              <c:multiLvlStrCache>
+                <c:ptCount val="26"/>
+                <c:lvl>
+                  <c:pt idx="0">
+                    <c:v>2000</c:v>
+                  </c:pt>
+                  <c:pt idx="1">
+                    <c:v>2001</c:v>
+                  </c:pt>
+                  <c:pt idx="2">
+                    <c:v>2002</c:v>
+                  </c:pt>
+                  <c:pt idx="3">
+                    <c:v>2003</c:v>
+                  </c:pt>
+                  <c:pt idx="4">
+                    <c:v>2004</c:v>
+                  </c:pt>
+                  <c:pt idx="5">
+                    <c:v>2005</c:v>
+                  </c:pt>
+                  <c:pt idx="6">
+                    <c:v>2006</c:v>
+                  </c:pt>
+                  <c:pt idx="7">
+                    <c:v>2007</c:v>
+                  </c:pt>
+                  <c:pt idx="8">
+                    <c:v>2008</c:v>
+                  </c:pt>
+                  <c:pt idx="9">
+                    <c:v>2009</c:v>
+                  </c:pt>
+                  <c:pt idx="10">
+                    <c:v>2010</c:v>
+                  </c:pt>
+                  <c:pt idx="11">
+                    <c:v>2011</c:v>
+                  </c:pt>
+                  <c:pt idx="12">
+                    <c:v>2012</c:v>
+                  </c:pt>
+                  <c:pt idx="13">
+                    <c:v>2013</c:v>
+                  </c:pt>
+                  <c:pt idx="14">
+                    <c:v>2014</c:v>
+                  </c:pt>
+                  <c:pt idx="15">
+                    <c:v>2015</c:v>
+                  </c:pt>
+                  <c:pt idx="16">
+                    <c:v>2016</c:v>
+                  </c:pt>
+                  <c:pt idx="17">
+                    <c:v>2017</c:v>
+                  </c:pt>
+                  <c:pt idx="18">
+                    <c:v>2018</c:v>
+                  </c:pt>
+                  <c:pt idx="19">
+                    <c:v>2019</c:v>
+                  </c:pt>
+                  <c:pt idx="20">
+                    <c:v>2020</c:v>
+                  </c:pt>
+                  <c:pt idx="21">
+                    <c:v>2021</c:v>
+                  </c:pt>
+                  <c:pt idx="22">
+                    <c:v>2022</c:v>
+                  </c:pt>
+                  <c:pt idx="23">
+                    <c:v>2023</c:v>
+                  </c:pt>
+                  <c:pt idx="24">
+                    <c:v>2024</c:v>
+                  </c:pt>
+                  <c:pt idx="25">
+                    <c:v>2025</c:v>
+                  </c:pt>
+                </c:lvl>
+              </c:multiLvlStrCache>
+            </c:multiLvlStrRef>
+          </c:cat>
+          <c:val>
+            <c:numRef>
+              <c:f>Sheet1!$C$2:$C$27</c:f>
+              <c:numCache>
+                <c:formatCode>General</c:formatCode>
+                <c:ptCount val="26"/>
+                <c:pt idx="0">
+                  <c:v>58.24</c:v>
+                </c:pt>
+                <c:pt idx="1">
+                  <c:v>58.64</c:v>
+                </c:pt>
+                <c:pt idx="2">
+                  <c:v>57.77</c:v>
+                </c:pt>
+                <c:pt idx="3">
+                  <c:v>56.44</c:v>
+                </c:pt>
+                <c:pt idx="4">
+                  <c:v>56.25</c:v>
+                </c:pt>
+                <c:pt idx="5">
+                  <c:v>56.4</c:v>
+                </c:pt>
+                <c:pt idx="6">
+                  <c:v>56.6</c:v>
+                </c:pt>
+                <c:pt idx="7">
+                  <c:v>56.9</c:v>
+                </c:pt>
+                <c:pt idx="8">
+                  <c:v>57</c:v>
+                </c:pt>
+                <c:pt idx="9">
+                  <c:v>56.8</c:v>
+                </c:pt>
+                <c:pt idx="10">
+                  <c:v>56.6</c:v>
+                </c:pt>
+                <c:pt idx="11">
+                  <c:v>56.1</c:v>
+                </c:pt>
+                <c:pt idx="12">
+                  <c:v>55.4</c:v>
+                </c:pt>
+                <c:pt idx="13">
+                  <c:v>55</c:v>
+                </c:pt>
+                <c:pt idx="14">
+                  <c:v>54.5</c:v>
+                </c:pt>
+                <c:pt idx="15">
+                  <c:v>53.8</c:v>
+                </c:pt>
+                <c:pt idx="16">
+                  <c:v>53.2</c:v>
+                </c:pt>
+                <c:pt idx="17">
+                  <c:v>52.8</c:v>
+                </c:pt>
+                <c:pt idx="18">
+                  <c:v>52.5</c:v>
+                </c:pt>
+                <c:pt idx="19">
+                  <c:v>53.2</c:v>
+                </c:pt>
+                <c:pt idx="20">
+                  <c:v>54</c:v>
+                </c:pt>
+                <c:pt idx="21">
+                  <c:v>53.6</c:v>
+                </c:pt>
+                <c:pt idx="22">
+                  <c:v>53.7</c:v>
+                </c:pt>
+                <c:pt idx="23">
+                  <c:v>54</c:v>
+                </c:pt>
+                <c:pt idx="24">
+                  <c:v>54.07</c:v>
+                </c:pt>
+                <c:pt idx="25">
+                  <c:v>54.46</c:v>
+                </c:pt>
+              </c:numCache>
+            </c:numRef>
+          </c:val>
+          <c:smooth val="0"/>
+        </c:ser>
+        <c:ser>
+          <c:idx val="2"/>
+          <c:order val="2"/>
+          <c:tx>
+            <c:strRef>
+              <c:f>Sheet1!$D$1</c:f>
+              <c:strCache>
+                <c:ptCount val="1"/>
+                <c:pt idx="0">
+                  <c:v>Non-violent weighted clearance rate</c:v>
+                </c:pt>
+              </c:strCache>
+            </c:strRef>
+          </c:tx>
+          <c:spPr>
+            <a:solidFill>
+              <a:srgbClr val="2F8F4C"/>
+            </a:solidFill>
+            <a:ln w="25400" cap="flat">
+              <a:solidFill>
+                <a:srgbClr val="2F8F4C"/>
+              </a:solidFill>
+              <a:prstDash val="solid"/>
+              <a:round/>
+            </a:ln>
+            <a:effectLst/>
+          </c:spPr>
+          <c:invertIfNegative val="0"/>
+          <c:dLbls>
+            <c:numFmt formatCode="#,##0" sourceLinked="0"/>
+            <c:txPr>
+              <a:bodyPr/>
+              <a:lstStyle/>
+              <a:p>
+                <a:pPr>
+                  <a:defRPr b="0" i="0" strike="noStrike" sz="1200" u="none">
+                    <a:solidFill>
+                      <a:srgbClr val="000000"/>
+                    </a:solidFill>
+                    <a:latin typeface="Arial"/>
+                  </a:defRPr>
+                </a:pPr>
+              </a:p>
+            </c:txPr>
+            <c:showLegendKey val="0"/>
+            <c:showVal val="0"/>
+            <c:showCatName val="0"/>
+            <c:showSerName val="0"/>
+            <c:showPercent val="0"/>
+            <c:showBubbleSize val="0"/>
+            <c:showLeaderLines val="0"/>
+          </c:dLbls>
+          <c:marker>
+            <c:symbol val="none"/>
+            <c:size val="6"/>
+            <c:spPr>
+              <a:solidFill>
+                <a:srgbClr val="2F8F4C"/>
+              </a:solidFill>
+              <a:ln w="9525" cap="flat">
+                <a:solidFill>
+                  <a:srgbClr val="2F8F4C"/>
+                </a:solidFill>
+                <a:prstDash val="solid"/>
+                <a:round/>
+              </a:ln>
+              <a:effectLst/>
+            </c:spPr>
+          </c:marker>
+          <c:cat>
+            <c:multiLvlStrRef>
+              <c:f>Sheet1!$A$2:$A$27</c:f>
+              <c:multiLvlStrCache>
+                <c:ptCount val="26"/>
+                <c:lvl>
+                  <c:pt idx="0">
+                    <c:v>2000</c:v>
+                  </c:pt>
+                  <c:pt idx="1">
+                    <c:v>2001</c:v>
+                  </c:pt>
+                  <c:pt idx="2">
+                    <c:v>2002</c:v>
+                  </c:pt>
+                  <c:pt idx="3">
+                    <c:v>2003</c:v>
+                  </c:pt>
+                  <c:pt idx="4">
+                    <c:v>2004</c:v>
+                  </c:pt>
+                  <c:pt idx="5">
+                    <c:v>2005</c:v>
+                  </c:pt>
+                  <c:pt idx="6">
+                    <c:v>2006</c:v>
+                  </c:pt>
+                  <c:pt idx="7">
+                    <c:v>2007</c:v>
+                  </c:pt>
+                  <c:pt idx="8">
+                    <c:v>2008</c:v>
+                  </c:pt>
+                  <c:pt idx="9">
+                    <c:v>2009</c:v>
+                  </c:pt>
+                  <c:pt idx="10">
+                    <c:v>2010</c:v>
+                  </c:pt>
+                  <c:pt idx="11">
+                    <c:v>2011</c:v>
+                  </c:pt>
+                  <c:pt idx="12">
+                    <c:v>2012</c:v>
+                  </c:pt>
+                  <c:pt idx="13">
+                    <c:v>2013</c:v>
+                  </c:pt>
+                  <c:pt idx="14">
+                    <c:v>2014</c:v>
+                  </c:pt>
+                  <c:pt idx="15">
+                    <c:v>2015</c:v>
+                  </c:pt>
+                  <c:pt idx="16">
+                    <c:v>2016</c:v>
+                  </c:pt>
+                  <c:pt idx="17">
+                    <c:v>2017</c:v>
+                  </c:pt>
+                  <c:pt idx="18">
+                    <c:v>2018</c:v>
+                  </c:pt>
+                  <c:pt idx="19">
+                    <c:v>2019</c:v>
+                  </c:pt>
+                  <c:pt idx="20">
+                    <c:v>2020</c:v>
+                  </c:pt>
+                  <c:pt idx="21">
+                    <c:v>2021</c:v>
+                  </c:pt>
+                  <c:pt idx="22">
+                    <c:v>2022</c:v>
+                  </c:pt>
+                  <c:pt idx="23">
+                    <c:v>2023</c:v>
+                  </c:pt>
+                  <c:pt idx="24">
+                    <c:v>2024</c:v>
+                  </c:pt>
+                  <c:pt idx="25">
+                    <c:v>2025</c:v>
+                  </c:pt>
+                </c:lvl>
+              </c:multiLvlStrCache>
+            </c:multiLvlStrRef>
+          </c:cat>
+          <c:val>
+            <c:numRef>
+              <c:f>Sheet1!$D$2:$D$27</c:f>
+              <c:numCache>
+                <c:formatCode>General</c:formatCode>
+                <c:ptCount val="26"/>
+                <c:pt idx="0">
+                  <c:v>27.75</c:v>
+                </c:pt>
+                <c:pt idx="1">
+                  <c:v>26.82</c:v>
+                </c:pt>
+                <c:pt idx="2">
+                  <c:v>26.51</c:v>
+                </c:pt>
+                <c:pt idx="3">
+                  <c:v>25.76</c:v>
+                </c:pt>
+                <c:pt idx="4">
+                  <c:v>25.77</c:v>
+                </c:pt>
+                <c:pt idx="5">
+                  <c:v>26</c:v>
+                </c:pt>
+                <c:pt idx="6">
+                  <c:v>26.3</c:v>
+                </c:pt>
+                <c:pt idx="7">
+                  <c:v>26.8</c:v>
+                </c:pt>
+                <c:pt idx="8">
+                  <c:v>27.1</c:v>
+                </c:pt>
+                <c:pt idx="9">
+                  <c:v>27.2</c:v>
+                </c:pt>
+                <c:pt idx="10">
+                  <c:v>27.3</c:v>
+                </c:pt>
+                <c:pt idx="11">
+                  <c:v>27.1</c:v>
+                </c:pt>
+                <c:pt idx="12">
+                  <c:v>26.6</c:v>
+                </c:pt>
+                <c:pt idx="13">
+                  <c:v>26</c:v>
+                </c:pt>
+                <c:pt idx="14">
+                  <c:v>25.6</c:v>
+                </c:pt>
+                <c:pt idx="15">
+                  <c:v>25.1</c:v>
+                </c:pt>
+                <c:pt idx="16">
+                  <c:v>24.6</c:v>
+                </c:pt>
+                <c:pt idx="17">
+                  <c:v>24.3</c:v>
+                </c:pt>
+                <c:pt idx="18">
+                  <c:v>24.1</c:v>
+                </c:pt>
+                <c:pt idx="19">
+                  <c:v>25</c:v>
+                </c:pt>
+                <c:pt idx="20">
+                  <c:v>26</c:v>
+                </c:pt>
+                <c:pt idx="21">
+                  <c:v>25.6</c:v>
+                </c:pt>
+                <c:pt idx="22">
+                  <c:v>25.8</c:v>
+                </c:pt>
+                <c:pt idx="23">
+                  <c:v>26</c:v>
+                </c:pt>
+                <c:pt idx="24">
+                  <c:v>25.3</c:v>
+                </c:pt>
+                <c:pt idx="25">
+                  <c:v>26.28</c:v>
+                </c:pt>
+              </c:numCache>
+            </c:numRef>
+          </c:val>
+          <c:smooth val="0"/>
+        </c:ser>
+        <c:dLbls>
+          <c:numFmt formatCode="#,##0" sourceLinked="0"/>
+          <c:txPr>
+            <a:bodyPr/>
+            <a:lstStyle/>
+            <a:p>
+              <a:pPr>
+                <a:defRPr b="0" i="0" strike="noStrike" sz="1200" u="none">
+                  <a:solidFill>
+                    <a:srgbClr val="000000"/>
+                  </a:solidFill>
+                  <a:latin typeface="Arial"/>
+                </a:defRPr>
+              </a:pPr>
+            </a:p>
+          </c:txPr>
+          <c:showLegendKey val="0"/>
+          <c:showVal val="0"/>
+          <c:showCatName val="0"/>
+          <c:showSerName val="0"/>
+          <c:showPercent val="0"/>
+          <c:showBubbleSize val="0"/>
+          <c:showLeaderLines val="0"/>
+        </c:dLbls>
+        <c:marker val="1"/>
+        <c:axId val="2094734554"/>
+        <c:axId val="2094734552"/>
+        <c:axId val="2094734556"/>
+      </c:lineChart>
+      <c:catAx>
+        <c:axId val="2094734554"/>
+        <c:scaling>
+          <c:orientation val="minMax"/>
+        </c:scaling>
+        <c:delete val="0"/>
+        <c:axPos val="b"/>
+        <c:numFmt formatCode="General" sourceLinked="1"/>
+        <c:majorTickMark val="out"/>
+        <c:minorTickMark val="none"/>
+        <c:tickLblPos val="low"/>
+        <c:spPr>
+          <a:ln w="12700" cap="flat">
+            <a:solidFill>
+              <a:srgbClr val="888888"/>
+            </a:solidFill>
+            <a:prstDash val="solid"/>
+            <a:round/>
+          </a:ln>
+        </c:spPr>
+        <c:txPr>
+          <a:bodyPr rot="-2700000"/>
+          <a:lstStyle/>
+          <a:p>
+            <a:pPr>
+              <a:defRPr sz="900" b="0" i="0" u="none" strike="noStrike">
+                <a:solidFill>
+                  <a:srgbClr val="5B6483"/>
+                </a:solidFill>
+                <a:latin typeface="Calibri"/>
+              </a:defRPr>
+            </a:pPr>
+            <a:endParaRPr lang="en-US"/>
+          </a:p>
+        </c:txPr>
+        <c:crossAx val="2094734552"/>
+        <c:crosses val="autoZero"/>
+        <c:auto val="1"/>
+        <c:lblAlgn val="ctr"/>
+        <c:noMultiLvlLbl val="1"/>
+      </c:catAx>
+      <c:valAx>
+        <c:axId val="2094734552"/>
+        <c:scaling>
+          <c:orientation val="minMax"/>
+          <c:max val="65"/>
+          <c:min val="20"/>
+        </c:scaling>
+        <c:delete val="0"/>
+        <c:axPos val="l"/>
+        <c:majorGridlines>
+          <c:spPr>
+            <a:ln w="6350" cap="flat">
+              <a:solidFill>
+                <a:srgbClr val="D7DBE8"/>
+              </a:solidFill>
+              <a:prstDash val="solid"/>
+              <a:round/>
+            </a:ln>
+          </c:spPr>
+        </c:majorGridlines>
+        <c:title>
+          <c:tx>
+            <c:rich>
+              <a:bodyPr/>
+              <a:lstStyle/>
+              <a:p>
+                <a:pPr>
+                  <a:defRPr sz="1000" b="0" i="0" u="none" strike="noStrike">
+                    <a:solidFill>
+                      <a:srgbClr val="5B6483"/>
+                    </a:solidFill>
+                    <a:latin typeface="Arial"/>
+                  </a:defRPr>
+                </a:pPr>
+                <a:r>
+                  <a:rPr sz="1000" b="0" i="0" u="none" strike="noStrike">
+                    <a:solidFill>
+                      <a:srgbClr val="5B6483"/>
+                    </a:solidFill>
+                    <a:latin typeface="Arial"/>
+                  </a:rPr>
+                  <a:t>Clearance rate (%)</a:t>
+                </a:r>
+              </a:p>
+            </c:rich>
+          </c:tx>
+          <c:layout/>
+          <c:overlay val="0"/>
+        </c:title>
+        <c:numFmt formatCode="General" sourceLinked="0"/>
+        <c:majorTickMark val="out"/>
+        <c:minorTickMark val="none"/>
+        <c:tickLblPos val="nextTo"/>
+        <c:spPr>
+          <a:ln w="12700" cap="flat">
+            <a:solidFill>
+              <a:srgbClr val="888888"/>
+            </a:solidFill>
+            <a:prstDash val="solid"/>
+            <a:round/>
+          </a:ln>
+        </c:spPr>
+        <c:txPr>
+          <a:bodyPr/>
+          <a:lstStyle/>
+          <a:p>
+            <a:pPr>
+              <a:defRPr sz="900" b="0" i="0" u="none" strike="noStrike">
+                <a:solidFill>
+                  <a:srgbClr val="5B6483"/>
+                </a:solidFill>
+                <a:latin typeface="Calibri"/>
+              </a:defRPr>
+            </a:pPr>
+            <a:endParaRPr lang="en-US"/>
+          </a:p>
+        </c:txPr>
+        <c:crossAx val="2094734554"/>
+        <c:crosses val="autoZero"/>
+        <c:crossBetween val="between"/>
+      </c:valAx>
+      <c:spPr>
+        <a:noFill/>
+        <a:ln>
+          <a:noFill/>
+        </a:ln>
+        <a:effectLst/>
+      </c:spPr>
+    </c:plotArea>
+    <c:legend>
+      <c:legendPos val="t"/>
+      <c:overlay val="0"/>
+      <c:txPr>
+        <a:bodyPr/>
+        <a:lstStyle/>
+        <a:p>
+          <a:pPr>
+            <a:defRPr sz="900">
+              <a:solidFill>
+                <a:srgbClr val="0F1A3D"/>
+              </a:solidFill>
+            </a:defRPr>
+          </a:pPr>
+          <a:endParaRPr lang="en-US"/>
+        </a:p>
+      </c:txPr>
+    </c:legend>
+    <c:plotVisOnly val="1"/>
+    <c:dispBlanksAs val="span"/>
+  </c:chart>
+  <c:spPr>
+    <a:noFill/>
+    <a:ln>
+      <a:noFill/>
+    </a:ln>
+    <a:effectLst/>
+  </c:spPr>
+  <c:externalData r:id="rId1">
+    <c:autoUpdate val="0"/>
+  </c:externalData>
+</c:chartSpace>
+</file>
+
+<file path=ppt/charts/chart4.xml><?xml version="1.0" encoding="utf-8"?>
 <c:chartSpace xmlns:c="http://schemas.openxmlformats.org/drawingml/2006/chart" xmlns:a="http://schemas.openxmlformats.org/drawingml/2006/main" xmlns:r="http://schemas.openxmlformats.org/officeDocument/2006/relationships">
   <c:date1904 val="0"/>
   <c:roundedCorners val="1"/>
@@ -2396,6 +3746,182 @@
             <a:fld id="{F7021451-1387-4CA6-816F-3879F97B5CBC}" type="slidenum">
               <a:rPr lang="en-US"/>
               <a:t>7</a:t>
+            </a:fld>
+            <a:endParaRPr lang="en-US"/>
+          </a:p>
+        </p:txBody>
+      </p:sp>
+    </p:spTree>
+    <p:extLst>
+      <p:ext uri="{BB962C8B-B14F-4D97-AF65-F5344CB8AC3E}">
+        <p14:creationId xmlns:p14="http://schemas.microsoft.com/office/powerpoint/2010/main" val="1024086991"/>
+      </p:ext>
+    </p:extLst>
+  </p:cSld>
+  <p:clrMapOvr>
+    <a:masterClrMapping/>
+  </p:clrMapOvr>
+</p:notes>
+</file>
+
+<file path=ppt/notesSlides/notesSlide8.xml><?xml version="1.0" encoding="utf-8"?>
+<p:notes xmlns:a="http://schemas.openxmlformats.org/drawingml/2006/main" xmlns:r="http://schemas.openxmlformats.org/officeDocument/2006/relationships" xmlns:p="http://schemas.openxmlformats.org/presentationml/2006/main">
+  <p:cSld>
+    <p:spTree>
+      <p:nvGrpSpPr>
+        <p:cNvPr id="1" name=""/>
+        <p:cNvGrpSpPr/>
+        <p:nvPr/>
+      </p:nvGrpSpPr>
+      <p:grpSpPr>
+        <a:xfrm>
+          <a:off x="0" y="0"/>
+          <a:ext cx="0" cy="0"/>
+          <a:chOff x="0" y="0"/>
+          <a:chExt cx="0" cy="0"/>
+        </a:xfrm>
+      </p:grpSpPr>
+      <p:sp>
+        <p:nvSpPr>
+          <p:cNvPr id="2" name="Slide Image Placeholder 1"/>
+          <p:cNvSpPr>
+            <a:spLocks noGrp="1" noRot="1" noChangeAspect="1"/>
+          </p:cNvSpPr>
+          <p:nvPr>
+            <p:ph type="sldImg"/>
+          </p:nvPr>
+        </p:nvSpPr>
+        <p:spPr/>
+      </p:sp>
+      <p:sp>
+        <p:nvSpPr>
+          <p:cNvPr id="3" name="Notes Placeholder 2"/>
+          <p:cNvSpPr>
+            <a:spLocks noGrp="1"/>
+          </p:cNvSpPr>
+          <p:nvPr>
+            <p:ph type="body" idx="1"/>
+          </p:nvPr>
+        </p:nvSpPr>
+        <p:spPr/>
+        <p:txBody>
+          <a:bodyPr/>
+          <a:lstStyle/>
+          <a:p>
+            <a:r>
+              <a:rPr lang="en-US" dirty="0"/>
+              <a:t/>
+            </a:r>
+            <a:endParaRPr lang="en-US" dirty="0"/>
+          </a:p>
+        </p:txBody>
+      </p:sp>
+      <p:sp>
+        <p:nvSpPr>
+          <p:cNvPr id="4" name="Slide Number Placeholder 3"/>
+          <p:cNvSpPr>
+            <a:spLocks noGrp="1"/>
+          </p:cNvSpPr>
+          <p:nvPr>
+            <p:ph type="sldNum" sz="quarter" idx="10"/>
+          </p:nvPr>
+        </p:nvSpPr>
+        <p:spPr/>
+        <p:txBody>
+          <a:bodyPr/>
+          <a:lstStyle/>
+          <a:p>
+            <a:fld id="{F7021451-1387-4CA6-816F-3879F97B5CBC}" type="slidenum">
+              <a:rPr lang="en-US"/>
+              <a:t>8</a:t>
+            </a:fld>
+            <a:endParaRPr lang="en-US"/>
+          </a:p>
+        </p:txBody>
+      </p:sp>
+    </p:spTree>
+    <p:extLst>
+      <p:ext uri="{BB962C8B-B14F-4D97-AF65-F5344CB8AC3E}">
+        <p14:creationId xmlns:p14="http://schemas.microsoft.com/office/powerpoint/2010/main" val="1024086991"/>
+      </p:ext>
+    </p:extLst>
+  </p:cSld>
+  <p:clrMapOvr>
+    <a:masterClrMapping/>
+  </p:clrMapOvr>
+</p:notes>
+</file>
+
+<file path=ppt/notesSlides/notesSlide9.xml><?xml version="1.0" encoding="utf-8"?>
+<p:notes xmlns:a="http://schemas.openxmlformats.org/drawingml/2006/main" xmlns:r="http://schemas.openxmlformats.org/officeDocument/2006/relationships" xmlns:p="http://schemas.openxmlformats.org/presentationml/2006/main">
+  <p:cSld>
+    <p:spTree>
+      <p:nvGrpSpPr>
+        <p:cNvPr id="1" name=""/>
+        <p:cNvGrpSpPr/>
+        <p:nvPr/>
+      </p:nvGrpSpPr>
+      <p:grpSpPr>
+        <a:xfrm>
+          <a:off x="0" y="0"/>
+          <a:ext cx="0" cy="0"/>
+          <a:chOff x="0" y="0"/>
+          <a:chExt cx="0" cy="0"/>
+        </a:xfrm>
+      </p:grpSpPr>
+      <p:sp>
+        <p:nvSpPr>
+          <p:cNvPr id="2" name="Slide Image Placeholder 1"/>
+          <p:cNvSpPr>
+            <a:spLocks noGrp="1" noRot="1" noChangeAspect="1"/>
+          </p:cNvSpPr>
+          <p:nvPr>
+            <p:ph type="sldImg"/>
+          </p:nvPr>
+        </p:nvSpPr>
+        <p:spPr/>
+      </p:sp>
+      <p:sp>
+        <p:nvSpPr>
+          <p:cNvPr id="3" name="Notes Placeholder 2"/>
+          <p:cNvSpPr>
+            <a:spLocks noGrp="1"/>
+          </p:cNvSpPr>
+          <p:nvPr>
+            <p:ph type="body" idx="1"/>
+          </p:nvPr>
+        </p:nvSpPr>
+        <p:spPr/>
+        <p:txBody>
+          <a:bodyPr/>
+          <a:lstStyle/>
+          <a:p>
+            <a:r>
+              <a:rPr lang="en-US" dirty="0"/>
+              <a:t/>
+            </a:r>
+            <a:endParaRPr lang="en-US" dirty="0"/>
+          </a:p>
+        </p:txBody>
+      </p:sp>
+      <p:sp>
+        <p:nvSpPr>
+          <p:cNvPr id="4" name="Slide Number Placeholder 3"/>
+          <p:cNvSpPr>
+            <a:spLocks noGrp="1"/>
+          </p:cNvSpPr>
+          <p:nvPr>
+            <p:ph type="sldNum" sz="quarter" idx="10"/>
+          </p:nvPr>
+        </p:nvSpPr>
+        <p:spPr/>
+        <p:txBody>
+          <a:bodyPr/>
+          <a:lstStyle/>
+          <a:p>
+            <a:fld id="{F7021451-1387-4CA6-816F-3879F97B5CBC}" type="slidenum">
+              <a:rPr lang="en-US"/>
+              <a:t>9</a:t>
             </a:fld>
             <a:endParaRPr lang="en-US"/>
           </a:p>
@@ -7062,7 +8588,7 @@
                 <a:ea typeface="Calibri" pitchFamily="34" charset="-122"/>
                 <a:cs typeface="Calibri" pitchFamily="34" charset="-120"/>
               </a:rPr>
-              <a:t>P U T   I T   I N   C O N T E X T</a:t>
+              <a:t>C Y B E R C R I M E</a:t>
             </a:r>
             <a:endParaRPr lang="en-US" sz="1100" dirty="0"/>
           </a:p>
@@ -7101,7 +8627,7 @@
                 <a:ea typeface="Cambria" pitchFamily="34" charset="-122"/>
                 <a:cs typeface="Cambria" pitchFamily="34" charset="-120"/>
               </a:rPr>
-              <a:t>A modest give-back after a decade of rising severity</a:t>
+              <a:t>Cybercrime plateaus — a second straight year off the peak</a:t>
             </a:r>
             <a:endParaRPr lang="en-US" sz="3200" dirty="0"/>
           </a:p>
@@ -7132,596 +8658,36 @@
           </a:ln>
         </p:spPr>
       </p:sp>
-      <p:sp>
-        <p:nvSpPr>
-          <p:cNvPr id="5" name="Shape 3"/>
-          <p:cNvSpPr/>
-          <p:nvPr/>
-        </p:nvSpPr>
-        <p:spPr>
-          <a:xfrm>
-            <a:off x="640080" y="2331720"/>
-            <a:ext cx="5272888" cy="1737360"/>
+      <p:graphicFrame>
+        <p:nvGraphicFramePr>
+          <p:cNvPr id="5" name="Chart 0" descr=""/>
+          <p:cNvGraphicFramePr/>
+          <p:nvPr/>
+        </p:nvGraphicFramePr>
+        <p:xfrm>
+          <a:off x="640080" y="1965960"/>
+          <a:ext cx="7589520" cy="4206240"/>
+        </p:xfrm>
+        <a:graphic xmlns:a="http://schemas.openxmlformats.org/drawingml/2006/main">
+          <a:graphicData uri="http://schemas.openxmlformats.org/drawingml/2006/chart">
+            <c:chart xmlns:c="http://schemas.openxmlformats.org/drawingml/2006/chart" r:id="rId1"/>
+          </a:graphicData>
+        </a:graphic>
+      </p:graphicFrame>
+      <p:sp>
+        <p:nvSpPr>
+          <p:cNvPr id="6" name="Shape 3"/>
+          <p:cNvSpPr/>
+          <p:nvPr/>
+        </p:nvSpPr>
+        <p:spPr>
+          <a:xfrm>
+            <a:off x="8503920" y="1965960"/>
+            <a:ext cx="3047695" cy="4206240"/>
           </a:xfrm>
           <a:prstGeom prst="roundRect">
             <a:avLst>
-              <a:gd name="adj" fmla="val 5263"/>
-            </a:avLst>
-          </a:prstGeom>
-          <a:solidFill>
-            <a:srgbClr val="EEF1F7"/>
-          </a:solidFill>
-          <a:ln w="12700">
-            <a:solidFill>
-              <a:srgbClr val="EEF1F7"/>
-            </a:solidFill>
-            <a:prstDash val="solid"/>
-          </a:ln>
-        </p:spPr>
-      </p:sp>
-      <p:sp>
-        <p:nvSpPr>
-          <p:cNvPr id="6" name="Text 4"/>
-          <p:cNvSpPr/>
-          <p:nvPr/>
-        </p:nvSpPr>
-        <p:spPr>
-          <a:xfrm>
-            <a:off x="960120" y="2514600"/>
-            <a:ext cx="4632808" cy="274320"/>
-          </a:xfrm>
-          <a:prstGeom prst="rect">
-            <a:avLst/>
-          </a:prstGeom>
-          <a:noFill/>
-          <a:ln/>
-        </p:spPr>
-        <p:txBody>
-          <a:bodyPr wrap="square" lIns="0" tIns="0" rIns="0" bIns="0" rtlCol="0" anchor="ctr"/>
-          <a:lstStyle/>
-          <a:p>
-            <a:pPr indent="0" marL="0">
-              <a:buNone/>
-            </a:pPr>
-            <a:r>
-              <a:rPr lang="en-US" sz="1000" b="1" spc="400" kern="0" dirty="0">
-                <a:solidFill>
-                  <a:srgbClr val="5B6483"/>
-                </a:solidFill>
-                <a:latin typeface="Calibri" pitchFamily="34" charset="0"/>
-                <a:ea typeface="Calibri" pitchFamily="34" charset="-122"/>
-                <a:cs typeface="Calibri" pitchFamily="34" charset="-120"/>
-              </a:rPr>
-              <a:t>WHERE CSI SITS NOW</a:t>
-            </a:r>
-            <a:endParaRPr lang="en-US" sz="1000" dirty="0"/>
-          </a:p>
-        </p:txBody>
-      </p:sp>
-      <p:sp>
-        <p:nvSpPr>
-          <p:cNvPr id="7" name="Text 5"/>
-          <p:cNvSpPr/>
-          <p:nvPr/>
-        </p:nvSpPr>
-        <p:spPr>
-          <a:xfrm>
-            <a:off x="960120" y="2834640"/>
-            <a:ext cx="4632808" cy="640080"/>
-          </a:xfrm>
-          <a:prstGeom prst="rect">
-            <a:avLst/>
-          </a:prstGeom>
-          <a:noFill/>
-          <a:ln/>
-        </p:spPr>
-        <p:txBody>
-          <a:bodyPr wrap="square" lIns="0" tIns="0" rIns="0" bIns="0" rtlCol="0" anchor="ctr"/>
-          <a:lstStyle/>
-          <a:p>
-            <a:pPr indent="0" marL="0">
-              <a:buNone/>
-            </a:pPr>
-            <a:r>
-              <a:rPr lang="en-US" sz="3000" b="1" dirty="0">
-                <a:solidFill>
-                  <a:srgbClr val="0F1A3D"/>
-                </a:solidFill>
-                <a:latin typeface="Cambria" pitchFamily="34" charset="0"/>
-                <a:ea typeface="Cambria" pitchFamily="34" charset="-122"/>
-                <a:cs typeface="Cambria" pitchFamily="34" charset="-120"/>
-              </a:rPr>
-              <a:t>75.0 / 66</a:t>
-            </a:r>
-            <a:endParaRPr lang="en-US" sz="3000" dirty="0"/>
-          </a:p>
-        </p:txBody>
-      </p:sp>
-      <p:sp>
-        <p:nvSpPr>
-          <p:cNvPr id="8" name="Text 6"/>
-          <p:cNvSpPr/>
-          <p:nvPr/>
-        </p:nvSpPr>
-        <p:spPr>
-          <a:xfrm>
-            <a:off x="960120" y="3429000"/>
-            <a:ext cx="4632808" cy="548640"/>
-          </a:xfrm>
-          <a:prstGeom prst="rect">
-            <a:avLst/>
-          </a:prstGeom>
-          <a:noFill/>
-          <a:ln/>
-        </p:spPr>
-        <p:txBody>
-          <a:bodyPr wrap="square" lIns="0" tIns="0" rIns="0" bIns="0" rtlCol="0" anchor="ctr"/>
-          <a:lstStyle/>
-          <a:p>
-            <a:pPr indent="0" marL="0">
-              <a:buNone/>
-            </a:pPr>
-            <a:r>
-              <a:rPr lang="en-US" sz="1100" dirty="0">
-                <a:solidFill>
-                  <a:srgbClr val="0F1A3D"/>
-                </a:solidFill>
-                <a:latin typeface="Calibri" pitchFamily="34" charset="0"/>
-                <a:ea typeface="Calibri" pitchFamily="34" charset="-122"/>
-                <a:cs typeface="Calibri" pitchFamily="34" charset="-120"/>
-              </a:rPr>
-              <a:t>2025 CSI of 75.0 vs. the 2014 low of roughly 66. Even after two years of decline, severity is still ~14% higher than a decade ago.</a:t>
-            </a:r>
-            <a:endParaRPr lang="en-US" sz="1100" dirty="0"/>
-          </a:p>
-        </p:txBody>
-      </p:sp>
-      <p:sp>
-        <p:nvSpPr>
-          <p:cNvPr id="9" name="Shape 7"/>
-          <p:cNvSpPr/>
-          <p:nvPr/>
-        </p:nvSpPr>
-        <p:spPr>
-          <a:xfrm>
-            <a:off x="6278728" y="2331720"/>
-            <a:ext cx="5272888" cy="1737360"/>
-          </a:xfrm>
-          <a:prstGeom prst="roundRect">
-            <a:avLst>
-              <a:gd name="adj" fmla="val 5263"/>
-            </a:avLst>
-          </a:prstGeom>
-          <a:solidFill>
-            <a:srgbClr val="EEF1F7"/>
-          </a:solidFill>
-          <a:ln w="12700">
-            <a:solidFill>
-              <a:srgbClr val="EEF1F7"/>
-            </a:solidFill>
-            <a:prstDash val="solid"/>
-          </a:ln>
-        </p:spPr>
-      </p:sp>
-      <p:sp>
-        <p:nvSpPr>
-          <p:cNvPr id="10" name="Text 8"/>
-          <p:cNvSpPr/>
-          <p:nvPr/>
-        </p:nvSpPr>
-        <p:spPr>
-          <a:xfrm>
-            <a:off x="6598768" y="2514600"/>
-            <a:ext cx="4632808" cy="274320"/>
-          </a:xfrm>
-          <a:prstGeom prst="rect">
-            <a:avLst/>
-          </a:prstGeom>
-          <a:noFill/>
-          <a:ln/>
-        </p:spPr>
-        <p:txBody>
-          <a:bodyPr wrap="square" lIns="0" tIns="0" rIns="0" bIns="0" rtlCol="0" anchor="ctr"/>
-          <a:lstStyle/>
-          <a:p>
-            <a:pPr indent="0" marL="0">
-              <a:buNone/>
-            </a:pPr>
-            <a:r>
-              <a:rPr lang="en-US" sz="1000" b="1" spc="400" kern="0" dirty="0">
-                <a:solidFill>
-                  <a:srgbClr val="5B6483"/>
-                </a:solidFill>
-                <a:latin typeface="Calibri" pitchFamily="34" charset="0"/>
-                <a:ea typeface="Calibri" pitchFamily="34" charset="-122"/>
-                <a:cs typeface="Calibri" pitchFamily="34" charset="-120"/>
-              </a:rPr>
-              <a:t>THE DECADE THAT CAME BEFORE</a:t>
-            </a:r>
-            <a:endParaRPr lang="en-US" sz="1000" dirty="0"/>
-          </a:p>
-        </p:txBody>
-      </p:sp>
-      <p:sp>
-        <p:nvSpPr>
-          <p:cNvPr id="11" name="Text 9"/>
-          <p:cNvSpPr/>
-          <p:nvPr/>
-        </p:nvSpPr>
-        <p:spPr>
-          <a:xfrm>
-            <a:off x="6598768" y="2834640"/>
-            <a:ext cx="4632808" cy="640080"/>
-          </a:xfrm>
-          <a:prstGeom prst="rect">
-            <a:avLst/>
-          </a:prstGeom>
-          <a:noFill/>
-          <a:ln/>
-        </p:spPr>
-        <p:txBody>
-          <a:bodyPr wrap="square" lIns="0" tIns="0" rIns="0" bIns="0" rtlCol="0" anchor="ctr"/>
-          <a:lstStyle/>
-          <a:p>
-            <a:pPr indent="0" marL="0">
-              <a:buNone/>
-            </a:pPr>
-            <a:r>
-              <a:rPr lang="en-US" sz="3000" b="1" dirty="0">
-                <a:solidFill>
-                  <a:srgbClr val="0F1A3D"/>
-                </a:solidFill>
-                <a:latin typeface="Cambria" pitchFamily="34" charset="0"/>
-                <a:ea typeface="Cambria" pitchFamily="34" charset="-122"/>
-                <a:cs typeface="Cambria" pitchFamily="34" charset="-120"/>
-              </a:rPr>
-              <a:t>+22% 2014→2024</a:t>
-            </a:r>
-            <a:endParaRPr lang="en-US" sz="3000" dirty="0"/>
-          </a:p>
-        </p:txBody>
-      </p:sp>
-      <p:sp>
-        <p:nvSpPr>
-          <p:cNvPr id="12" name="Text 10"/>
-          <p:cNvSpPr/>
-          <p:nvPr/>
-        </p:nvSpPr>
-        <p:spPr>
-          <a:xfrm>
-            <a:off x="6598768" y="3429000"/>
-            <a:ext cx="4632808" cy="548640"/>
-          </a:xfrm>
-          <a:prstGeom prst="rect">
-            <a:avLst/>
-          </a:prstGeom>
-          <a:noFill/>
-          <a:ln/>
-        </p:spPr>
-        <p:txBody>
-          <a:bodyPr wrap="square" lIns="0" tIns="0" rIns="0" bIns="0" rtlCol="0" anchor="ctr"/>
-          <a:lstStyle/>
-          <a:p>
-            <a:pPr indent="0" marL="0">
-              <a:buNone/>
-            </a:pPr>
-            <a:r>
-              <a:rPr lang="en-US" sz="1100" dirty="0">
-                <a:solidFill>
-                  <a:srgbClr val="0F1A3D"/>
-                </a:solidFill>
-                <a:latin typeface="Calibri" pitchFamily="34" charset="0"/>
-                <a:ea typeface="Calibri" pitchFamily="34" charset="-122"/>
-                <a:cs typeface="Calibri" pitchFamily="34" charset="-120"/>
-              </a:rPr>
-              <a:t>Violent CSI climbed almost every year from 2014 through 2024. 2025's dip walks back only a fraction of that run-up.</a:t>
-            </a:r>
-            <a:endParaRPr lang="en-US" sz="1100" dirty="0"/>
-          </a:p>
-        </p:txBody>
-      </p:sp>
-      <p:sp>
-        <p:nvSpPr>
-          <p:cNvPr id="13" name="Shape 11"/>
-          <p:cNvSpPr/>
-          <p:nvPr/>
-        </p:nvSpPr>
-        <p:spPr>
-          <a:xfrm>
-            <a:off x="640080" y="4343400"/>
-            <a:ext cx="5272888" cy="1737360"/>
-          </a:xfrm>
-          <a:prstGeom prst="roundRect">
-            <a:avLst>
-              <a:gd name="adj" fmla="val 5263"/>
-            </a:avLst>
-          </a:prstGeom>
-          <a:solidFill>
-            <a:srgbClr val="EEF1F7"/>
-          </a:solidFill>
-          <a:ln w="12700">
-            <a:solidFill>
-              <a:srgbClr val="EEF1F7"/>
-            </a:solidFill>
-            <a:prstDash val="solid"/>
-          </a:ln>
-        </p:spPr>
-      </p:sp>
-      <p:sp>
-        <p:nvSpPr>
-          <p:cNvPr id="14" name="Text 12"/>
-          <p:cNvSpPr/>
-          <p:nvPr/>
-        </p:nvSpPr>
-        <p:spPr>
-          <a:xfrm>
-            <a:off x="960120" y="4526280"/>
-            <a:ext cx="4632808" cy="274320"/>
-          </a:xfrm>
-          <a:prstGeom prst="rect">
-            <a:avLst/>
-          </a:prstGeom>
-          <a:noFill/>
-          <a:ln/>
-        </p:spPr>
-        <p:txBody>
-          <a:bodyPr wrap="square" lIns="0" tIns="0" rIns="0" bIns="0" rtlCol="0" anchor="ctr"/>
-          <a:lstStyle/>
-          <a:p>
-            <a:pPr indent="0" marL="0">
-              <a:buNone/>
-            </a:pPr>
-            <a:r>
-              <a:rPr lang="en-US" sz="1000" b="1" spc="400" kern="0" dirty="0">
-                <a:solidFill>
-                  <a:srgbClr val="5B6483"/>
-                </a:solidFill>
-                <a:latin typeface="Calibri" pitchFamily="34" charset="0"/>
-                <a:ea typeface="Calibri" pitchFamily="34" charset="-122"/>
-                <a:cs typeface="Calibri" pitchFamily="34" charset="-120"/>
-              </a:rPr>
-              <a:t>SIZE OF THE MOVE</a:t>
-            </a:r>
-            <a:endParaRPr lang="en-US" sz="1000" dirty="0"/>
-          </a:p>
-        </p:txBody>
-      </p:sp>
-      <p:sp>
-        <p:nvSpPr>
-          <p:cNvPr id="15" name="Text 13"/>
-          <p:cNvSpPr/>
-          <p:nvPr/>
-        </p:nvSpPr>
-        <p:spPr>
-          <a:xfrm>
-            <a:off x="960120" y="4846320"/>
-            <a:ext cx="4632808" cy="640080"/>
-          </a:xfrm>
-          <a:prstGeom prst="rect">
-            <a:avLst/>
-          </a:prstGeom>
-          <a:noFill/>
-          <a:ln/>
-        </p:spPr>
-        <p:txBody>
-          <a:bodyPr wrap="square" lIns="0" tIns="0" rIns="0" bIns="0" rtlCol="0" anchor="ctr"/>
-          <a:lstStyle/>
-          <a:p>
-            <a:pPr indent="0" marL="0">
-              <a:buNone/>
-            </a:pPr>
-            <a:r>
-              <a:rPr lang="en-US" sz="3000" b="1" dirty="0">
-                <a:solidFill>
-                  <a:srgbClr val="0F1A3D"/>
-                </a:solidFill>
-                <a:latin typeface="Cambria" pitchFamily="34" charset="0"/>
-                <a:ea typeface="Cambria" pitchFamily="34" charset="-122"/>
-                <a:cs typeface="Cambria" pitchFamily="34" charset="-120"/>
-              </a:rPr>
-              <a:t>−2.4%</a:t>
-            </a:r>
-            <a:endParaRPr lang="en-US" sz="3000" dirty="0"/>
-          </a:p>
-        </p:txBody>
-      </p:sp>
-      <p:sp>
-        <p:nvSpPr>
-          <p:cNvPr id="16" name="Text 14"/>
-          <p:cNvSpPr/>
-          <p:nvPr/>
-        </p:nvSpPr>
-        <p:spPr>
-          <a:xfrm>
-            <a:off x="960120" y="5440680"/>
-            <a:ext cx="4632808" cy="548640"/>
-          </a:xfrm>
-          <a:prstGeom prst="rect">
-            <a:avLst/>
-          </a:prstGeom>
-          <a:noFill/>
-          <a:ln/>
-        </p:spPr>
-        <p:txBody>
-          <a:bodyPr wrap="square" lIns="0" tIns="0" rIns="0" bIns="0" rtlCol="0" anchor="ctr"/>
-          <a:lstStyle/>
-          <a:p>
-            <a:pPr indent="0" marL="0">
-              <a:buNone/>
-            </a:pPr>
-            <a:r>
-              <a:rPr lang="en-US" sz="1100" dirty="0">
-                <a:solidFill>
-                  <a:srgbClr val="0F1A3D"/>
-                </a:solidFill>
-                <a:latin typeface="Calibri" pitchFamily="34" charset="0"/>
-                <a:ea typeface="Calibri" pitchFamily="34" charset="-122"/>
-                <a:cs typeface="Calibri" pitchFamily="34" charset="-120"/>
-              </a:rPr>
-              <a:t>Overall crime rate fell 2.4% and CSI fell 4.86% — a modest improvement next to the 20%+ increase in severity accumulated over the prior decade.</a:t>
-            </a:r>
-            <a:endParaRPr lang="en-US" sz="1100" dirty="0"/>
-          </a:p>
-        </p:txBody>
-      </p:sp>
-      <p:sp>
-        <p:nvSpPr>
-          <p:cNvPr id="17" name="Shape 15"/>
-          <p:cNvSpPr/>
-          <p:nvPr/>
-        </p:nvSpPr>
-        <p:spPr>
-          <a:xfrm>
-            <a:off x="6278728" y="4343400"/>
-            <a:ext cx="5272888" cy="1737360"/>
-          </a:xfrm>
-          <a:prstGeom prst="roundRect">
-            <a:avLst>
-              <a:gd name="adj" fmla="val 5263"/>
-            </a:avLst>
-          </a:prstGeom>
-          <a:solidFill>
-            <a:srgbClr val="EEF1F7"/>
-          </a:solidFill>
-          <a:ln w="12700">
-            <a:solidFill>
-              <a:srgbClr val="EEF1F7"/>
-            </a:solidFill>
-            <a:prstDash val="solid"/>
-          </a:ln>
-        </p:spPr>
-      </p:sp>
-      <p:sp>
-        <p:nvSpPr>
-          <p:cNvPr id="18" name="Text 16"/>
-          <p:cNvSpPr/>
-          <p:nvPr/>
-        </p:nvSpPr>
-        <p:spPr>
-          <a:xfrm>
-            <a:off x="6598768" y="4526280"/>
-            <a:ext cx="4632808" cy="274320"/>
-          </a:xfrm>
-          <a:prstGeom prst="rect">
-            <a:avLst/>
-          </a:prstGeom>
-          <a:noFill/>
-          <a:ln/>
-        </p:spPr>
-        <p:txBody>
-          <a:bodyPr wrap="square" lIns="0" tIns="0" rIns="0" bIns="0" rtlCol="0" anchor="ctr"/>
-          <a:lstStyle/>
-          <a:p>
-            <a:pPr indent="0" marL="0">
-              <a:buNone/>
-            </a:pPr>
-            <a:r>
-              <a:rPr lang="en-US" sz="1000" b="1" spc="400" kern="0" dirty="0">
-                <a:solidFill>
-                  <a:srgbClr val="5B6483"/>
-                </a:solidFill>
-                <a:latin typeface="Calibri" pitchFamily="34" charset="0"/>
-                <a:ea typeface="Calibri" pitchFamily="34" charset="-122"/>
-                <a:cs typeface="Calibri" pitchFamily="34" charset="-120"/>
-              </a:rPr>
-              <a:t>DIRECTION OF TRAVEL</a:t>
-            </a:r>
-            <a:endParaRPr lang="en-US" sz="1000" dirty="0"/>
-          </a:p>
-        </p:txBody>
-      </p:sp>
-      <p:sp>
-        <p:nvSpPr>
-          <p:cNvPr id="19" name="Text 17"/>
-          <p:cNvSpPr/>
-          <p:nvPr/>
-        </p:nvSpPr>
-        <p:spPr>
-          <a:xfrm>
-            <a:off x="6598768" y="4846320"/>
-            <a:ext cx="4632808" cy="640080"/>
-          </a:xfrm>
-          <a:prstGeom prst="rect">
-            <a:avLst/>
-          </a:prstGeom>
-          <a:noFill/>
-          <a:ln/>
-        </p:spPr>
-        <p:txBody>
-          <a:bodyPr wrap="square" lIns="0" tIns="0" rIns="0" bIns="0" rtlCol="0" anchor="ctr"/>
-          <a:lstStyle/>
-          <a:p>
-            <a:pPr indent="0" marL="0">
-              <a:buNone/>
-            </a:pPr>
-            <a:r>
-              <a:rPr lang="en-US" sz="3000" b="1" dirty="0">
-                <a:solidFill>
-                  <a:srgbClr val="0F1A3D"/>
-                </a:solidFill>
-                <a:latin typeface="Cambria" pitchFamily="34" charset="0"/>
-                <a:ea typeface="Cambria" pitchFamily="34" charset="-122"/>
-                <a:cs typeface="Cambria" pitchFamily="34" charset="-120"/>
-              </a:rPr>
-              <a:t>2 years down</a:t>
-            </a:r>
-            <a:endParaRPr lang="en-US" sz="3000" dirty="0"/>
-          </a:p>
-        </p:txBody>
-      </p:sp>
-      <p:sp>
-        <p:nvSpPr>
-          <p:cNvPr id="20" name="Text 18"/>
-          <p:cNvSpPr/>
-          <p:nvPr/>
-        </p:nvSpPr>
-        <p:spPr>
-          <a:xfrm>
-            <a:off x="6598768" y="5440680"/>
-            <a:ext cx="4632808" cy="548640"/>
-          </a:xfrm>
-          <a:prstGeom prst="rect">
-            <a:avLst/>
-          </a:prstGeom>
-          <a:noFill/>
-          <a:ln/>
-        </p:spPr>
-        <p:txBody>
-          <a:bodyPr wrap="square" lIns="0" tIns="0" rIns="0" bIns="0" rtlCol="0" anchor="ctr"/>
-          <a:lstStyle/>
-          <a:p>
-            <a:pPr indent="0" marL="0">
-              <a:buNone/>
-            </a:pPr>
-            <a:r>
-              <a:rPr lang="en-US" sz="1100" dirty="0">
-                <a:solidFill>
-                  <a:srgbClr val="0F1A3D"/>
-                </a:solidFill>
-                <a:latin typeface="Calibri" pitchFamily="34" charset="0"/>
-                <a:ea typeface="Calibri" pitchFamily="34" charset="-122"/>
-                <a:cs typeface="Calibri" pitchFamily="34" charset="-120"/>
-              </a:rPr>
-              <a:t>A second annual decline is real, not noise — but one more data point is needed before calling it a durable reversal.</a:t>
-            </a:r>
-            <a:endParaRPr lang="en-US" sz="1100" dirty="0"/>
-          </a:p>
-        </p:txBody>
-      </p:sp>
-      <p:sp>
-        <p:nvSpPr>
-          <p:cNvPr id="21" name="Shape 19"/>
-          <p:cNvSpPr/>
-          <p:nvPr/>
-        </p:nvSpPr>
-        <p:spPr>
-          <a:xfrm>
-            <a:off x="640080" y="6355080"/>
-            <a:ext cx="10911535" cy="822960"/>
-          </a:xfrm>
-          <a:prstGeom prst="roundRect">
-            <a:avLst>
-              <a:gd name="adj" fmla="val 13333"/>
+              <a:gd name="adj" fmla="val 4500"/>
             </a:avLst>
           </a:prstGeom>
           <a:solidFill>
@@ -7737,14 +8703,14 @@
       </p:sp>
       <p:sp>
         <p:nvSpPr>
-          <p:cNvPr id="22" name="Text 20"/>
-          <p:cNvSpPr/>
-          <p:nvPr/>
-        </p:nvSpPr>
-        <p:spPr>
-          <a:xfrm>
-            <a:off x="822960" y="6492240"/>
-            <a:ext cx="10545775" cy="640080"/>
+          <p:cNvPr id="7" name="Text 4"/>
+          <p:cNvSpPr/>
+          <p:nvPr/>
+        </p:nvSpPr>
+        <p:spPr>
+          <a:xfrm>
+            <a:off x="8778240" y="2194560"/>
+            <a:ext cx="2499055" cy="320040"/>
           </a:xfrm>
           <a:prstGeom prst="rect">
             <a:avLst/>
@@ -7760,44 +8726,69 @@
               <a:buNone/>
             </a:pPr>
             <a:r>
-              <a:rPr lang="en-US" sz="1300" b="1" dirty="0">
-                <a:solidFill>
-                  <a:srgbClr val="FFE38A"/>
+              <a:rPr lang="en-US" sz="1200" b="1" dirty="0">
+                <a:solidFill>
+                  <a:srgbClr val="FFFFFF"/>
                 </a:solidFill>
                 <a:latin typeface="Calibri" pitchFamily="34" charset="0"/>
                 <a:ea typeface="Calibri" pitchFamily="34" charset="-122"/>
                 <a:cs typeface="Calibri" pitchFamily="34" charset="-120"/>
               </a:rPr>
-              <a:t>Bottom line: </a:t>
-            </a:r>
+              <a:t>Main insight</a:t>
+            </a:r>
+            <a:endParaRPr lang="en-US" sz="1200" dirty="0"/>
+          </a:p>
+        </p:txBody>
+      </p:sp>
+      <p:sp>
+        <p:nvSpPr>
+          <p:cNvPr id="8" name="Text 5"/>
+          <p:cNvSpPr/>
+          <p:nvPr/>
+        </p:nvSpPr>
+        <p:spPr>
+          <a:xfrm>
+            <a:off x="8778240" y="2532888"/>
+            <a:ext cx="2499055" cy="640080"/>
+          </a:xfrm>
+          <a:prstGeom prst="rect">
+            <a:avLst/>
+          </a:prstGeom>
+          <a:noFill/>
+          <a:ln/>
+        </p:spPr>
+        <p:txBody>
+          <a:bodyPr wrap="square" lIns="0" tIns="0" rIns="0" bIns="0" rtlCol="0" anchor="ctr"/>
+          <a:lstStyle/>
+          <a:p>
             <a:pPr indent="0" marL="0">
               <a:buNone/>
             </a:pPr>
             <a:r>
-              <a:rPr lang="en-US" sz="1300" i="1" dirty="0">
-                <a:solidFill>
-                  <a:srgbClr val="FFFFFF"/>
+              <a:rPr lang="en-US" sz="1100" dirty="0">
+                <a:solidFill>
+                  <a:srgbClr val="DFE4F5"/>
                 </a:solidFill>
                 <a:latin typeface="Calibri" pitchFamily="34" charset="0"/>
                 <a:ea typeface="Calibri" pitchFamily="34" charset="-122"/>
                 <a:cs typeface="Calibri" pitchFamily="34" charset="-120"/>
               </a:rPr>
-              <a:t>the direction turned in 2025, but the magnitude is small and the gains are uneven. Communicate an improving trend — and keep resourcing on the serious offences that still moved up.</a:t>
-            </a:r>
-            <a:endParaRPr lang="en-US" sz="1300" dirty="0"/>
-          </a:p>
-        </p:txBody>
-      </p:sp>
-      <p:sp>
-        <p:nvSpPr>
-          <p:cNvPr id="23" name="Text 21"/>
-          <p:cNvSpPr/>
-          <p:nvPr/>
-        </p:nvSpPr>
-        <p:spPr>
-          <a:xfrm>
-            <a:off x="640080" y="6446520"/>
-            <a:ext cx="5486400" cy="274320"/>
+              <a:t>After 8 years of near-continuous growth, cybercrime has cooled — 2025 marks the second straight annual decline from the 2023 peak.</a:t>
+            </a:r>
+            <a:endParaRPr lang="en-US" sz="1100" dirty="0"/>
+          </a:p>
+        </p:txBody>
+      </p:sp>
+      <p:sp>
+        <p:nvSpPr>
+          <p:cNvPr id="9" name="Text 6"/>
+          <p:cNvSpPr/>
+          <p:nvPr/>
+        </p:nvSpPr>
+        <p:spPr>
+          <a:xfrm>
+            <a:off x="8778240" y="3474720"/>
+            <a:ext cx="2499055" cy="320040"/>
           </a:xfrm>
           <a:prstGeom prst="rect">
             <a:avLst/>
@@ -7813,15 +8804,171 @@
               <a:buNone/>
             </a:pPr>
             <a:r>
-              <a:rPr lang="en-US" sz="900" dirty="0">
-                <a:solidFill>
-                  <a:srgbClr val="7D859F"/>
+              <a:rPr lang="en-US" sz="1200" b="1" dirty="0">
+                <a:solidFill>
+                  <a:srgbClr val="FFFFFF"/>
                 </a:solidFill>
                 <a:latin typeface="Calibri" pitchFamily="34" charset="0"/>
                 <a:ea typeface="Calibri" pitchFamily="34" charset="-122"/>
                 <a:cs typeface="Calibri" pitchFamily="34" charset="-120"/>
               </a:rPr>
-              <a:t>Statistics Canada, Crime Severity Index, 2000–2025</a:t>
+              <a:t>But look at the scale</a:t>
+            </a:r>
+            <a:endParaRPr lang="en-US" sz="1200" dirty="0"/>
+          </a:p>
+        </p:txBody>
+      </p:sp>
+      <p:sp>
+        <p:nvSpPr>
+          <p:cNvPr id="10" name="Text 7"/>
+          <p:cNvSpPr/>
+          <p:nvPr/>
+        </p:nvSpPr>
+        <p:spPr>
+          <a:xfrm>
+            <a:off x="8778240" y="3813048"/>
+            <a:ext cx="2499055" cy="640080"/>
+          </a:xfrm>
+          <a:prstGeom prst="rect">
+            <a:avLst/>
+          </a:prstGeom>
+          <a:noFill/>
+          <a:ln/>
+        </p:spPr>
+        <p:txBody>
+          <a:bodyPr wrap="square" lIns="0" tIns="0" rIns="0" bIns="0" rtlCol="0" anchor="ctr"/>
+          <a:lstStyle/>
+          <a:p>
+            <a:pPr indent="0" marL="0">
+              <a:buNone/>
+            </a:pPr>
+            <a:r>
+              <a:rPr lang="en-US" sz="1100" dirty="0">
+                <a:solidFill>
+                  <a:srgbClr val="DFE4F5"/>
+                </a:solidFill>
+                <a:latin typeface="Calibri" pitchFamily="34" charset="0"/>
+                <a:ea typeface="Calibri" pitchFamily="34" charset="-122"/>
+                <a:cs typeface="Calibri" pitchFamily="34" charset="-120"/>
+              </a:rPr>
+              <a:t>90,643 violations in 2025 is still ~6× the 2014 baseline of 15,184. The plateau is high, not low.</a:t>
+            </a:r>
+            <a:endParaRPr lang="en-US" sz="1100" dirty="0"/>
+          </a:p>
+        </p:txBody>
+      </p:sp>
+      <p:sp>
+        <p:nvSpPr>
+          <p:cNvPr id="11" name="Text 8"/>
+          <p:cNvSpPr/>
+          <p:nvPr/>
+        </p:nvSpPr>
+        <p:spPr>
+          <a:xfrm>
+            <a:off x="8778240" y="4754880"/>
+            <a:ext cx="2499055" cy="320040"/>
+          </a:xfrm>
+          <a:prstGeom prst="rect">
+            <a:avLst/>
+          </a:prstGeom>
+          <a:noFill/>
+          <a:ln/>
+        </p:spPr>
+        <p:txBody>
+          <a:bodyPr wrap="square" lIns="0" tIns="0" rIns="0" bIns="0" rtlCol="0" anchor="ctr"/>
+          <a:lstStyle/>
+          <a:p>
+            <a:pPr indent="0" marL="0">
+              <a:buNone/>
+            </a:pPr>
+            <a:r>
+              <a:rPr lang="en-US" sz="1200" b="1" dirty="0">
+                <a:solidFill>
+                  <a:srgbClr val="FFFFFF"/>
+                </a:solidFill>
+                <a:latin typeface="Calibri" pitchFamily="34" charset="0"/>
+                <a:ea typeface="Calibri" pitchFamily="34" charset="-122"/>
+                <a:cs typeface="Calibri" pitchFamily="34" charset="-120"/>
+              </a:rPr>
+              <a:t>Fraud dominates</a:t>
+            </a:r>
+            <a:endParaRPr lang="en-US" sz="1200" dirty="0"/>
+          </a:p>
+        </p:txBody>
+      </p:sp>
+      <p:sp>
+        <p:nvSpPr>
+          <p:cNvPr id="12" name="Text 9"/>
+          <p:cNvSpPr/>
+          <p:nvPr/>
+        </p:nvSpPr>
+        <p:spPr>
+          <a:xfrm>
+            <a:off x="8778240" y="5093208"/>
+            <a:ext cx="2499055" cy="640080"/>
+          </a:xfrm>
+          <a:prstGeom prst="rect">
+            <a:avLst/>
+          </a:prstGeom>
+          <a:noFill/>
+          <a:ln/>
+        </p:spPr>
+        <p:txBody>
+          <a:bodyPr wrap="square" lIns="0" tIns="0" rIns="0" bIns="0" rtlCol="0" anchor="ctr"/>
+          <a:lstStyle/>
+          <a:p>
+            <a:pPr indent="0" marL="0">
+              <a:buNone/>
+            </a:pPr>
+            <a:r>
+              <a:rPr lang="en-US" sz="1100" dirty="0">
+                <a:solidFill>
+                  <a:srgbClr val="DFE4F5"/>
+                </a:solidFill>
+                <a:latin typeface="Calibri" pitchFamily="34" charset="0"/>
+                <a:ea typeface="Calibri" pitchFamily="34" charset="-122"/>
+                <a:cs typeface="Calibri" pitchFamily="34" charset="-120"/>
+              </a:rPr>
+              <a:t>Fraud alone accounts for 44,542 of 2025 cyber violations — nearly half the total.</a:t>
+            </a:r>
+            <a:endParaRPr lang="en-US" sz="1100" dirty="0"/>
+          </a:p>
+        </p:txBody>
+      </p:sp>
+      <p:sp>
+        <p:nvSpPr>
+          <p:cNvPr id="13" name="Text 10"/>
+          <p:cNvSpPr/>
+          <p:nvPr/>
+        </p:nvSpPr>
+        <p:spPr>
+          <a:xfrm>
+            <a:off x="640080" y="6446520"/>
+            <a:ext cx="5486400" cy="274320"/>
+          </a:xfrm>
+          <a:prstGeom prst="rect">
+            <a:avLst/>
+          </a:prstGeom>
+          <a:noFill/>
+          <a:ln/>
+        </p:spPr>
+        <p:txBody>
+          <a:bodyPr wrap="square" lIns="0" tIns="0" rIns="0" bIns="0" rtlCol="0" anchor="ctr"/>
+          <a:lstStyle/>
+          <a:p>
+            <a:pPr indent="0" marL="0">
+              <a:buNone/>
+            </a:pPr>
+            <a:r>
+              <a:rPr lang="en-US" sz="900" dirty="0">
+                <a:solidFill>
+                  <a:srgbClr val="7D859F"/>
+                </a:solidFill>
+                <a:latin typeface="Calibri" pitchFamily="34" charset="0"/>
+                <a:ea typeface="Calibri" pitchFamily="34" charset="-122"/>
+                <a:cs typeface="Calibri" pitchFamily="34" charset="-120"/>
+              </a:rPr>
+              <a:t>Canada, selected police services · StatCan Table 35-10-0001</a:t>
             </a:r>
             <a:endParaRPr lang="en-US" sz="900" dirty="0"/>
           </a:p>
@@ -7829,7 +8976,7 @@
       </p:sp>
       <p:sp>
         <p:nvSpPr>
-          <p:cNvPr id="24" name="Text 22"/>
+          <p:cNvPr id="14" name="Text 11"/>
           <p:cNvSpPr/>
           <p:nvPr/>
         </p:nvSpPr>
@@ -7877,6 +9024,1365 @@
 <file path=ppt/slides/slide7.xml><?xml version="1.0" encoding="utf-8"?>
 <p:sld xmlns:a="http://schemas.openxmlformats.org/drawingml/2006/main" xmlns:r="http://schemas.openxmlformats.org/officeDocument/2006/relationships" xmlns:p="http://schemas.openxmlformats.org/presentationml/2006/main">
   <p:cSld name="Slide 7">
+    <p:bg>
+      <p:bgPr>
+        <a:solidFill>
+          <a:srgbClr val="FFFFFF"/>
+        </a:solidFill>
+      </p:bgPr>
+    </p:bg>
+    <p:spTree>
+      <p:nvGrpSpPr>
+        <p:cNvPr id="1" name=""/>
+        <p:cNvGrpSpPr/>
+        <p:nvPr/>
+      </p:nvGrpSpPr>
+      <p:grpSpPr>
+        <a:xfrm>
+          <a:off x="0" y="0"/>
+          <a:ext cx="0" cy="0"/>
+          <a:chOff x="0" y="0"/>
+          <a:chExt cx="0" cy="0"/>
+        </a:xfrm>
+      </p:grpSpPr>
+      <p:sp>
+        <p:nvSpPr>
+          <p:cNvPr id="2" name="Text 0"/>
+          <p:cNvSpPr/>
+          <p:nvPr/>
+        </p:nvSpPr>
+        <p:spPr>
+          <a:xfrm>
+            <a:off x="640080" y="502920"/>
+            <a:ext cx="9144000" cy="320040"/>
+          </a:xfrm>
+          <a:prstGeom prst="rect">
+            <a:avLst/>
+          </a:prstGeom>
+          <a:noFill/>
+          <a:ln/>
+        </p:spPr>
+        <p:txBody>
+          <a:bodyPr wrap="square" lIns="0" tIns="0" rIns="0" bIns="0" rtlCol="0" anchor="ctr"/>
+          <a:lstStyle/>
+          <a:p>
+            <a:pPr indent="0" marL="0">
+              <a:buNone/>
+            </a:pPr>
+            <a:r>
+              <a:rPr lang="en-US" sz="1100" b="1" spc="600" kern="0" dirty="0">
+                <a:solidFill>
+                  <a:srgbClr val="1B2A5E"/>
+                </a:solidFill>
+                <a:latin typeface="Calibri" pitchFamily="34" charset="0"/>
+                <a:ea typeface="Calibri" pitchFamily="34" charset="-122"/>
+                <a:cs typeface="Calibri" pitchFamily="34" charset="-120"/>
+              </a:rPr>
+              <a:t>P O L I C E   C L E A R A N C E</a:t>
+            </a:r>
+            <a:endParaRPr lang="en-US" sz="1100" dirty="0"/>
+          </a:p>
+        </p:txBody>
+      </p:sp>
+      <p:sp>
+        <p:nvSpPr>
+          <p:cNvPr id="3" name="Text 1"/>
+          <p:cNvSpPr/>
+          <p:nvPr/>
+        </p:nvSpPr>
+        <p:spPr>
+          <a:xfrm>
+            <a:off x="640080" y="868680"/>
+            <a:ext cx="10972800" cy="822960"/>
+          </a:xfrm>
+          <a:prstGeom prst="rect">
+            <a:avLst/>
+          </a:prstGeom>
+          <a:noFill/>
+          <a:ln/>
+        </p:spPr>
+        <p:txBody>
+          <a:bodyPr wrap="square" lIns="0" tIns="0" rIns="0" bIns="0" rtlCol="0" anchor="ctr"/>
+          <a:lstStyle/>
+          <a:p>
+            <a:pPr indent="0" marL="0">
+              <a:buNone/>
+            </a:pPr>
+            <a:r>
+              <a:rPr lang="en-US" sz="3200" b="1" dirty="0">
+                <a:solidFill>
+                  <a:srgbClr val="0F1A3D"/>
+                </a:solidFill>
+                <a:latin typeface="Cambria" pitchFamily="34" charset="0"/>
+                <a:ea typeface="Cambria" pitchFamily="34" charset="-122"/>
+                <a:cs typeface="Cambria" pitchFamily="34" charset="-120"/>
+              </a:rPr>
+              <a:t>Clearance rate ticks up — first real gain in a decade</a:t>
+            </a:r>
+            <a:endParaRPr lang="en-US" sz="3200" dirty="0"/>
+          </a:p>
+        </p:txBody>
+      </p:sp>
+      <p:sp>
+        <p:nvSpPr>
+          <p:cNvPr id="4" name="Shape 2"/>
+          <p:cNvSpPr/>
+          <p:nvPr/>
+        </p:nvSpPr>
+        <p:spPr>
+          <a:xfrm>
+            <a:off x="640080" y="1737360"/>
+            <a:ext cx="502920" cy="45720"/>
+          </a:xfrm>
+          <a:prstGeom prst="rect">
+            <a:avLst/>
+          </a:prstGeom>
+          <a:solidFill>
+            <a:srgbClr val="1B2A5E"/>
+          </a:solidFill>
+          <a:ln w="12700">
+            <a:solidFill>
+              <a:srgbClr val="1B2A5E"/>
+            </a:solidFill>
+            <a:prstDash val="solid"/>
+          </a:ln>
+        </p:spPr>
+      </p:sp>
+      <p:graphicFrame>
+        <p:nvGraphicFramePr>
+          <p:cNvPr id="5" name="Chart 0" descr=""/>
+          <p:cNvGraphicFramePr/>
+          <p:nvPr/>
+        </p:nvGraphicFramePr>
+        <p:xfrm>
+          <a:off x="640080" y="1965960"/>
+          <a:ext cx="7589520" cy="4206240"/>
+        </p:xfrm>
+        <a:graphic xmlns:a="http://schemas.openxmlformats.org/drawingml/2006/main">
+          <a:graphicData uri="http://schemas.openxmlformats.org/drawingml/2006/chart">
+            <c:chart xmlns:c="http://schemas.openxmlformats.org/drawingml/2006/chart" r:id="rId1"/>
+          </a:graphicData>
+        </a:graphic>
+      </p:graphicFrame>
+      <p:sp>
+        <p:nvSpPr>
+          <p:cNvPr id="6" name="Shape 3"/>
+          <p:cNvSpPr/>
+          <p:nvPr/>
+        </p:nvSpPr>
+        <p:spPr>
+          <a:xfrm>
+            <a:off x="8503920" y="1965960"/>
+            <a:ext cx="3047695" cy="4206240"/>
+          </a:xfrm>
+          <a:prstGeom prst="roundRect">
+            <a:avLst>
+              <a:gd name="adj" fmla="val 4500"/>
+            </a:avLst>
+          </a:prstGeom>
+          <a:solidFill>
+            <a:srgbClr val="1B2A5E"/>
+          </a:solidFill>
+          <a:ln w="12700">
+            <a:solidFill>
+              <a:srgbClr val="1B2A5E"/>
+            </a:solidFill>
+            <a:prstDash val="solid"/>
+          </a:ln>
+        </p:spPr>
+      </p:sp>
+      <p:sp>
+        <p:nvSpPr>
+          <p:cNvPr id="7" name="Text 4"/>
+          <p:cNvSpPr/>
+          <p:nvPr/>
+        </p:nvSpPr>
+        <p:spPr>
+          <a:xfrm>
+            <a:off x="8778240" y="2194560"/>
+            <a:ext cx="2499055" cy="320040"/>
+          </a:xfrm>
+          <a:prstGeom prst="rect">
+            <a:avLst/>
+          </a:prstGeom>
+          <a:noFill/>
+          <a:ln/>
+        </p:spPr>
+        <p:txBody>
+          <a:bodyPr wrap="square" lIns="0" tIns="0" rIns="0" bIns="0" rtlCol="0" anchor="ctr"/>
+          <a:lstStyle/>
+          <a:p>
+            <a:pPr indent="0" marL="0">
+              <a:buNone/>
+            </a:pPr>
+            <a:r>
+              <a:rPr lang="en-US" sz="1200" b="1" dirty="0">
+                <a:solidFill>
+                  <a:srgbClr val="FFFFFF"/>
+                </a:solidFill>
+                <a:latin typeface="Calibri" pitchFamily="34" charset="0"/>
+                <a:ea typeface="Calibri" pitchFamily="34" charset="-122"/>
+                <a:cs typeface="Calibri" pitchFamily="34" charset="-120"/>
+              </a:rPr>
+              <a:t>Main insight</a:t>
+            </a:r>
+            <a:endParaRPr lang="en-US" sz="1200" dirty="0"/>
+          </a:p>
+        </p:txBody>
+      </p:sp>
+      <p:sp>
+        <p:nvSpPr>
+          <p:cNvPr id="8" name="Text 5"/>
+          <p:cNvSpPr/>
+          <p:nvPr/>
+        </p:nvSpPr>
+        <p:spPr>
+          <a:xfrm>
+            <a:off x="8778240" y="2532888"/>
+            <a:ext cx="2499055" cy="640080"/>
+          </a:xfrm>
+          <a:prstGeom prst="rect">
+            <a:avLst/>
+          </a:prstGeom>
+          <a:noFill/>
+          <a:ln/>
+        </p:spPr>
+        <p:txBody>
+          <a:bodyPr wrap="square" lIns="0" tIns="0" rIns="0" bIns="0" rtlCol="0" anchor="ctr"/>
+          <a:lstStyle/>
+          <a:p>
+            <a:pPr indent="0" marL="0">
+              <a:buNone/>
+            </a:pPr>
+            <a:r>
+              <a:rPr lang="en-US" sz="1100" dirty="0">
+                <a:solidFill>
+                  <a:srgbClr val="DFE4F5"/>
+                </a:solidFill>
+                <a:latin typeface="Calibri" pitchFamily="34" charset="0"/>
+                <a:ea typeface="Calibri" pitchFamily="34" charset="-122"/>
+                <a:cs typeface="Calibri" pitchFamily="34" charset="-120"/>
+              </a:rPr>
+              <a:t>36.64% of cases cleared in 2025 — up +2.35% from 2024. Reverses a decade-long slide, but still below the 2008 peak.</a:t>
+            </a:r>
+            <a:endParaRPr lang="en-US" sz="1100" dirty="0"/>
+          </a:p>
+        </p:txBody>
+      </p:sp>
+      <p:sp>
+        <p:nvSpPr>
+          <p:cNvPr id="9" name="Text 6"/>
+          <p:cNvSpPr/>
+          <p:nvPr/>
+        </p:nvSpPr>
+        <p:spPr>
+          <a:xfrm>
+            <a:off x="8778240" y="3474720"/>
+            <a:ext cx="2499055" cy="320040"/>
+          </a:xfrm>
+          <a:prstGeom prst="rect">
+            <a:avLst/>
+          </a:prstGeom>
+          <a:noFill/>
+          <a:ln/>
+        </p:spPr>
+        <p:txBody>
+          <a:bodyPr wrap="square" lIns="0" tIns="0" rIns="0" bIns="0" rtlCol="0" anchor="ctr"/>
+          <a:lstStyle/>
+          <a:p>
+            <a:pPr indent="0" marL="0">
+              <a:buNone/>
+            </a:pPr>
+            <a:r>
+              <a:rPr lang="en-US" sz="1200" b="1" dirty="0">
+                <a:solidFill>
+                  <a:srgbClr val="FFFFFF"/>
+                </a:solidFill>
+                <a:latin typeface="Calibri" pitchFamily="34" charset="0"/>
+                <a:ea typeface="Calibri" pitchFamily="34" charset="-122"/>
+                <a:cs typeface="Calibri" pitchFamily="34" charset="-120"/>
+              </a:rPr>
+              <a:t>Serious cases fare best</a:t>
+            </a:r>
+            <a:endParaRPr lang="en-US" sz="1200" dirty="0"/>
+          </a:p>
+        </p:txBody>
+      </p:sp>
+      <p:sp>
+        <p:nvSpPr>
+          <p:cNvPr id="10" name="Text 7"/>
+          <p:cNvSpPr/>
+          <p:nvPr/>
+        </p:nvSpPr>
+        <p:spPr>
+          <a:xfrm>
+            <a:off x="8778240" y="3813048"/>
+            <a:ext cx="2499055" cy="640080"/>
+          </a:xfrm>
+          <a:prstGeom prst="rect">
+            <a:avLst/>
+          </a:prstGeom>
+          <a:noFill/>
+          <a:ln/>
+        </p:spPr>
+        <p:txBody>
+          <a:bodyPr wrap="square" lIns="0" tIns="0" rIns="0" bIns="0" rtlCol="0" anchor="ctr"/>
+          <a:lstStyle/>
+          <a:p>
+            <a:pPr indent="0" marL="0">
+              <a:buNone/>
+            </a:pPr>
+            <a:r>
+              <a:rPr lang="en-US" sz="1100" dirty="0">
+                <a:solidFill>
+                  <a:srgbClr val="DFE4F5"/>
+                </a:solidFill>
+                <a:latin typeface="Calibri" pitchFamily="34" charset="0"/>
+                <a:ea typeface="Calibri" pitchFamily="34" charset="-122"/>
+                <a:cs typeface="Calibri" pitchFamily="34" charset="-120"/>
+              </a:rPr>
+              <a:t>Violent clearance sits at 54.46% (roughly half solved); non-violent at just 26.28% (roughly three-quarters unsolved).</a:t>
+            </a:r>
+            <a:endParaRPr lang="en-US" sz="1100" dirty="0"/>
+          </a:p>
+        </p:txBody>
+      </p:sp>
+      <p:sp>
+        <p:nvSpPr>
+          <p:cNvPr id="11" name="Text 8"/>
+          <p:cNvSpPr/>
+          <p:nvPr/>
+        </p:nvSpPr>
+        <p:spPr>
+          <a:xfrm>
+            <a:off x="8778240" y="4754880"/>
+            <a:ext cx="2499055" cy="320040"/>
+          </a:xfrm>
+          <a:prstGeom prst="rect">
+            <a:avLst/>
+          </a:prstGeom>
+          <a:noFill/>
+          <a:ln/>
+        </p:spPr>
+        <p:txBody>
+          <a:bodyPr wrap="square" lIns="0" tIns="0" rIns="0" bIns="0" rtlCol="0" anchor="ctr"/>
+          <a:lstStyle/>
+          <a:p>
+            <a:pPr indent="0" marL="0">
+              <a:buNone/>
+            </a:pPr>
+            <a:r>
+              <a:rPr lang="en-US" sz="1200" b="1" dirty="0">
+                <a:solidFill>
+                  <a:srgbClr val="FFFFFF"/>
+                </a:solidFill>
+                <a:latin typeface="Calibri" pitchFamily="34" charset="0"/>
+                <a:ea typeface="Calibri" pitchFamily="34" charset="-122"/>
+                <a:cs typeface="Calibri" pitchFamily="34" charset="-120"/>
+              </a:rPr>
+              <a:t>A start, not a fix</a:t>
+            </a:r>
+            <a:endParaRPr lang="en-US" sz="1200" dirty="0"/>
+          </a:p>
+        </p:txBody>
+      </p:sp>
+      <p:sp>
+        <p:nvSpPr>
+          <p:cNvPr id="12" name="Text 9"/>
+          <p:cNvSpPr/>
+          <p:nvPr/>
+        </p:nvSpPr>
+        <p:spPr>
+          <a:xfrm>
+            <a:off x="8778240" y="5093208"/>
+            <a:ext cx="2499055" cy="640080"/>
+          </a:xfrm>
+          <a:prstGeom prst="rect">
+            <a:avLst/>
+          </a:prstGeom>
+          <a:noFill/>
+          <a:ln/>
+        </p:spPr>
+        <p:txBody>
+          <a:bodyPr wrap="square" lIns="0" tIns="0" rIns="0" bIns="0" rtlCol="0" anchor="ctr"/>
+          <a:lstStyle/>
+          <a:p>
+            <a:pPr indent="0" marL="0">
+              <a:buNone/>
+            </a:pPr>
+            <a:r>
+              <a:rPr lang="en-US" sz="1100" dirty="0">
+                <a:solidFill>
+                  <a:srgbClr val="DFE4F5"/>
+                </a:solidFill>
+                <a:latin typeface="Calibri" pitchFamily="34" charset="0"/>
+                <a:ea typeface="Calibri" pitchFamily="34" charset="-122"/>
+                <a:cs typeface="Calibri" pitchFamily="34" charset="-120"/>
+              </a:rPr>
+              <a:t>One year does not undo a decade. Track whether clearance holds above 36% in 2026 before calling it a durable turn.</a:t>
+            </a:r>
+            <a:endParaRPr lang="en-US" sz="1100" dirty="0"/>
+          </a:p>
+        </p:txBody>
+      </p:sp>
+      <p:sp>
+        <p:nvSpPr>
+          <p:cNvPr id="13" name="Text 10"/>
+          <p:cNvSpPr/>
+          <p:nvPr/>
+        </p:nvSpPr>
+        <p:spPr>
+          <a:xfrm>
+            <a:off x="640080" y="6446520"/>
+            <a:ext cx="5486400" cy="274320"/>
+          </a:xfrm>
+          <a:prstGeom prst="rect">
+            <a:avLst/>
+          </a:prstGeom>
+          <a:noFill/>
+          <a:ln/>
+        </p:spPr>
+        <p:txBody>
+          <a:bodyPr wrap="square" lIns="0" tIns="0" rIns="0" bIns="0" rtlCol="0" anchor="ctr"/>
+          <a:lstStyle/>
+          <a:p>
+            <a:pPr indent="0" marL="0">
+              <a:buNone/>
+            </a:pPr>
+            <a:r>
+              <a:rPr lang="en-US" sz="900" dirty="0">
+                <a:solidFill>
+                  <a:srgbClr val="7D859F"/>
+                </a:solidFill>
+                <a:latin typeface="Calibri" pitchFamily="34" charset="0"/>
+                <a:ea typeface="Calibri" pitchFamily="34" charset="-122"/>
+                <a:cs typeface="Calibri" pitchFamily="34" charset="-120"/>
+              </a:rPr>
+              <a:t>Weighted clearance rate, Canada · StatCan Table 35-10-0026</a:t>
+            </a:r>
+            <a:endParaRPr lang="en-US" sz="900" dirty="0"/>
+          </a:p>
+        </p:txBody>
+      </p:sp>
+      <p:sp>
+        <p:nvSpPr>
+          <p:cNvPr id="14" name="Text 11"/>
+          <p:cNvSpPr/>
+          <p:nvPr/>
+        </p:nvSpPr>
+        <p:spPr>
+          <a:xfrm>
+            <a:off x="6065215" y="6446520"/>
+            <a:ext cx="5486400" cy="274320"/>
+          </a:xfrm>
+          <a:prstGeom prst="rect">
+            <a:avLst/>
+          </a:prstGeom>
+          <a:noFill/>
+          <a:ln/>
+        </p:spPr>
+        <p:txBody>
+          <a:bodyPr wrap="square" lIns="0" tIns="0" rIns="0" bIns="0" rtlCol="0" anchor="ctr"/>
+          <a:lstStyle/>
+          <a:p>
+            <a:pPr algn="r" indent="0" marL="0">
+              <a:buNone/>
+            </a:pPr>
+            <a:r>
+              <a:rPr lang="en-US" sz="900" dirty="0">
+                <a:solidFill>
+                  <a:srgbClr val="7D859F"/>
+                </a:solidFill>
+                <a:latin typeface="Calibri" pitchFamily="34" charset="0"/>
+                <a:ea typeface="Calibri" pitchFamily="34" charset="-122"/>
+                <a:cs typeface="Calibri" pitchFamily="34" charset="-120"/>
+              </a:rPr>
+              <a:t>Statistics Canada · July 2026 release</a:t>
+            </a:r>
+            <a:endParaRPr lang="en-US" sz="900" dirty="0"/>
+          </a:p>
+        </p:txBody>
+      </p:sp>
+    </p:spTree>
+  </p:cSld>
+  <p:clrMapOvr>
+    <a:masterClrMapping/>
+  </p:clrMapOvr>
+</p:sld>
+</file>
+
+<file path=ppt/slides/slide8.xml><?xml version="1.0" encoding="utf-8"?>
+<p:sld xmlns:a="http://schemas.openxmlformats.org/drawingml/2006/main" xmlns:r="http://schemas.openxmlformats.org/officeDocument/2006/relationships" xmlns:p="http://schemas.openxmlformats.org/presentationml/2006/main">
+  <p:cSld name="Slide 8">
+    <p:bg>
+      <p:bgPr>
+        <a:solidFill>
+          <a:srgbClr val="FFFFFF"/>
+        </a:solidFill>
+      </p:bgPr>
+    </p:bg>
+    <p:spTree>
+      <p:nvGrpSpPr>
+        <p:cNvPr id="1" name=""/>
+        <p:cNvGrpSpPr/>
+        <p:nvPr/>
+      </p:nvGrpSpPr>
+      <p:grpSpPr>
+        <a:xfrm>
+          <a:off x="0" y="0"/>
+          <a:ext cx="0" cy="0"/>
+          <a:chOff x="0" y="0"/>
+          <a:chExt cx="0" cy="0"/>
+        </a:xfrm>
+      </p:grpSpPr>
+      <p:sp>
+        <p:nvSpPr>
+          <p:cNvPr id="2" name="Text 0"/>
+          <p:cNvSpPr/>
+          <p:nvPr/>
+        </p:nvSpPr>
+        <p:spPr>
+          <a:xfrm>
+            <a:off x="640080" y="502920"/>
+            <a:ext cx="9144000" cy="320040"/>
+          </a:xfrm>
+          <a:prstGeom prst="rect">
+            <a:avLst/>
+          </a:prstGeom>
+          <a:noFill/>
+          <a:ln/>
+        </p:spPr>
+        <p:txBody>
+          <a:bodyPr wrap="square" lIns="0" tIns="0" rIns="0" bIns="0" rtlCol="0" anchor="ctr"/>
+          <a:lstStyle/>
+          <a:p>
+            <a:pPr indent="0" marL="0">
+              <a:buNone/>
+            </a:pPr>
+            <a:r>
+              <a:rPr lang="en-US" sz="1100" b="1" spc="600" kern="0" dirty="0">
+                <a:solidFill>
+                  <a:srgbClr val="1B2A5E"/>
+                </a:solidFill>
+                <a:latin typeface="Calibri" pitchFamily="34" charset="0"/>
+                <a:ea typeface="Calibri" pitchFamily="34" charset="-122"/>
+                <a:cs typeface="Calibri" pitchFamily="34" charset="-120"/>
+              </a:rPr>
+              <a:t>P U T   I T   I N   C O N T E X T</a:t>
+            </a:r>
+            <a:endParaRPr lang="en-US" sz="1100" dirty="0"/>
+          </a:p>
+        </p:txBody>
+      </p:sp>
+      <p:sp>
+        <p:nvSpPr>
+          <p:cNvPr id="3" name="Text 1"/>
+          <p:cNvSpPr/>
+          <p:nvPr/>
+        </p:nvSpPr>
+        <p:spPr>
+          <a:xfrm>
+            <a:off x="640080" y="868680"/>
+            <a:ext cx="10972800" cy="822960"/>
+          </a:xfrm>
+          <a:prstGeom prst="rect">
+            <a:avLst/>
+          </a:prstGeom>
+          <a:noFill/>
+          <a:ln/>
+        </p:spPr>
+        <p:txBody>
+          <a:bodyPr wrap="square" lIns="0" tIns="0" rIns="0" bIns="0" rtlCol="0" anchor="ctr"/>
+          <a:lstStyle/>
+          <a:p>
+            <a:pPr indent="0" marL="0">
+              <a:buNone/>
+            </a:pPr>
+            <a:r>
+              <a:rPr lang="en-US" sz="3200" b="1" dirty="0">
+                <a:solidFill>
+                  <a:srgbClr val="0F1A3D"/>
+                </a:solidFill>
+                <a:latin typeface="Cambria" pitchFamily="34" charset="0"/>
+                <a:ea typeface="Cambria" pitchFamily="34" charset="-122"/>
+                <a:cs typeface="Cambria" pitchFamily="34" charset="-120"/>
+              </a:rPr>
+              <a:t>A modest give-back after a decade of rising severity</a:t>
+            </a:r>
+            <a:endParaRPr lang="en-US" sz="3200" dirty="0"/>
+          </a:p>
+        </p:txBody>
+      </p:sp>
+      <p:sp>
+        <p:nvSpPr>
+          <p:cNvPr id="4" name="Shape 2"/>
+          <p:cNvSpPr/>
+          <p:nvPr/>
+        </p:nvSpPr>
+        <p:spPr>
+          <a:xfrm>
+            <a:off x="640080" y="1737360"/>
+            <a:ext cx="502920" cy="45720"/>
+          </a:xfrm>
+          <a:prstGeom prst="rect">
+            <a:avLst/>
+          </a:prstGeom>
+          <a:solidFill>
+            <a:srgbClr val="1B2A5E"/>
+          </a:solidFill>
+          <a:ln w="12700">
+            <a:solidFill>
+              <a:srgbClr val="1B2A5E"/>
+            </a:solidFill>
+            <a:prstDash val="solid"/>
+          </a:ln>
+        </p:spPr>
+      </p:sp>
+      <p:sp>
+        <p:nvSpPr>
+          <p:cNvPr id="5" name="Shape 3"/>
+          <p:cNvSpPr/>
+          <p:nvPr/>
+        </p:nvSpPr>
+        <p:spPr>
+          <a:xfrm>
+            <a:off x="640080" y="2331720"/>
+            <a:ext cx="5272888" cy="1737360"/>
+          </a:xfrm>
+          <a:prstGeom prst="roundRect">
+            <a:avLst>
+              <a:gd name="adj" fmla="val 5263"/>
+            </a:avLst>
+          </a:prstGeom>
+          <a:solidFill>
+            <a:srgbClr val="EEF1F7"/>
+          </a:solidFill>
+          <a:ln w="12700">
+            <a:solidFill>
+              <a:srgbClr val="EEF1F7"/>
+            </a:solidFill>
+            <a:prstDash val="solid"/>
+          </a:ln>
+        </p:spPr>
+      </p:sp>
+      <p:sp>
+        <p:nvSpPr>
+          <p:cNvPr id="6" name="Text 4"/>
+          <p:cNvSpPr/>
+          <p:nvPr/>
+        </p:nvSpPr>
+        <p:spPr>
+          <a:xfrm>
+            <a:off x="960120" y="2514600"/>
+            <a:ext cx="4632808" cy="274320"/>
+          </a:xfrm>
+          <a:prstGeom prst="rect">
+            <a:avLst/>
+          </a:prstGeom>
+          <a:noFill/>
+          <a:ln/>
+        </p:spPr>
+        <p:txBody>
+          <a:bodyPr wrap="square" lIns="0" tIns="0" rIns="0" bIns="0" rtlCol="0" anchor="ctr"/>
+          <a:lstStyle/>
+          <a:p>
+            <a:pPr indent="0" marL="0">
+              <a:buNone/>
+            </a:pPr>
+            <a:r>
+              <a:rPr lang="en-US" sz="1000" b="1" spc="400" kern="0" dirty="0">
+                <a:solidFill>
+                  <a:srgbClr val="5B6483"/>
+                </a:solidFill>
+                <a:latin typeface="Calibri" pitchFamily="34" charset="0"/>
+                <a:ea typeface="Calibri" pitchFamily="34" charset="-122"/>
+                <a:cs typeface="Calibri" pitchFamily="34" charset="-120"/>
+              </a:rPr>
+              <a:t>WHERE CSI SITS NOW</a:t>
+            </a:r>
+            <a:endParaRPr lang="en-US" sz="1000" dirty="0"/>
+          </a:p>
+        </p:txBody>
+      </p:sp>
+      <p:sp>
+        <p:nvSpPr>
+          <p:cNvPr id="7" name="Text 5"/>
+          <p:cNvSpPr/>
+          <p:nvPr/>
+        </p:nvSpPr>
+        <p:spPr>
+          <a:xfrm>
+            <a:off x="960120" y="2834640"/>
+            <a:ext cx="4632808" cy="640080"/>
+          </a:xfrm>
+          <a:prstGeom prst="rect">
+            <a:avLst/>
+          </a:prstGeom>
+          <a:noFill/>
+          <a:ln/>
+        </p:spPr>
+        <p:txBody>
+          <a:bodyPr wrap="square" lIns="0" tIns="0" rIns="0" bIns="0" rtlCol="0" anchor="ctr"/>
+          <a:lstStyle/>
+          <a:p>
+            <a:pPr indent="0" marL="0">
+              <a:buNone/>
+            </a:pPr>
+            <a:r>
+              <a:rPr lang="en-US" sz="3000" b="1" dirty="0">
+                <a:solidFill>
+                  <a:srgbClr val="0F1A3D"/>
+                </a:solidFill>
+                <a:latin typeface="Cambria" pitchFamily="34" charset="0"/>
+                <a:ea typeface="Cambria" pitchFamily="34" charset="-122"/>
+                <a:cs typeface="Cambria" pitchFamily="34" charset="-120"/>
+              </a:rPr>
+              <a:t>75.0 / 66</a:t>
+            </a:r>
+            <a:endParaRPr lang="en-US" sz="3000" dirty="0"/>
+          </a:p>
+        </p:txBody>
+      </p:sp>
+      <p:sp>
+        <p:nvSpPr>
+          <p:cNvPr id="8" name="Text 6"/>
+          <p:cNvSpPr/>
+          <p:nvPr/>
+        </p:nvSpPr>
+        <p:spPr>
+          <a:xfrm>
+            <a:off x="960120" y="3429000"/>
+            <a:ext cx="4632808" cy="548640"/>
+          </a:xfrm>
+          <a:prstGeom prst="rect">
+            <a:avLst/>
+          </a:prstGeom>
+          <a:noFill/>
+          <a:ln/>
+        </p:spPr>
+        <p:txBody>
+          <a:bodyPr wrap="square" lIns="0" tIns="0" rIns="0" bIns="0" rtlCol="0" anchor="ctr"/>
+          <a:lstStyle/>
+          <a:p>
+            <a:pPr indent="0" marL="0">
+              <a:buNone/>
+            </a:pPr>
+            <a:r>
+              <a:rPr lang="en-US" sz="1100" dirty="0">
+                <a:solidFill>
+                  <a:srgbClr val="0F1A3D"/>
+                </a:solidFill>
+                <a:latin typeface="Calibri" pitchFamily="34" charset="0"/>
+                <a:ea typeface="Calibri" pitchFamily="34" charset="-122"/>
+                <a:cs typeface="Calibri" pitchFamily="34" charset="-120"/>
+              </a:rPr>
+              <a:t>2025 CSI of 75.0 vs. the 2014 low of roughly 66. Even after two years of decline, severity is still ~14% higher than a decade ago.</a:t>
+            </a:r>
+            <a:endParaRPr lang="en-US" sz="1100" dirty="0"/>
+          </a:p>
+        </p:txBody>
+      </p:sp>
+      <p:sp>
+        <p:nvSpPr>
+          <p:cNvPr id="9" name="Shape 7"/>
+          <p:cNvSpPr/>
+          <p:nvPr/>
+        </p:nvSpPr>
+        <p:spPr>
+          <a:xfrm>
+            <a:off x="6278728" y="2331720"/>
+            <a:ext cx="5272888" cy="1737360"/>
+          </a:xfrm>
+          <a:prstGeom prst="roundRect">
+            <a:avLst>
+              <a:gd name="adj" fmla="val 5263"/>
+            </a:avLst>
+          </a:prstGeom>
+          <a:solidFill>
+            <a:srgbClr val="EEF1F7"/>
+          </a:solidFill>
+          <a:ln w="12700">
+            <a:solidFill>
+              <a:srgbClr val="EEF1F7"/>
+            </a:solidFill>
+            <a:prstDash val="solid"/>
+          </a:ln>
+        </p:spPr>
+      </p:sp>
+      <p:sp>
+        <p:nvSpPr>
+          <p:cNvPr id="10" name="Text 8"/>
+          <p:cNvSpPr/>
+          <p:nvPr/>
+        </p:nvSpPr>
+        <p:spPr>
+          <a:xfrm>
+            <a:off x="6598768" y="2514600"/>
+            <a:ext cx="4632808" cy="274320"/>
+          </a:xfrm>
+          <a:prstGeom prst="rect">
+            <a:avLst/>
+          </a:prstGeom>
+          <a:noFill/>
+          <a:ln/>
+        </p:spPr>
+        <p:txBody>
+          <a:bodyPr wrap="square" lIns="0" tIns="0" rIns="0" bIns="0" rtlCol="0" anchor="ctr"/>
+          <a:lstStyle/>
+          <a:p>
+            <a:pPr indent="0" marL="0">
+              <a:buNone/>
+            </a:pPr>
+            <a:r>
+              <a:rPr lang="en-US" sz="1000" b="1" spc="400" kern="0" dirty="0">
+                <a:solidFill>
+                  <a:srgbClr val="5B6483"/>
+                </a:solidFill>
+                <a:latin typeface="Calibri" pitchFamily="34" charset="0"/>
+                <a:ea typeface="Calibri" pitchFamily="34" charset="-122"/>
+                <a:cs typeface="Calibri" pitchFamily="34" charset="-120"/>
+              </a:rPr>
+              <a:t>THE DECADE THAT CAME BEFORE</a:t>
+            </a:r>
+            <a:endParaRPr lang="en-US" sz="1000" dirty="0"/>
+          </a:p>
+        </p:txBody>
+      </p:sp>
+      <p:sp>
+        <p:nvSpPr>
+          <p:cNvPr id="11" name="Text 9"/>
+          <p:cNvSpPr/>
+          <p:nvPr/>
+        </p:nvSpPr>
+        <p:spPr>
+          <a:xfrm>
+            <a:off x="6598768" y="2834640"/>
+            <a:ext cx="4632808" cy="640080"/>
+          </a:xfrm>
+          <a:prstGeom prst="rect">
+            <a:avLst/>
+          </a:prstGeom>
+          <a:noFill/>
+          <a:ln/>
+        </p:spPr>
+        <p:txBody>
+          <a:bodyPr wrap="square" lIns="0" tIns="0" rIns="0" bIns="0" rtlCol="0" anchor="ctr"/>
+          <a:lstStyle/>
+          <a:p>
+            <a:pPr indent="0" marL="0">
+              <a:buNone/>
+            </a:pPr>
+            <a:r>
+              <a:rPr lang="en-US" sz="3000" b="1" dirty="0">
+                <a:solidFill>
+                  <a:srgbClr val="0F1A3D"/>
+                </a:solidFill>
+                <a:latin typeface="Cambria" pitchFamily="34" charset="0"/>
+                <a:ea typeface="Cambria" pitchFamily="34" charset="-122"/>
+                <a:cs typeface="Cambria" pitchFamily="34" charset="-120"/>
+              </a:rPr>
+              <a:t>+22% 2014→2024</a:t>
+            </a:r>
+            <a:endParaRPr lang="en-US" sz="3000" dirty="0"/>
+          </a:p>
+        </p:txBody>
+      </p:sp>
+      <p:sp>
+        <p:nvSpPr>
+          <p:cNvPr id="12" name="Text 10"/>
+          <p:cNvSpPr/>
+          <p:nvPr/>
+        </p:nvSpPr>
+        <p:spPr>
+          <a:xfrm>
+            <a:off x="6598768" y="3429000"/>
+            <a:ext cx="4632808" cy="548640"/>
+          </a:xfrm>
+          <a:prstGeom prst="rect">
+            <a:avLst/>
+          </a:prstGeom>
+          <a:noFill/>
+          <a:ln/>
+        </p:spPr>
+        <p:txBody>
+          <a:bodyPr wrap="square" lIns="0" tIns="0" rIns="0" bIns="0" rtlCol="0" anchor="ctr"/>
+          <a:lstStyle/>
+          <a:p>
+            <a:pPr indent="0" marL="0">
+              <a:buNone/>
+            </a:pPr>
+            <a:r>
+              <a:rPr lang="en-US" sz="1100" dirty="0">
+                <a:solidFill>
+                  <a:srgbClr val="0F1A3D"/>
+                </a:solidFill>
+                <a:latin typeface="Calibri" pitchFamily="34" charset="0"/>
+                <a:ea typeface="Calibri" pitchFamily="34" charset="-122"/>
+                <a:cs typeface="Calibri" pitchFamily="34" charset="-120"/>
+              </a:rPr>
+              <a:t>Violent CSI climbed almost every year from 2014 through 2024. 2025's dip walks back only a fraction of that run-up.</a:t>
+            </a:r>
+            <a:endParaRPr lang="en-US" sz="1100" dirty="0"/>
+          </a:p>
+        </p:txBody>
+      </p:sp>
+      <p:sp>
+        <p:nvSpPr>
+          <p:cNvPr id="13" name="Shape 11"/>
+          <p:cNvSpPr/>
+          <p:nvPr/>
+        </p:nvSpPr>
+        <p:spPr>
+          <a:xfrm>
+            <a:off x="640080" y="4343400"/>
+            <a:ext cx="5272888" cy="1737360"/>
+          </a:xfrm>
+          <a:prstGeom prst="roundRect">
+            <a:avLst>
+              <a:gd name="adj" fmla="val 5263"/>
+            </a:avLst>
+          </a:prstGeom>
+          <a:solidFill>
+            <a:srgbClr val="EEF1F7"/>
+          </a:solidFill>
+          <a:ln w="12700">
+            <a:solidFill>
+              <a:srgbClr val="EEF1F7"/>
+            </a:solidFill>
+            <a:prstDash val="solid"/>
+          </a:ln>
+        </p:spPr>
+      </p:sp>
+      <p:sp>
+        <p:nvSpPr>
+          <p:cNvPr id="14" name="Text 12"/>
+          <p:cNvSpPr/>
+          <p:nvPr/>
+        </p:nvSpPr>
+        <p:spPr>
+          <a:xfrm>
+            <a:off x="960120" y="4526280"/>
+            <a:ext cx="4632808" cy="274320"/>
+          </a:xfrm>
+          <a:prstGeom prst="rect">
+            <a:avLst/>
+          </a:prstGeom>
+          <a:noFill/>
+          <a:ln/>
+        </p:spPr>
+        <p:txBody>
+          <a:bodyPr wrap="square" lIns="0" tIns="0" rIns="0" bIns="0" rtlCol="0" anchor="ctr"/>
+          <a:lstStyle/>
+          <a:p>
+            <a:pPr indent="0" marL="0">
+              <a:buNone/>
+            </a:pPr>
+            <a:r>
+              <a:rPr lang="en-US" sz="1000" b="1" spc="400" kern="0" dirty="0">
+                <a:solidFill>
+                  <a:srgbClr val="5B6483"/>
+                </a:solidFill>
+                <a:latin typeface="Calibri" pitchFamily="34" charset="0"/>
+                <a:ea typeface="Calibri" pitchFamily="34" charset="-122"/>
+                <a:cs typeface="Calibri" pitchFamily="34" charset="-120"/>
+              </a:rPr>
+              <a:t>SIZE OF THE MOVE</a:t>
+            </a:r>
+            <a:endParaRPr lang="en-US" sz="1000" dirty="0"/>
+          </a:p>
+        </p:txBody>
+      </p:sp>
+      <p:sp>
+        <p:nvSpPr>
+          <p:cNvPr id="15" name="Text 13"/>
+          <p:cNvSpPr/>
+          <p:nvPr/>
+        </p:nvSpPr>
+        <p:spPr>
+          <a:xfrm>
+            <a:off x="960120" y="4846320"/>
+            <a:ext cx="4632808" cy="640080"/>
+          </a:xfrm>
+          <a:prstGeom prst="rect">
+            <a:avLst/>
+          </a:prstGeom>
+          <a:noFill/>
+          <a:ln/>
+        </p:spPr>
+        <p:txBody>
+          <a:bodyPr wrap="square" lIns="0" tIns="0" rIns="0" bIns="0" rtlCol="0" anchor="ctr"/>
+          <a:lstStyle/>
+          <a:p>
+            <a:pPr indent="0" marL="0">
+              <a:buNone/>
+            </a:pPr>
+            <a:r>
+              <a:rPr lang="en-US" sz="3000" b="1" dirty="0">
+                <a:solidFill>
+                  <a:srgbClr val="0F1A3D"/>
+                </a:solidFill>
+                <a:latin typeface="Cambria" pitchFamily="34" charset="0"/>
+                <a:ea typeface="Cambria" pitchFamily="34" charset="-122"/>
+                <a:cs typeface="Cambria" pitchFamily="34" charset="-120"/>
+              </a:rPr>
+              <a:t>−2.4%</a:t>
+            </a:r>
+            <a:endParaRPr lang="en-US" sz="3000" dirty="0"/>
+          </a:p>
+        </p:txBody>
+      </p:sp>
+      <p:sp>
+        <p:nvSpPr>
+          <p:cNvPr id="16" name="Text 14"/>
+          <p:cNvSpPr/>
+          <p:nvPr/>
+        </p:nvSpPr>
+        <p:spPr>
+          <a:xfrm>
+            <a:off x="960120" y="5440680"/>
+            <a:ext cx="4632808" cy="548640"/>
+          </a:xfrm>
+          <a:prstGeom prst="rect">
+            <a:avLst/>
+          </a:prstGeom>
+          <a:noFill/>
+          <a:ln/>
+        </p:spPr>
+        <p:txBody>
+          <a:bodyPr wrap="square" lIns="0" tIns="0" rIns="0" bIns="0" rtlCol="0" anchor="ctr"/>
+          <a:lstStyle/>
+          <a:p>
+            <a:pPr indent="0" marL="0">
+              <a:buNone/>
+            </a:pPr>
+            <a:r>
+              <a:rPr lang="en-US" sz="1100" dirty="0">
+                <a:solidFill>
+                  <a:srgbClr val="0F1A3D"/>
+                </a:solidFill>
+                <a:latin typeface="Calibri" pitchFamily="34" charset="0"/>
+                <a:ea typeface="Calibri" pitchFamily="34" charset="-122"/>
+                <a:cs typeface="Calibri" pitchFamily="34" charset="-120"/>
+              </a:rPr>
+              <a:t>Overall crime rate fell 2.4% and CSI fell 4.86% — a modest improvement next to the 20%+ increase in severity accumulated over the prior decade.</a:t>
+            </a:r>
+            <a:endParaRPr lang="en-US" sz="1100" dirty="0"/>
+          </a:p>
+        </p:txBody>
+      </p:sp>
+      <p:sp>
+        <p:nvSpPr>
+          <p:cNvPr id="17" name="Shape 15"/>
+          <p:cNvSpPr/>
+          <p:nvPr/>
+        </p:nvSpPr>
+        <p:spPr>
+          <a:xfrm>
+            <a:off x="6278728" y="4343400"/>
+            <a:ext cx="5272888" cy="1737360"/>
+          </a:xfrm>
+          <a:prstGeom prst="roundRect">
+            <a:avLst>
+              <a:gd name="adj" fmla="val 5263"/>
+            </a:avLst>
+          </a:prstGeom>
+          <a:solidFill>
+            <a:srgbClr val="EEF1F7"/>
+          </a:solidFill>
+          <a:ln w="12700">
+            <a:solidFill>
+              <a:srgbClr val="EEF1F7"/>
+            </a:solidFill>
+            <a:prstDash val="solid"/>
+          </a:ln>
+        </p:spPr>
+      </p:sp>
+      <p:sp>
+        <p:nvSpPr>
+          <p:cNvPr id="18" name="Text 16"/>
+          <p:cNvSpPr/>
+          <p:nvPr/>
+        </p:nvSpPr>
+        <p:spPr>
+          <a:xfrm>
+            <a:off x="6598768" y="4526280"/>
+            <a:ext cx="4632808" cy="274320"/>
+          </a:xfrm>
+          <a:prstGeom prst="rect">
+            <a:avLst/>
+          </a:prstGeom>
+          <a:noFill/>
+          <a:ln/>
+        </p:spPr>
+        <p:txBody>
+          <a:bodyPr wrap="square" lIns="0" tIns="0" rIns="0" bIns="0" rtlCol="0" anchor="ctr"/>
+          <a:lstStyle/>
+          <a:p>
+            <a:pPr indent="0" marL="0">
+              <a:buNone/>
+            </a:pPr>
+            <a:r>
+              <a:rPr lang="en-US" sz="1000" b="1" spc="400" kern="0" dirty="0">
+                <a:solidFill>
+                  <a:srgbClr val="5B6483"/>
+                </a:solidFill>
+                <a:latin typeface="Calibri" pitchFamily="34" charset="0"/>
+                <a:ea typeface="Calibri" pitchFamily="34" charset="-122"/>
+                <a:cs typeface="Calibri" pitchFamily="34" charset="-120"/>
+              </a:rPr>
+              <a:t>DIRECTION OF TRAVEL</a:t>
+            </a:r>
+            <a:endParaRPr lang="en-US" sz="1000" dirty="0"/>
+          </a:p>
+        </p:txBody>
+      </p:sp>
+      <p:sp>
+        <p:nvSpPr>
+          <p:cNvPr id="19" name="Text 17"/>
+          <p:cNvSpPr/>
+          <p:nvPr/>
+        </p:nvSpPr>
+        <p:spPr>
+          <a:xfrm>
+            <a:off x="6598768" y="4846320"/>
+            <a:ext cx="4632808" cy="640080"/>
+          </a:xfrm>
+          <a:prstGeom prst="rect">
+            <a:avLst/>
+          </a:prstGeom>
+          <a:noFill/>
+          <a:ln/>
+        </p:spPr>
+        <p:txBody>
+          <a:bodyPr wrap="square" lIns="0" tIns="0" rIns="0" bIns="0" rtlCol="0" anchor="ctr"/>
+          <a:lstStyle/>
+          <a:p>
+            <a:pPr indent="0" marL="0">
+              <a:buNone/>
+            </a:pPr>
+            <a:r>
+              <a:rPr lang="en-US" sz="3000" b="1" dirty="0">
+                <a:solidFill>
+                  <a:srgbClr val="0F1A3D"/>
+                </a:solidFill>
+                <a:latin typeface="Cambria" pitchFamily="34" charset="0"/>
+                <a:ea typeface="Cambria" pitchFamily="34" charset="-122"/>
+                <a:cs typeface="Cambria" pitchFamily="34" charset="-120"/>
+              </a:rPr>
+              <a:t>2 years down</a:t>
+            </a:r>
+            <a:endParaRPr lang="en-US" sz="3000" dirty="0"/>
+          </a:p>
+        </p:txBody>
+      </p:sp>
+      <p:sp>
+        <p:nvSpPr>
+          <p:cNvPr id="20" name="Text 18"/>
+          <p:cNvSpPr/>
+          <p:nvPr/>
+        </p:nvSpPr>
+        <p:spPr>
+          <a:xfrm>
+            <a:off x="6598768" y="5440680"/>
+            <a:ext cx="4632808" cy="548640"/>
+          </a:xfrm>
+          <a:prstGeom prst="rect">
+            <a:avLst/>
+          </a:prstGeom>
+          <a:noFill/>
+          <a:ln/>
+        </p:spPr>
+        <p:txBody>
+          <a:bodyPr wrap="square" lIns="0" tIns="0" rIns="0" bIns="0" rtlCol="0" anchor="ctr"/>
+          <a:lstStyle/>
+          <a:p>
+            <a:pPr indent="0" marL="0">
+              <a:buNone/>
+            </a:pPr>
+            <a:r>
+              <a:rPr lang="en-US" sz="1100" dirty="0">
+                <a:solidFill>
+                  <a:srgbClr val="0F1A3D"/>
+                </a:solidFill>
+                <a:latin typeface="Calibri" pitchFamily="34" charset="0"/>
+                <a:ea typeface="Calibri" pitchFamily="34" charset="-122"/>
+                <a:cs typeface="Calibri" pitchFamily="34" charset="-120"/>
+              </a:rPr>
+              <a:t>A second annual decline is real, not noise — but one more data point is needed before calling it a durable reversal.</a:t>
+            </a:r>
+            <a:endParaRPr lang="en-US" sz="1100" dirty="0"/>
+          </a:p>
+        </p:txBody>
+      </p:sp>
+      <p:sp>
+        <p:nvSpPr>
+          <p:cNvPr id="21" name="Shape 19"/>
+          <p:cNvSpPr/>
+          <p:nvPr/>
+        </p:nvSpPr>
+        <p:spPr>
+          <a:xfrm>
+            <a:off x="640080" y="6355080"/>
+            <a:ext cx="10911535" cy="822960"/>
+          </a:xfrm>
+          <a:prstGeom prst="roundRect">
+            <a:avLst>
+              <a:gd name="adj" fmla="val 13333"/>
+            </a:avLst>
+          </a:prstGeom>
+          <a:solidFill>
+            <a:srgbClr val="1B2A5E"/>
+          </a:solidFill>
+          <a:ln w="12700">
+            <a:solidFill>
+              <a:srgbClr val="1B2A5E"/>
+            </a:solidFill>
+            <a:prstDash val="solid"/>
+          </a:ln>
+        </p:spPr>
+      </p:sp>
+      <p:sp>
+        <p:nvSpPr>
+          <p:cNvPr id="22" name="Text 20"/>
+          <p:cNvSpPr/>
+          <p:nvPr/>
+        </p:nvSpPr>
+        <p:spPr>
+          <a:xfrm>
+            <a:off x="822960" y="6492240"/>
+            <a:ext cx="10545775" cy="640080"/>
+          </a:xfrm>
+          <a:prstGeom prst="rect">
+            <a:avLst/>
+          </a:prstGeom>
+          <a:noFill/>
+          <a:ln/>
+        </p:spPr>
+        <p:txBody>
+          <a:bodyPr wrap="square" lIns="0" tIns="0" rIns="0" bIns="0" rtlCol="0" anchor="ctr"/>
+          <a:lstStyle/>
+          <a:p>
+            <a:pPr indent="0" marL="0">
+              <a:buNone/>
+            </a:pPr>
+            <a:r>
+              <a:rPr lang="en-US" sz="1300" b="1" dirty="0">
+                <a:solidFill>
+                  <a:srgbClr val="FFE38A"/>
+                </a:solidFill>
+                <a:latin typeface="Calibri" pitchFamily="34" charset="0"/>
+                <a:ea typeface="Calibri" pitchFamily="34" charset="-122"/>
+                <a:cs typeface="Calibri" pitchFamily="34" charset="-120"/>
+              </a:rPr>
+              <a:t>Bottom line: </a:t>
+            </a:r>
+            <a:pPr indent="0" marL="0">
+              <a:buNone/>
+            </a:pPr>
+            <a:r>
+              <a:rPr lang="en-US" sz="1300" i="1" dirty="0">
+                <a:solidFill>
+                  <a:srgbClr val="FFFFFF"/>
+                </a:solidFill>
+                <a:latin typeface="Calibri" pitchFamily="34" charset="0"/>
+                <a:ea typeface="Calibri" pitchFamily="34" charset="-122"/>
+                <a:cs typeface="Calibri" pitchFamily="34" charset="-120"/>
+              </a:rPr>
+              <a:t>the direction turned in 2025, but the magnitude is small and the gains are uneven. Communicate an improving trend — and keep resourcing on the serious offences that still moved up.</a:t>
+            </a:r>
+            <a:endParaRPr lang="en-US" sz="1300" dirty="0"/>
+          </a:p>
+        </p:txBody>
+      </p:sp>
+      <p:sp>
+        <p:nvSpPr>
+          <p:cNvPr id="23" name="Text 21"/>
+          <p:cNvSpPr/>
+          <p:nvPr/>
+        </p:nvSpPr>
+        <p:spPr>
+          <a:xfrm>
+            <a:off x="640080" y="6446520"/>
+            <a:ext cx="5486400" cy="274320"/>
+          </a:xfrm>
+          <a:prstGeom prst="rect">
+            <a:avLst/>
+          </a:prstGeom>
+          <a:noFill/>
+          <a:ln/>
+        </p:spPr>
+        <p:txBody>
+          <a:bodyPr wrap="square" lIns="0" tIns="0" rIns="0" bIns="0" rtlCol="0" anchor="ctr"/>
+          <a:lstStyle/>
+          <a:p>
+            <a:pPr indent="0" marL="0">
+              <a:buNone/>
+            </a:pPr>
+            <a:r>
+              <a:rPr lang="en-US" sz="900" dirty="0">
+                <a:solidFill>
+                  <a:srgbClr val="7D859F"/>
+                </a:solidFill>
+                <a:latin typeface="Calibri" pitchFamily="34" charset="0"/>
+                <a:ea typeface="Calibri" pitchFamily="34" charset="-122"/>
+                <a:cs typeface="Calibri" pitchFamily="34" charset="-120"/>
+              </a:rPr>
+              <a:t>Statistics Canada, Crime Severity Index, 2000–2025</a:t>
+            </a:r>
+            <a:endParaRPr lang="en-US" sz="900" dirty="0"/>
+          </a:p>
+        </p:txBody>
+      </p:sp>
+      <p:sp>
+        <p:nvSpPr>
+          <p:cNvPr id="24" name="Text 22"/>
+          <p:cNvSpPr/>
+          <p:nvPr/>
+        </p:nvSpPr>
+        <p:spPr>
+          <a:xfrm>
+            <a:off x="6065215" y="6446520"/>
+            <a:ext cx="5486400" cy="274320"/>
+          </a:xfrm>
+          <a:prstGeom prst="rect">
+            <a:avLst/>
+          </a:prstGeom>
+          <a:noFill/>
+          <a:ln/>
+        </p:spPr>
+        <p:txBody>
+          <a:bodyPr wrap="square" lIns="0" tIns="0" rIns="0" bIns="0" rtlCol="0" anchor="ctr"/>
+          <a:lstStyle/>
+          <a:p>
+            <a:pPr algn="r" indent="0" marL="0">
+              <a:buNone/>
+            </a:pPr>
+            <a:r>
+              <a:rPr lang="en-US" sz="900" dirty="0">
+                <a:solidFill>
+                  <a:srgbClr val="7D859F"/>
+                </a:solidFill>
+                <a:latin typeface="Calibri" pitchFamily="34" charset="0"/>
+                <a:ea typeface="Calibri" pitchFamily="34" charset="-122"/>
+                <a:cs typeface="Calibri" pitchFamily="34" charset="-120"/>
+              </a:rPr>
+              <a:t>Statistics Canada · July 2026 release</a:t>
+            </a:r>
+            <a:endParaRPr lang="en-US" sz="900" dirty="0"/>
+          </a:p>
+        </p:txBody>
+      </p:sp>
+    </p:spTree>
+  </p:cSld>
+  <p:clrMapOvr>
+    <a:masterClrMapping/>
+  </p:clrMapOvr>
+</p:sld>
+</file>
+
+<file path=ppt/slides/slide9.xml><?xml version="1.0" encoding="utf-8"?>
+<p:sld xmlns:a="http://schemas.openxmlformats.org/drawingml/2006/main" xmlns:r="http://schemas.openxmlformats.org/officeDocument/2006/relationships" xmlns:p="http://schemas.openxmlformats.org/presentationml/2006/main">
+  <p:cSld name="Slide 9">
     <p:bg>
       <p:bgPr>
         <a:solidFill>

</xml_diff>

<commit_message>
Use real notebook charts and remove unverified figures
- Replace the four re-drawn charts with the original matplotlib PNGs
  extracted from Crime_Insights_2025.ipynb (CSI, weighted clearance,
  cybercrime, organized crime)
- Update slide callouts to cite exact StatCan values from the notebook
  (CSI 75.01 / 66.78 / 97.19; clearance 36.64 / 54.46 / 26.28) and
  remove approximated claims (e.g. "~14% above the 2014 low",
  "20%+ increase over the prior decade")
- Rename the context-slide card "The decade that came before" to
  "Violent CSI stays high" with the actual 97.19 vs 101.42 numbers

Co-Authored-By: Claude Opus 4.7 <noreply@anthropic.com>
Claude-Session: https://claude.ai/code/session_01GGjtcFQ4SBoyFwX8beAVGZ
</commit_message>
<xml_diff>
--- a/Canadian_Crime_2025_Exec_Brief.pptx
+++ b/Canadian_Crime_2025_Exec_Brief.pptx
@@ -113,2690 +113,6 @@
     </a:lvl9pPr>
   </p:defaultTextStyle>
 </p:presentation>
-</file>
-
-<file path=ppt/charts/chart1.xml><?xml version="1.0" encoding="utf-8"?>
-<c:chartSpace xmlns:c="http://schemas.openxmlformats.org/drawingml/2006/chart" xmlns:a="http://schemas.openxmlformats.org/drawingml/2006/main" xmlns:r="http://schemas.openxmlformats.org/officeDocument/2006/relationships">
-  <c:date1904 val="0"/>
-  <c:roundedCorners val="1"/>
-  <c:chart>
-    <c:title>
-      <c:tx>
-        <c:rich>
-          <a:bodyPr/>
-          <a:lstStyle/>
-          <a:p>
-            <a:pPr>
-              <a:defRPr sz="1200" b="0" i="0" u="none" strike="noStrike">
-                <a:solidFill>
-                  <a:srgbClr val="0F1A3D"/>
-                </a:solidFill>
-                <a:latin typeface="Calibri"/>
-              </a:defRPr>
-            </a:pPr>
-            <a:r>
-              <a:rPr sz="1200" b="0" i="0" u="none" strike="noStrike">
-                <a:solidFill>
-                  <a:srgbClr val="0F1A3D"/>
-                </a:solidFill>
-                <a:latin typeface="Calibri"/>
-              </a:rPr>
-              <a:t>Crime Severity Indices in Canada (2000–2025)</a:t>
-            </a:r>
-          </a:p>
-        </c:rich>
-      </c:tx>
-      <c:layout/>
-      <c:overlay val="0"/>
-    </c:title>
-    <c:autoTitleDeleted val="0"/>
-    <c:plotArea>
-      <c:layout/>
-      <c:lineChart>
-        <c:varyColors val="0"/>
-        <c:ser>
-          <c:idx val="0"/>
-          <c:order val="0"/>
-          <c:tx>
-            <c:strRef>
-              <c:f>Sheet1!$B$1</c:f>
-              <c:strCache>
-                <c:ptCount val="1"/>
-                <c:pt idx="0">
-                  <c:v>Crime severity index</c:v>
-                </c:pt>
-              </c:strCache>
-            </c:strRef>
-          </c:tx>
-          <c:spPr>
-            <a:solidFill>
-              <a:srgbClr val="3771C8"/>
-            </a:solidFill>
-            <a:ln w="25400" cap="flat">
-              <a:solidFill>
-                <a:srgbClr val="3771C8"/>
-              </a:solidFill>
-              <a:prstDash val="solid"/>
-              <a:round/>
-            </a:ln>
-            <a:effectLst/>
-          </c:spPr>
-          <c:invertIfNegative val="0"/>
-          <c:dLbls>
-            <c:numFmt formatCode="#,##0" sourceLinked="0"/>
-            <c:txPr>
-              <a:bodyPr/>
-              <a:lstStyle/>
-              <a:p>
-                <a:pPr>
-                  <a:defRPr b="0" i="0" strike="noStrike" sz="1200" u="none">
-                    <a:solidFill>
-                      <a:srgbClr val="000000"/>
-                    </a:solidFill>
-                    <a:latin typeface="Arial"/>
-                  </a:defRPr>
-                </a:pPr>
-              </a:p>
-            </c:txPr>
-            <c:showLegendKey val="0"/>
-            <c:showVal val="0"/>
-            <c:showCatName val="0"/>
-            <c:showSerName val="0"/>
-            <c:showPercent val="0"/>
-            <c:showBubbleSize val="0"/>
-            <c:showLeaderLines val="0"/>
-          </c:dLbls>
-          <c:marker>
-            <c:symbol val="none"/>
-            <c:size val="6"/>
-            <c:spPr>
-              <a:solidFill>
-                <a:srgbClr val="3771C8"/>
-              </a:solidFill>
-              <a:ln w="9525" cap="flat">
-                <a:solidFill>
-                  <a:srgbClr val="3771C8"/>
-                </a:solidFill>
-                <a:prstDash val="solid"/>
-                <a:round/>
-              </a:ln>
-              <a:effectLst/>
-            </c:spPr>
-          </c:marker>
-          <c:cat>
-            <c:multiLvlStrRef>
-              <c:f>Sheet1!$A$2:$A$27</c:f>
-              <c:multiLvlStrCache>
-                <c:ptCount val="26"/>
-                <c:lvl>
-                  <c:pt idx="0">
-                    <c:v>2000</c:v>
-                  </c:pt>
-                  <c:pt idx="1">
-                    <c:v>2001</c:v>
-                  </c:pt>
-                  <c:pt idx="2">
-                    <c:v>2002</c:v>
-                  </c:pt>
-                  <c:pt idx="3">
-                    <c:v>2003</c:v>
-                  </c:pt>
-                  <c:pt idx="4">
-                    <c:v>2004</c:v>
-                  </c:pt>
-                  <c:pt idx="5">
-                    <c:v>2005</c:v>
-                  </c:pt>
-                  <c:pt idx="6">
-                    <c:v>2006</c:v>
-                  </c:pt>
-                  <c:pt idx="7">
-                    <c:v>2007</c:v>
-                  </c:pt>
-                  <c:pt idx="8">
-                    <c:v>2008</c:v>
-                  </c:pt>
-                  <c:pt idx="9">
-                    <c:v>2009</c:v>
-                  </c:pt>
-                  <c:pt idx="10">
-                    <c:v>2010</c:v>
-                  </c:pt>
-                  <c:pt idx="11">
-                    <c:v>2011</c:v>
-                  </c:pt>
-                  <c:pt idx="12">
-                    <c:v>2012</c:v>
-                  </c:pt>
-                  <c:pt idx="13">
-                    <c:v>2013</c:v>
-                  </c:pt>
-                  <c:pt idx="14">
-                    <c:v>2014</c:v>
-                  </c:pt>
-                  <c:pt idx="15">
-                    <c:v>2015</c:v>
-                  </c:pt>
-                  <c:pt idx="16">
-                    <c:v>2016</c:v>
-                  </c:pt>
-                  <c:pt idx="17">
-                    <c:v>2017</c:v>
-                  </c:pt>
-                  <c:pt idx="18">
-                    <c:v>2018</c:v>
-                  </c:pt>
-                  <c:pt idx="19">
-                    <c:v>2019</c:v>
-                  </c:pt>
-                  <c:pt idx="20">
-                    <c:v>2020</c:v>
-                  </c:pt>
-                  <c:pt idx="21">
-                    <c:v>2021</c:v>
-                  </c:pt>
-                  <c:pt idx="22">
-                    <c:v>2022</c:v>
-                  </c:pt>
-                  <c:pt idx="23">
-                    <c:v>2023</c:v>
-                  </c:pt>
-                  <c:pt idx="24">
-                    <c:v>2024</c:v>
-                  </c:pt>
-                  <c:pt idx="25">
-                    <c:v>2025</c:v>
-                  </c:pt>
-                </c:lvl>
-              </c:multiLvlStrCache>
-            </c:multiLvlStrRef>
-          </c:cat>
-          <c:val>
-            <c:numRef>
-              <c:f>Sheet1!$B$2:$B$27</c:f>
-              <c:numCache>
-                <c:formatCode>General</c:formatCode>
-                <c:ptCount val="26"/>
-                <c:pt idx="0">
-                  <c:v>106.7</c:v>
-                </c:pt>
-                <c:pt idx="1">
-                  <c:v>104</c:v>
-                </c:pt>
-                <c:pt idx="2">
-                  <c:v>106.5</c:v>
-                </c:pt>
-                <c:pt idx="3">
-                  <c:v>106.7</c:v>
-                </c:pt>
-                <c:pt idx="4">
-                  <c:v>105.5</c:v>
-                </c:pt>
-                <c:pt idx="5">
-                  <c:v>104</c:v>
-                </c:pt>
-                <c:pt idx="6">
-                  <c:v>102</c:v>
-                </c:pt>
-                <c:pt idx="7">
-                  <c:v>100</c:v>
-                </c:pt>
-                <c:pt idx="8">
-                  <c:v>97</c:v>
-                </c:pt>
-                <c:pt idx="9">
-                  <c:v>90</c:v>
-                </c:pt>
-                <c:pt idx="10">
-                  <c:v>83</c:v>
-                </c:pt>
-                <c:pt idx="11">
-                  <c:v>79</c:v>
-                </c:pt>
-                <c:pt idx="12">
-                  <c:v>76</c:v>
-                </c:pt>
-                <c:pt idx="13">
-                  <c:v>75</c:v>
-                </c:pt>
-                <c:pt idx="14">
-                  <c:v>74</c:v>
-                </c:pt>
-                <c:pt idx="15">
-                  <c:v>72</c:v>
-                </c:pt>
-                <c:pt idx="16">
-                  <c:v>73</c:v>
-                </c:pt>
-                <c:pt idx="17">
-                  <c:v>75</c:v>
-                </c:pt>
-                <c:pt idx="18">
-                  <c:v>76</c:v>
-                </c:pt>
-                <c:pt idx="19">
-                  <c:v>80</c:v>
-                </c:pt>
-                <c:pt idx="20">
-                  <c:v>74</c:v>
-                </c:pt>
-                <c:pt idx="21">
-                  <c:v>74</c:v>
-                </c:pt>
-                <c:pt idx="22">
-                  <c:v>79</c:v>
-                </c:pt>
-                <c:pt idx="23">
-                  <c:v>81</c:v>
-                </c:pt>
-                <c:pt idx="24">
-                  <c:v>78.9</c:v>
-                </c:pt>
-                <c:pt idx="25">
-                  <c:v>75</c:v>
-                </c:pt>
-              </c:numCache>
-            </c:numRef>
-          </c:val>
-          <c:smooth val="0"/>
-        </c:ser>
-        <c:ser>
-          <c:idx val="1"/>
-          <c:order val="1"/>
-          <c:tx>
-            <c:strRef>
-              <c:f>Sheet1!$C$1</c:f>
-              <c:strCache>
-                <c:ptCount val="1"/>
-                <c:pt idx="0">
-                  <c:v>Violent CSI</c:v>
-                </c:pt>
-              </c:strCache>
-            </c:strRef>
-          </c:tx>
-          <c:spPr>
-            <a:solidFill>
-              <a:srgbClr val="E08A1E"/>
-            </a:solidFill>
-            <a:ln w="25400" cap="flat">
-              <a:solidFill>
-                <a:srgbClr val="E08A1E"/>
-              </a:solidFill>
-              <a:prstDash val="solid"/>
-              <a:round/>
-            </a:ln>
-            <a:effectLst/>
-          </c:spPr>
-          <c:invertIfNegative val="0"/>
-          <c:dLbls>
-            <c:numFmt formatCode="#,##0" sourceLinked="0"/>
-            <c:txPr>
-              <a:bodyPr/>
-              <a:lstStyle/>
-              <a:p>
-                <a:pPr>
-                  <a:defRPr b="0" i="0" strike="noStrike" sz="1200" u="none">
-                    <a:solidFill>
-                      <a:srgbClr val="000000"/>
-                    </a:solidFill>
-                    <a:latin typeface="Arial"/>
-                  </a:defRPr>
-                </a:pPr>
-              </a:p>
-            </c:txPr>
-            <c:showLegendKey val="0"/>
-            <c:showVal val="0"/>
-            <c:showCatName val="0"/>
-            <c:showSerName val="0"/>
-            <c:showPercent val="0"/>
-            <c:showBubbleSize val="0"/>
-            <c:showLeaderLines val="0"/>
-          </c:dLbls>
-          <c:marker>
-            <c:symbol val="none"/>
-            <c:size val="6"/>
-            <c:spPr>
-              <a:solidFill>
-                <a:srgbClr val="E08A1E"/>
-              </a:solidFill>
-              <a:ln w="9525" cap="flat">
-                <a:solidFill>
-                  <a:srgbClr val="E08A1E"/>
-                </a:solidFill>
-                <a:prstDash val="solid"/>
-                <a:round/>
-              </a:ln>
-              <a:effectLst/>
-            </c:spPr>
-          </c:marker>
-          <c:cat>
-            <c:multiLvlStrRef>
-              <c:f>Sheet1!$A$2:$A$27</c:f>
-              <c:multiLvlStrCache>
-                <c:ptCount val="26"/>
-                <c:lvl>
-                  <c:pt idx="0">
-                    <c:v>2000</c:v>
-                  </c:pt>
-                  <c:pt idx="1">
-                    <c:v>2001</c:v>
-                  </c:pt>
-                  <c:pt idx="2">
-                    <c:v>2002</c:v>
-                  </c:pt>
-                  <c:pt idx="3">
-                    <c:v>2003</c:v>
-                  </c:pt>
-                  <c:pt idx="4">
-                    <c:v>2004</c:v>
-                  </c:pt>
-                  <c:pt idx="5">
-                    <c:v>2005</c:v>
-                  </c:pt>
-                  <c:pt idx="6">
-                    <c:v>2006</c:v>
-                  </c:pt>
-                  <c:pt idx="7">
-                    <c:v>2007</c:v>
-                  </c:pt>
-                  <c:pt idx="8">
-                    <c:v>2008</c:v>
-                  </c:pt>
-                  <c:pt idx="9">
-                    <c:v>2009</c:v>
-                  </c:pt>
-                  <c:pt idx="10">
-                    <c:v>2010</c:v>
-                  </c:pt>
-                  <c:pt idx="11">
-                    <c:v>2011</c:v>
-                  </c:pt>
-                  <c:pt idx="12">
-                    <c:v>2012</c:v>
-                  </c:pt>
-                  <c:pt idx="13">
-                    <c:v>2013</c:v>
-                  </c:pt>
-                  <c:pt idx="14">
-                    <c:v>2014</c:v>
-                  </c:pt>
-                  <c:pt idx="15">
-                    <c:v>2015</c:v>
-                  </c:pt>
-                  <c:pt idx="16">
-                    <c:v>2016</c:v>
-                  </c:pt>
-                  <c:pt idx="17">
-                    <c:v>2017</c:v>
-                  </c:pt>
-                  <c:pt idx="18">
-                    <c:v>2018</c:v>
-                  </c:pt>
-                  <c:pt idx="19">
-                    <c:v>2019</c:v>
-                  </c:pt>
-                  <c:pt idx="20">
-                    <c:v>2020</c:v>
-                  </c:pt>
-                  <c:pt idx="21">
-                    <c:v>2021</c:v>
-                  </c:pt>
-                  <c:pt idx="22">
-                    <c:v>2022</c:v>
-                  </c:pt>
-                  <c:pt idx="23">
-                    <c:v>2023</c:v>
-                  </c:pt>
-                  <c:pt idx="24">
-                    <c:v>2024</c:v>
-                  </c:pt>
-                  <c:pt idx="25">
-                    <c:v>2025</c:v>
-                  </c:pt>
-                </c:lvl>
-              </c:multiLvlStrCache>
-            </c:multiLvlStrRef>
-          </c:cat>
-          <c:val>
-            <c:numRef>
-              <c:f>Sheet1!$C$2:$C$27</c:f>
-              <c:numCache>
-                <c:formatCode>General</c:formatCode>
-                <c:ptCount val="26"/>
-                <c:pt idx="0">
-                  <c:v>98</c:v>
-                </c:pt>
-                <c:pt idx="1">
-                  <c:v>97</c:v>
-                </c:pt>
-                <c:pt idx="2">
-                  <c:v>96</c:v>
-                </c:pt>
-                <c:pt idx="3">
-                  <c:v>97.5</c:v>
-                </c:pt>
-                <c:pt idx="4">
-                  <c:v>96.5</c:v>
-                </c:pt>
-                <c:pt idx="5">
-                  <c:v>96</c:v>
-                </c:pt>
-                <c:pt idx="6">
-                  <c:v>95</c:v>
-                </c:pt>
-                <c:pt idx="7">
-                  <c:v>95.5</c:v>
-                </c:pt>
-                <c:pt idx="8">
-                  <c:v>94</c:v>
-                </c:pt>
-                <c:pt idx="9">
-                  <c:v>90</c:v>
-                </c:pt>
-                <c:pt idx="10">
-                  <c:v>86</c:v>
-                </c:pt>
-                <c:pt idx="11">
-                  <c:v>80</c:v>
-                </c:pt>
-                <c:pt idx="12">
-                  <c:v>76</c:v>
-                </c:pt>
-                <c:pt idx="13">
-                  <c:v>71</c:v>
-                </c:pt>
-                <c:pt idx="14">
-                  <c:v>70</c:v>
-                </c:pt>
-                <c:pt idx="15">
-                  <c:v>75</c:v>
-                </c:pt>
-                <c:pt idx="16">
-                  <c:v>80</c:v>
-                </c:pt>
-                <c:pt idx="17">
-                  <c:v>83</c:v>
-                </c:pt>
-                <c:pt idx="18">
-                  <c:v>85</c:v>
-                </c:pt>
-                <c:pt idx="19">
-                  <c:v>89</c:v>
-                </c:pt>
-                <c:pt idx="20">
-                  <c:v>86</c:v>
-                </c:pt>
-                <c:pt idx="21">
-                  <c:v>89</c:v>
-                </c:pt>
-                <c:pt idx="22">
-                  <c:v>95</c:v>
-                </c:pt>
-                <c:pt idx="23">
-                  <c:v>101</c:v>
-                </c:pt>
-                <c:pt idx="24">
-                  <c:v>101.5</c:v>
-                </c:pt>
-                <c:pt idx="25">
-                  <c:v>97</c:v>
-                </c:pt>
-              </c:numCache>
-            </c:numRef>
-          </c:val>
-          <c:smooth val="0"/>
-        </c:ser>
-        <c:ser>
-          <c:idx val="2"/>
-          <c:order val="2"/>
-          <c:tx>
-            <c:strRef>
-              <c:f>Sheet1!$D$1</c:f>
-              <c:strCache>
-                <c:ptCount val="1"/>
-                <c:pt idx="0">
-                  <c:v>Non-violent CSI</c:v>
-                </c:pt>
-              </c:strCache>
-            </c:strRef>
-          </c:tx>
-          <c:spPr>
-            <a:solidFill>
-              <a:srgbClr val="2F8F4C"/>
-            </a:solidFill>
-            <a:ln w="25400" cap="flat">
-              <a:solidFill>
-                <a:srgbClr val="2F8F4C"/>
-              </a:solidFill>
-              <a:prstDash val="solid"/>
-              <a:round/>
-            </a:ln>
-            <a:effectLst/>
-          </c:spPr>
-          <c:invertIfNegative val="0"/>
-          <c:dLbls>
-            <c:numFmt formatCode="#,##0" sourceLinked="0"/>
-            <c:txPr>
-              <a:bodyPr/>
-              <a:lstStyle/>
-              <a:p>
-                <a:pPr>
-                  <a:defRPr b="0" i="0" strike="noStrike" sz="1200" u="none">
-                    <a:solidFill>
-                      <a:srgbClr val="000000"/>
-                    </a:solidFill>
-                    <a:latin typeface="Arial"/>
-                  </a:defRPr>
-                </a:pPr>
-              </a:p>
-            </c:txPr>
-            <c:showLegendKey val="0"/>
-            <c:showVal val="0"/>
-            <c:showCatName val="0"/>
-            <c:showSerName val="0"/>
-            <c:showPercent val="0"/>
-            <c:showBubbleSize val="0"/>
-            <c:showLeaderLines val="0"/>
-          </c:dLbls>
-          <c:marker>
-            <c:symbol val="none"/>
-            <c:size val="6"/>
-            <c:spPr>
-              <a:solidFill>
-                <a:srgbClr val="2F8F4C"/>
-              </a:solidFill>
-              <a:ln w="9525" cap="flat">
-                <a:solidFill>
-                  <a:srgbClr val="2F8F4C"/>
-                </a:solidFill>
-                <a:prstDash val="solid"/>
-                <a:round/>
-              </a:ln>
-              <a:effectLst/>
-            </c:spPr>
-          </c:marker>
-          <c:cat>
-            <c:multiLvlStrRef>
-              <c:f>Sheet1!$A$2:$A$27</c:f>
-              <c:multiLvlStrCache>
-                <c:ptCount val="26"/>
-                <c:lvl>
-                  <c:pt idx="0">
-                    <c:v>2000</c:v>
-                  </c:pt>
-                  <c:pt idx="1">
-                    <c:v>2001</c:v>
-                  </c:pt>
-                  <c:pt idx="2">
-                    <c:v>2002</c:v>
-                  </c:pt>
-                  <c:pt idx="3">
-                    <c:v>2003</c:v>
-                  </c:pt>
-                  <c:pt idx="4">
-                    <c:v>2004</c:v>
-                  </c:pt>
-                  <c:pt idx="5">
-                    <c:v>2005</c:v>
-                  </c:pt>
-                  <c:pt idx="6">
-                    <c:v>2006</c:v>
-                  </c:pt>
-                  <c:pt idx="7">
-                    <c:v>2007</c:v>
-                  </c:pt>
-                  <c:pt idx="8">
-                    <c:v>2008</c:v>
-                  </c:pt>
-                  <c:pt idx="9">
-                    <c:v>2009</c:v>
-                  </c:pt>
-                  <c:pt idx="10">
-                    <c:v>2010</c:v>
-                  </c:pt>
-                  <c:pt idx="11">
-                    <c:v>2011</c:v>
-                  </c:pt>
-                  <c:pt idx="12">
-                    <c:v>2012</c:v>
-                  </c:pt>
-                  <c:pt idx="13">
-                    <c:v>2013</c:v>
-                  </c:pt>
-                  <c:pt idx="14">
-                    <c:v>2014</c:v>
-                  </c:pt>
-                  <c:pt idx="15">
-                    <c:v>2015</c:v>
-                  </c:pt>
-                  <c:pt idx="16">
-                    <c:v>2016</c:v>
-                  </c:pt>
-                  <c:pt idx="17">
-                    <c:v>2017</c:v>
-                  </c:pt>
-                  <c:pt idx="18">
-                    <c:v>2018</c:v>
-                  </c:pt>
-                  <c:pt idx="19">
-                    <c:v>2019</c:v>
-                  </c:pt>
-                  <c:pt idx="20">
-                    <c:v>2020</c:v>
-                  </c:pt>
-                  <c:pt idx="21">
-                    <c:v>2021</c:v>
-                  </c:pt>
-                  <c:pt idx="22">
-                    <c:v>2022</c:v>
-                  </c:pt>
-                  <c:pt idx="23">
-                    <c:v>2023</c:v>
-                  </c:pt>
-                  <c:pt idx="24">
-                    <c:v>2024</c:v>
-                  </c:pt>
-                  <c:pt idx="25">
-                    <c:v>2025</c:v>
-                  </c:pt>
-                </c:lvl>
-              </c:multiLvlStrCache>
-            </c:multiLvlStrRef>
-          </c:cat>
-          <c:val>
-            <c:numRef>
-              <c:f>Sheet1!$D$2:$D$27</c:f>
-              <c:numCache>
-                <c:formatCode>General</c:formatCode>
-                <c:ptCount val="26"/>
-                <c:pt idx="0">
-                  <c:v>110</c:v>
-                </c:pt>
-                <c:pt idx="1">
-                  <c:v>107</c:v>
-                </c:pt>
-                <c:pt idx="2">
-                  <c:v>108</c:v>
-                </c:pt>
-                <c:pt idx="3">
-                  <c:v>110</c:v>
-                </c:pt>
-                <c:pt idx="4">
-                  <c:v>107</c:v>
-                </c:pt>
-                <c:pt idx="5">
-                  <c:v>105</c:v>
-                </c:pt>
-                <c:pt idx="6">
-                  <c:v>102</c:v>
-                </c:pt>
-                <c:pt idx="7">
-                  <c:v>100</c:v>
-                </c:pt>
-                <c:pt idx="8">
-                  <c:v>97</c:v>
-                </c:pt>
-                <c:pt idx="9">
-                  <c:v>88</c:v>
-                </c:pt>
-                <c:pt idx="10">
-                  <c:v>82</c:v>
-                </c:pt>
-                <c:pt idx="11">
-                  <c:v>77</c:v>
-                </c:pt>
-                <c:pt idx="12">
-                  <c:v>73</c:v>
-                </c:pt>
-                <c:pt idx="13">
-                  <c:v>68</c:v>
-                </c:pt>
-                <c:pt idx="14">
-                  <c:v>68</c:v>
-                </c:pt>
-                <c:pt idx="15">
-                  <c:v>66</c:v>
-                </c:pt>
-                <c:pt idx="16">
-                  <c:v>68</c:v>
-                </c:pt>
-                <c:pt idx="17">
-                  <c:v>70</c:v>
-                </c:pt>
-                <c:pt idx="18">
-                  <c:v>72</c:v>
-                </c:pt>
-                <c:pt idx="19">
-                  <c:v>76</c:v>
-                </c:pt>
-                <c:pt idx="20">
-                  <c:v>68</c:v>
-                </c:pt>
-                <c:pt idx="21">
-                  <c:v>72</c:v>
-                </c:pt>
-                <c:pt idx="22">
-                  <c:v>69</c:v>
-                </c:pt>
-                <c:pt idx="23">
-                  <c:v>71</c:v>
-                </c:pt>
-                <c:pt idx="24">
-                  <c:v>74.5</c:v>
-                </c:pt>
-                <c:pt idx="25">
-                  <c:v>71.5</c:v>
-                </c:pt>
-              </c:numCache>
-            </c:numRef>
-          </c:val>
-          <c:smooth val="0"/>
-        </c:ser>
-        <c:dLbls>
-          <c:numFmt formatCode="#,##0" sourceLinked="0"/>
-          <c:txPr>
-            <a:bodyPr/>
-            <a:lstStyle/>
-            <a:p>
-              <a:pPr>
-                <a:defRPr b="0" i="0" strike="noStrike" sz="1200" u="none">
-                  <a:solidFill>
-                    <a:srgbClr val="000000"/>
-                  </a:solidFill>
-                  <a:latin typeface="Arial"/>
-                </a:defRPr>
-              </a:pPr>
-            </a:p>
-          </c:txPr>
-          <c:showLegendKey val="0"/>
-          <c:showVal val="0"/>
-          <c:showCatName val="0"/>
-          <c:showSerName val="0"/>
-          <c:showPercent val="0"/>
-          <c:showBubbleSize val="0"/>
-          <c:showLeaderLines val="0"/>
-        </c:dLbls>
-        <c:marker val="1"/>
-        <c:axId val="2094734554"/>
-        <c:axId val="2094734552"/>
-        <c:axId val="2094734556"/>
-      </c:lineChart>
-      <c:catAx>
-        <c:axId val="2094734554"/>
-        <c:scaling>
-          <c:orientation val="minMax"/>
-        </c:scaling>
-        <c:delete val="0"/>
-        <c:axPos val="b"/>
-        <c:numFmt formatCode="General" sourceLinked="1"/>
-        <c:majorTickMark val="out"/>
-        <c:minorTickMark val="none"/>
-        <c:tickLblPos val="low"/>
-        <c:spPr>
-          <a:ln w="12700" cap="flat">
-            <a:solidFill>
-              <a:srgbClr val="888888"/>
-            </a:solidFill>
-            <a:prstDash val="solid"/>
-            <a:round/>
-          </a:ln>
-        </c:spPr>
-        <c:txPr>
-          <a:bodyPr rot="-2700000"/>
-          <a:lstStyle/>
-          <a:p>
-            <a:pPr>
-              <a:defRPr sz="900" b="0" i="0" u="none" strike="noStrike">
-                <a:solidFill>
-                  <a:srgbClr val="5B6483"/>
-                </a:solidFill>
-                <a:latin typeface="Calibri"/>
-              </a:defRPr>
-            </a:pPr>
-            <a:endParaRPr lang="en-US"/>
-          </a:p>
-        </c:txPr>
-        <c:crossAx val="2094734552"/>
-        <c:crosses val="autoZero"/>
-        <c:auto val="1"/>
-        <c:lblAlgn val="ctr"/>
-        <c:noMultiLvlLbl val="1"/>
-      </c:catAx>
-      <c:valAx>
-        <c:axId val="2094734552"/>
-        <c:scaling>
-          <c:orientation val="minMax"/>
-          <c:max val="115"/>
-          <c:min val="60"/>
-        </c:scaling>
-        <c:delete val="0"/>
-        <c:axPos val="l"/>
-        <c:majorGridlines>
-          <c:spPr>
-            <a:ln w="6350" cap="flat">
-              <a:solidFill>
-                <a:srgbClr val="D7DBE8"/>
-              </a:solidFill>
-              <a:prstDash val="solid"/>
-              <a:round/>
-            </a:ln>
-          </c:spPr>
-        </c:majorGridlines>
-        <c:title>
-          <c:tx>
-            <c:rich>
-              <a:bodyPr/>
-              <a:lstStyle/>
-              <a:p>
-                <a:pPr>
-                  <a:defRPr sz="1000" b="0" i="0" u="none" strike="noStrike">
-                    <a:solidFill>
-                      <a:srgbClr val="5B6483"/>
-                    </a:solidFill>
-                    <a:latin typeface="Arial"/>
-                  </a:defRPr>
-                </a:pPr>
-                <a:r>
-                  <a:rPr sz="1000" b="0" i="0" u="none" strike="noStrike">
-                    <a:solidFill>
-                      <a:srgbClr val="5B6483"/>
-                    </a:solidFill>
-                    <a:latin typeface="Arial"/>
-                  </a:rPr>
-                  <a:t>Severity Index Value</a:t>
-                </a:r>
-              </a:p>
-            </c:rich>
-          </c:tx>
-          <c:layout/>
-          <c:overlay val="0"/>
-        </c:title>
-        <c:numFmt formatCode="General" sourceLinked="0"/>
-        <c:majorTickMark val="out"/>
-        <c:minorTickMark val="none"/>
-        <c:tickLblPos val="nextTo"/>
-        <c:spPr>
-          <a:ln w="12700" cap="flat">
-            <a:solidFill>
-              <a:srgbClr val="888888"/>
-            </a:solidFill>
-            <a:prstDash val="solid"/>
-            <a:round/>
-          </a:ln>
-        </c:spPr>
-        <c:txPr>
-          <a:bodyPr/>
-          <a:lstStyle/>
-          <a:p>
-            <a:pPr>
-              <a:defRPr sz="900" b="0" i="0" u="none" strike="noStrike">
-                <a:solidFill>
-                  <a:srgbClr val="5B6483"/>
-                </a:solidFill>
-                <a:latin typeface="Calibri"/>
-              </a:defRPr>
-            </a:pPr>
-            <a:endParaRPr lang="en-US"/>
-          </a:p>
-        </c:txPr>
-        <c:crossAx val="2094734554"/>
-        <c:crosses val="autoZero"/>
-        <c:crossBetween val="between"/>
-      </c:valAx>
-      <c:spPr>
-        <a:noFill/>
-        <a:ln>
-          <a:noFill/>
-        </a:ln>
-        <a:effectLst/>
-      </c:spPr>
-    </c:plotArea>
-    <c:legend>
-      <c:legendPos val="t"/>
-      <c:overlay val="0"/>
-      <c:txPr>
-        <a:bodyPr/>
-        <a:lstStyle/>
-        <a:p>
-          <a:pPr>
-            <a:defRPr sz="900">
-              <a:solidFill>
-                <a:srgbClr val="0F1A3D"/>
-              </a:solidFill>
-            </a:defRPr>
-          </a:pPr>
-          <a:endParaRPr lang="en-US"/>
-        </a:p>
-      </c:txPr>
-    </c:legend>
-    <c:plotVisOnly val="1"/>
-    <c:dispBlanksAs val="span"/>
-  </c:chart>
-  <c:spPr>
-    <a:noFill/>
-    <a:ln>
-      <a:noFill/>
-    </a:ln>
-    <a:effectLst/>
-  </c:spPr>
-  <c:externalData r:id="rId1">
-    <c:autoUpdate val="0"/>
-  </c:externalData>
-</c:chartSpace>
-</file>
-
-<file path=ppt/charts/chart2.xml><?xml version="1.0" encoding="utf-8"?>
-<c:chartSpace xmlns:c="http://schemas.openxmlformats.org/drawingml/2006/chart" xmlns:a="http://schemas.openxmlformats.org/drawingml/2006/main" xmlns:r="http://schemas.openxmlformats.org/officeDocument/2006/relationships">
-  <c:date1904 val="0"/>
-  <c:roundedCorners val="1"/>
-  <c:chart>
-    <c:title>
-      <c:tx>
-        <c:rich>
-          <a:bodyPr/>
-          <a:lstStyle/>
-          <a:p>
-            <a:pPr>
-              <a:defRPr sz="1200" b="0" i="0" u="none" strike="noStrike">
-                <a:solidFill>
-                  <a:srgbClr val="0F1A3D"/>
-                </a:solidFill>
-                <a:latin typeface="Calibri"/>
-              </a:defRPr>
-            </a:pPr>
-            <a:r>
-              <a:rPr sz="1200" b="0" i="0" u="none" strike="noStrike">
-                <a:solidFill>
-                  <a:srgbClr val="0F1A3D"/>
-                </a:solidFill>
-                <a:latin typeface="Calibri"/>
-              </a:rPr>
-              <a:t>Total Cyber-related Violations in Canada (2014–2025)</a:t>
-            </a:r>
-          </a:p>
-        </c:rich>
-      </c:tx>
-      <c:layout/>
-      <c:overlay val="0"/>
-    </c:title>
-    <c:autoTitleDeleted val="0"/>
-    <c:plotArea>
-      <c:layout/>
-      <c:lineChart>
-        <c:varyColors val="0"/>
-        <c:ser>
-          <c:idx val="0"/>
-          <c:order val="0"/>
-          <c:tx>
-            <c:strRef>
-              <c:f>Sheet1!$B$1</c:f>
-              <c:strCache>
-                <c:ptCount val="1"/>
-                <c:pt idx="0">
-                  <c:v>Cyber-related violations</c:v>
-                </c:pt>
-              </c:strCache>
-            </c:strRef>
-          </c:tx>
-          <c:spPr>
-            <a:solidFill>
-              <a:srgbClr val="3771C8"/>
-            </a:solidFill>
-            <a:ln w="31750" cap="flat">
-              <a:solidFill>
-                <a:srgbClr val="3771C8"/>
-              </a:solidFill>
-              <a:prstDash val="solid"/>
-              <a:round/>
-            </a:ln>
-            <a:effectLst/>
-          </c:spPr>
-          <c:invertIfNegative val="0"/>
-          <c:dLbls>
-            <c:numFmt formatCode="#,##0" sourceLinked="0"/>
-            <c:txPr>
-              <a:bodyPr/>
-              <a:lstStyle/>
-              <a:p>
-                <a:pPr>
-                  <a:defRPr b="0" i="0" strike="noStrike" sz="800" u="none">
-                    <a:solidFill>
-                      <a:srgbClr val="0F1A3D"/>
-                    </a:solidFill>
-                    <a:latin typeface="Calibri"/>
-                  </a:defRPr>
-                </a:pPr>
-              </a:p>
-            </c:txPr>
-            <c:dLblPos val="t"/>
-            <c:showLegendKey val="0"/>
-            <c:showVal val="1"/>
-            <c:showCatName val="0"/>
-            <c:showSerName val="0"/>
-            <c:showPercent val="0"/>
-            <c:showBubbleSize val="0"/>
-            <c:showLeaderLines val="0"/>
-          </c:dLbls>
-          <c:marker>
-            <c:symbol val="circle"/>
-            <c:size val="6"/>
-            <c:spPr>
-              <a:solidFill>
-                <a:srgbClr val="3771C8"/>
-              </a:solidFill>
-              <a:ln w="9525" cap="flat">
-                <a:solidFill>
-                  <a:srgbClr val="3771C8"/>
-                </a:solidFill>
-                <a:prstDash val="solid"/>
-                <a:round/>
-              </a:ln>
-              <a:effectLst/>
-            </c:spPr>
-          </c:marker>
-          <c:cat>
-            <c:multiLvlStrRef>
-              <c:f>Sheet1!$A$2:$A$13</c:f>
-              <c:multiLvlStrCache>
-                <c:ptCount val="12"/>
-                <c:lvl>
-                  <c:pt idx="0">
-                    <c:v>2014</c:v>
-                  </c:pt>
-                  <c:pt idx="1">
-                    <c:v>2015</c:v>
-                  </c:pt>
-                  <c:pt idx="2">
-                    <c:v>2016</c:v>
-                  </c:pt>
-                  <c:pt idx="3">
-                    <c:v>2017</c:v>
-                  </c:pt>
-                  <c:pt idx="4">
-                    <c:v>2018</c:v>
-                  </c:pt>
-                  <c:pt idx="5">
-                    <c:v>2019</c:v>
-                  </c:pt>
-                  <c:pt idx="6">
-                    <c:v>2020</c:v>
-                  </c:pt>
-                  <c:pt idx="7">
-                    <c:v>2021</c:v>
-                  </c:pt>
-                  <c:pt idx="8">
-                    <c:v>2022</c:v>
-                  </c:pt>
-                  <c:pt idx="9">
-                    <c:v>2023</c:v>
-                  </c:pt>
-                  <c:pt idx="10">
-                    <c:v>2024</c:v>
-                  </c:pt>
-                  <c:pt idx="11">
-                    <c:v>2025</c:v>
-                  </c:pt>
-                </c:lvl>
-              </c:multiLvlStrCache>
-            </c:multiLvlStrRef>
-          </c:cat>
-          <c:val>
-            <c:numRef>
-              <c:f>Sheet1!$B$2:$B$13</c:f>
-              <c:numCache>
-                <c:formatCode>General</c:formatCode>
-                <c:ptCount val="12"/>
-                <c:pt idx="0">
-                  <c:v>15184</c:v>
-                </c:pt>
-                <c:pt idx="1">
-                  <c:v>17887</c:v>
-                </c:pt>
-                <c:pt idx="2">
-                  <c:v>23996</c:v>
-                </c:pt>
-                <c:pt idx="3">
-                  <c:v>27829</c:v>
-                </c:pt>
-                <c:pt idx="4">
-                  <c:v>33893</c:v>
-                </c:pt>
-                <c:pt idx="5">
-                  <c:v>44000</c:v>
-                </c:pt>
-                <c:pt idx="6">
-                  <c:v>63500</c:v>
-                </c:pt>
-                <c:pt idx="7">
-                  <c:v>74000</c:v>
-                </c:pt>
-                <c:pt idx="8">
-                  <c:v>92000</c:v>
-                </c:pt>
-                <c:pt idx="9">
-                  <c:v>99000</c:v>
-                </c:pt>
-                <c:pt idx="10">
-                  <c:v>94000</c:v>
-                </c:pt>
-                <c:pt idx="11">
-                  <c:v>90643</c:v>
-                </c:pt>
-              </c:numCache>
-            </c:numRef>
-          </c:val>
-          <c:smooth val="0"/>
-        </c:ser>
-        <c:dLbls>
-          <c:numFmt formatCode="#,##0" sourceLinked="0"/>
-          <c:txPr>
-            <a:bodyPr/>
-            <a:lstStyle/>
-            <a:p>
-              <a:pPr>
-                <a:defRPr b="0" i="0" strike="noStrike" sz="800" u="none">
-                  <a:solidFill>
-                    <a:srgbClr val="0F1A3D"/>
-                  </a:solidFill>
-                  <a:latin typeface="Calibri"/>
-                </a:defRPr>
-              </a:pPr>
-            </a:p>
-          </c:txPr>
-          <c:dLblPos val="t"/>
-          <c:showLegendKey val="0"/>
-          <c:showVal val="1"/>
-          <c:showCatName val="0"/>
-          <c:showSerName val="0"/>
-          <c:showPercent val="0"/>
-          <c:showBubbleSize val="0"/>
-          <c:showLeaderLines val="0"/>
-        </c:dLbls>
-        <c:marker val="1"/>
-        <c:axId val="2094734554"/>
-        <c:axId val="2094734552"/>
-        <c:axId val="2094734556"/>
-      </c:lineChart>
-      <c:catAx>
-        <c:axId val="2094734554"/>
-        <c:scaling>
-          <c:orientation val="minMax"/>
-        </c:scaling>
-        <c:delete val="0"/>
-        <c:axPos val="b"/>
-        <c:numFmt formatCode="General" sourceLinked="1"/>
-        <c:majorTickMark val="out"/>
-        <c:minorTickMark val="none"/>
-        <c:tickLblPos val="low"/>
-        <c:spPr>
-          <a:ln w="12700" cap="flat">
-            <a:solidFill>
-              <a:srgbClr val="888888"/>
-            </a:solidFill>
-            <a:prstDash val="solid"/>
-            <a:round/>
-          </a:ln>
-        </c:spPr>
-        <c:txPr>
-          <a:bodyPr/>
-          <a:lstStyle/>
-          <a:p>
-            <a:pPr>
-              <a:defRPr sz="1000" b="0" i="0" u="none" strike="noStrike">
-                <a:solidFill>
-                  <a:srgbClr val="5B6483"/>
-                </a:solidFill>
-                <a:latin typeface="Calibri"/>
-              </a:defRPr>
-            </a:pPr>
-            <a:endParaRPr lang="en-US"/>
-          </a:p>
-        </c:txPr>
-        <c:crossAx val="2094734552"/>
-        <c:crosses val="autoZero"/>
-        <c:auto val="1"/>
-        <c:lblAlgn val="ctr"/>
-        <c:noMultiLvlLbl val="1"/>
-      </c:catAx>
-      <c:valAx>
-        <c:axId val="2094734552"/>
-        <c:scaling>
-          <c:orientation val="minMax"/>
-          <c:max val="110000"/>
-          <c:min val="0"/>
-        </c:scaling>
-        <c:delete val="0"/>
-        <c:axPos val="l"/>
-        <c:majorGridlines>
-          <c:spPr>
-            <a:ln w="6350" cap="flat">
-              <a:solidFill>
-                <a:srgbClr val="D7DBE8"/>
-              </a:solidFill>
-              <a:prstDash val="solid"/>
-              <a:round/>
-            </a:ln>
-          </c:spPr>
-        </c:majorGridlines>
-        <c:title>
-          <c:tx>
-            <c:rich>
-              <a:bodyPr/>
-              <a:lstStyle/>
-              <a:p>
-                <a:pPr>
-                  <a:defRPr sz="1000" b="0" i="0" u="none" strike="noStrike">
-                    <a:solidFill>
-                      <a:srgbClr val="5B6483"/>
-                    </a:solidFill>
-                    <a:latin typeface="Arial"/>
-                  </a:defRPr>
-                </a:pPr>
-                <a:r>
-                  <a:rPr sz="1000" b="0" i="0" u="none" strike="noStrike">
-                    <a:solidFill>
-                      <a:srgbClr val="5B6483"/>
-                    </a:solidFill>
-                    <a:latin typeface="Arial"/>
-                  </a:rPr>
-                  <a:t>Number of Violations</a:t>
-                </a:r>
-              </a:p>
-            </c:rich>
-          </c:tx>
-          <c:layout/>
-          <c:overlay val="0"/>
-        </c:title>
-        <c:numFmt formatCode="General" sourceLinked="0"/>
-        <c:majorTickMark val="out"/>
-        <c:minorTickMark val="none"/>
-        <c:tickLblPos val="nextTo"/>
-        <c:spPr>
-          <a:ln w="12700" cap="flat">
-            <a:solidFill>
-              <a:srgbClr val="888888"/>
-            </a:solidFill>
-            <a:prstDash val="solid"/>
-            <a:round/>
-          </a:ln>
-        </c:spPr>
-        <c:txPr>
-          <a:bodyPr/>
-          <a:lstStyle/>
-          <a:p>
-            <a:pPr>
-              <a:defRPr sz="1000" b="0" i="0" u="none" strike="noStrike">
-                <a:solidFill>
-                  <a:srgbClr val="5B6483"/>
-                </a:solidFill>
-                <a:latin typeface="Calibri"/>
-              </a:defRPr>
-            </a:pPr>
-            <a:endParaRPr lang="en-US"/>
-          </a:p>
-        </c:txPr>
-        <c:crossAx val="2094734554"/>
-        <c:crosses val="autoZero"/>
-        <c:crossBetween val="between"/>
-      </c:valAx>
-      <c:spPr>
-        <a:noFill/>
-        <a:ln>
-          <a:noFill/>
-        </a:ln>
-        <a:effectLst/>
-      </c:spPr>
-    </c:plotArea>
-    <c:plotVisOnly val="1"/>
-    <c:dispBlanksAs val="span"/>
-  </c:chart>
-  <c:spPr>
-    <a:noFill/>
-    <a:ln>
-      <a:noFill/>
-    </a:ln>
-    <a:effectLst/>
-  </c:spPr>
-  <c:externalData r:id="rId1">
-    <c:autoUpdate val="0"/>
-  </c:externalData>
-</c:chartSpace>
-</file>
-
-<file path=ppt/charts/chart3.xml><?xml version="1.0" encoding="utf-8"?>
-<c:chartSpace xmlns:c="http://schemas.openxmlformats.org/drawingml/2006/chart" xmlns:a="http://schemas.openxmlformats.org/drawingml/2006/main" xmlns:r="http://schemas.openxmlformats.org/officeDocument/2006/relationships">
-  <c:date1904 val="0"/>
-  <c:roundedCorners val="1"/>
-  <c:chart>
-    <c:title>
-      <c:tx>
-        <c:rich>
-          <a:bodyPr/>
-          <a:lstStyle/>
-          <a:p>
-            <a:pPr>
-              <a:defRPr sz="1200" b="0" i="0" u="none" strike="noStrike">
-                <a:solidFill>
-                  <a:srgbClr val="0F1A3D"/>
-                </a:solidFill>
-                <a:latin typeface="Calibri"/>
-              </a:defRPr>
-            </a:pPr>
-            <a:r>
-              <a:rPr sz="1200" b="0" i="0" u="none" strike="noStrike">
-                <a:solidFill>
-                  <a:srgbClr val="0F1A3D"/>
-                </a:solidFill>
-                <a:latin typeface="Calibri"/>
-              </a:rPr>
-              <a:t>Weighted Clearance Rates in Canada (2000–2025)</a:t>
-            </a:r>
-          </a:p>
-        </c:rich>
-      </c:tx>
-      <c:layout/>
-      <c:overlay val="0"/>
-    </c:title>
-    <c:autoTitleDeleted val="0"/>
-    <c:plotArea>
-      <c:layout/>
-      <c:lineChart>
-        <c:varyColors val="0"/>
-        <c:ser>
-          <c:idx val="0"/>
-          <c:order val="0"/>
-          <c:tx>
-            <c:strRef>
-              <c:f>Sheet1!$B$1</c:f>
-              <c:strCache>
-                <c:ptCount val="1"/>
-                <c:pt idx="0">
-                  <c:v>Weighted clearance rate</c:v>
-                </c:pt>
-              </c:strCache>
-            </c:strRef>
-          </c:tx>
-          <c:spPr>
-            <a:solidFill>
-              <a:srgbClr val="3771C8"/>
-            </a:solidFill>
-            <a:ln w="25400" cap="flat">
-              <a:solidFill>
-                <a:srgbClr val="3771C8"/>
-              </a:solidFill>
-              <a:prstDash val="solid"/>
-              <a:round/>
-            </a:ln>
-            <a:effectLst/>
-          </c:spPr>
-          <c:invertIfNegative val="0"/>
-          <c:dLbls>
-            <c:numFmt formatCode="#,##0" sourceLinked="0"/>
-            <c:txPr>
-              <a:bodyPr/>
-              <a:lstStyle/>
-              <a:p>
-                <a:pPr>
-                  <a:defRPr b="0" i="0" strike="noStrike" sz="1200" u="none">
-                    <a:solidFill>
-                      <a:srgbClr val="000000"/>
-                    </a:solidFill>
-                    <a:latin typeface="Arial"/>
-                  </a:defRPr>
-                </a:pPr>
-              </a:p>
-            </c:txPr>
-            <c:showLegendKey val="0"/>
-            <c:showVal val="0"/>
-            <c:showCatName val="0"/>
-            <c:showSerName val="0"/>
-            <c:showPercent val="0"/>
-            <c:showBubbleSize val="0"/>
-            <c:showLeaderLines val="0"/>
-          </c:dLbls>
-          <c:marker>
-            <c:symbol val="none"/>
-            <c:size val="6"/>
-            <c:spPr>
-              <a:solidFill>
-                <a:srgbClr val="3771C8"/>
-              </a:solidFill>
-              <a:ln w="9525" cap="flat">
-                <a:solidFill>
-                  <a:srgbClr val="3771C8"/>
-                </a:solidFill>
-                <a:prstDash val="solid"/>
-                <a:round/>
-              </a:ln>
-              <a:effectLst/>
-            </c:spPr>
-          </c:marker>
-          <c:cat>
-            <c:multiLvlStrRef>
-              <c:f>Sheet1!$A$2:$A$27</c:f>
-              <c:multiLvlStrCache>
-                <c:ptCount val="26"/>
-                <c:lvl>
-                  <c:pt idx="0">
-                    <c:v>2000</c:v>
-                  </c:pt>
-                  <c:pt idx="1">
-                    <c:v>2001</c:v>
-                  </c:pt>
-                  <c:pt idx="2">
-                    <c:v>2002</c:v>
-                  </c:pt>
-                  <c:pt idx="3">
-                    <c:v>2003</c:v>
-                  </c:pt>
-                  <c:pt idx="4">
-                    <c:v>2004</c:v>
-                  </c:pt>
-                  <c:pt idx="5">
-                    <c:v>2005</c:v>
-                  </c:pt>
-                  <c:pt idx="6">
-                    <c:v>2006</c:v>
-                  </c:pt>
-                  <c:pt idx="7">
-                    <c:v>2007</c:v>
-                  </c:pt>
-                  <c:pt idx="8">
-                    <c:v>2008</c:v>
-                  </c:pt>
-                  <c:pt idx="9">
-                    <c:v>2009</c:v>
-                  </c:pt>
-                  <c:pt idx="10">
-                    <c:v>2010</c:v>
-                  </c:pt>
-                  <c:pt idx="11">
-                    <c:v>2011</c:v>
-                  </c:pt>
-                  <c:pt idx="12">
-                    <c:v>2012</c:v>
-                  </c:pt>
-                  <c:pt idx="13">
-                    <c:v>2013</c:v>
-                  </c:pt>
-                  <c:pt idx="14">
-                    <c:v>2014</c:v>
-                  </c:pt>
-                  <c:pt idx="15">
-                    <c:v>2015</c:v>
-                  </c:pt>
-                  <c:pt idx="16">
-                    <c:v>2016</c:v>
-                  </c:pt>
-                  <c:pt idx="17">
-                    <c:v>2017</c:v>
-                  </c:pt>
-                  <c:pt idx="18">
-                    <c:v>2018</c:v>
-                  </c:pt>
-                  <c:pt idx="19">
-                    <c:v>2019</c:v>
-                  </c:pt>
-                  <c:pt idx="20">
-                    <c:v>2020</c:v>
-                  </c:pt>
-                  <c:pt idx="21">
-                    <c:v>2021</c:v>
-                  </c:pt>
-                  <c:pt idx="22">
-                    <c:v>2022</c:v>
-                  </c:pt>
-                  <c:pt idx="23">
-                    <c:v>2023</c:v>
-                  </c:pt>
-                  <c:pt idx="24">
-                    <c:v>2024</c:v>
-                  </c:pt>
-                  <c:pt idx="25">
-                    <c:v>2025</c:v>
-                  </c:pt>
-                </c:lvl>
-              </c:multiLvlStrCache>
-            </c:multiLvlStrRef>
-          </c:cat>
-          <c:val>
-            <c:numRef>
-              <c:f>Sheet1!$B$2:$B$27</c:f>
-              <c:numCache>
-                <c:formatCode>General</c:formatCode>
-                <c:ptCount val="26"/>
-                <c:pt idx="0">
-                  <c:v>35.51</c:v>
-                </c:pt>
-                <c:pt idx="1">
-                  <c:v>34.98</c:v>
-                </c:pt>
-                <c:pt idx="2">
-                  <c:v>34.53</c:v>
-                </c:pt>
-                <c:pt idx="3">
-                  <c:v>33.54</c:v>
-                </c:pt>
-                <c:pt idx="4">
-                  <c:v>33.58</c:v>
-                </c:pt>
-                <c:pt idx="5">
-                  <c:v>33.9</c:v>
-                </c:pt>
-                <c:pt idx="6">
-                  <c:v>34.2</c:v>
-                </c:pt>
-                <c:pt idx="7">
-                  <c:v>34.8</c:v>
-                </c:pt>
-                <c:pt idx="8">
-                  <c:v>35.2</c:v>
-                </c:pt>
-                <c:pt idx="9">
-                  <c:v>35.4</c:v>
-                </c:pt>
-                <c:pt idx="10">
-                  <c:v>35.6</c:v>
-                </c:pt>
-                <c:pt idx="11">
-                  <c:v>35.4</c:v>
-                </c:pt>
-                <c:pt idx="12">
-                  <c:v>34.9</c:v>
-                </c:pt>
-                <c:pt idx="13">
-                  <c:v>34.4</c:v>
-                </c:pt>
-                <c:pt idx="14">
-                  <c:v>34</c:v>
-                </c:pt>
-                <c:pt idx="15">
-                  <c:v>33.5</c:v>
-                </c:pt>
-                <c:pt idx="16">
-                  <c:v>33</c:v>
-                </c:pt>
-                <c:pt idx="17">
-                  <c:v>32.7</c:v>
-                </c:pt>
-                <c:pt idx="18">
-                  <c:v>32.5</c:v>
-                </c:pt>
-                <c:pt idx="19">
-                  <c:v>33.5</c:v>
-                </c:pt>
-                <c:pt idx="20">
-                  <c:v>34.6</c:v>
-                </c:pt>
-                <c:pt idx="21">
-                  <c:v>34.3</c:v>
-                </c:pt>
-                <c:pt idx="22">
-                  <c:v>34.5</c:v>
-                </c:pt>
-                <c:pt idx="23">
-                  <c:v>34.85</c:v>
-                </c:pt>
-                <c:pt idx="24">
-                  <c:v>35.8</c:v>
-                </c:pt>
-                <c:pt idx="25">
-                  <c:v>36.64</c:v>
-                </c:pt>
-              </c:numCache>
-            </c:numRef>
-          </c:val>
-          <c:smooth val="0"/>
-        </c:ser>
-        <c:ser>
-          <c:idx val="1"/>
-          <c:order val="1"/>
-          <c:tx>
-            <c:strRef>
-              <c:f>Sheet1!$C$1</c:f>
-              <c:strCache>
-                <c:ptCount val="1"/>
-                <c:pt idx="0">
-                  <c:v>Violent weighted clearance rate</c:v>
-                </c:pt>
-              </c:strCache>
-            </c:strRef>
-          </c:tx>
-          <c:spPr>
-            <a:solidFill>
-              <a:srgbClr val="E08A1E"/>
-            </a:solidFill>
-            <a:ln w="25400" cap="flat">
-              <a:solidFill>
-                <a:srgbClr val="E08A1E"/>
-              </a:solidFill>
-              <a:prstDash val="solid"/>
-              <a:round/>
-            </a:ln>
-            <a:effectLst/>
-          </c:spPr>
-          <c:invertIfNegative val="0"/>
-          <c:dLbls>
-            <c:numFmt formatCode="#,##0" sourceLinked="0"/>
-            <c:txPr>
-              <a:bodyPr/>
-              <a:lstStyle/>
-              <a:p>
-                <a:pPr>
-                  <a:defRPr b="0" i="0" strike="noStrike" sz="1200" u="none">
-                    <a:solidFill>
-                      <a:srgbClr val="000000"/>
-                    </a:solidFill>
-                    <a:latin typeface="Arial"/>
-                  </a:defRPr>
-                </a:pPr>
-              </a:p>
-            </c:txPr>
-            <c:showLegendKey val="0"/>
-            <c:showVal val="0"/>
-            <c:showCatName val="0"/>
-            <c:showSerName val="0"/>
-            <c:showPercent val="0"/>
-            <c:showBubbleSize val="0"/>
-            <c:showLeaderLines val="0"/>
-          </c:dLbls>
-          <c:marker>
-            <c:symbol val="none"/>
-            <c:size val="6"/>
-            <c:spPr>
-              <a:solidFill>
-                <a:srgbClr val="E08A1E"/>
-              </a:solidFill>
-              <a:ln w="9525" cap="flat">
-                <a:solidFill>
-                  <a:srgbClr val="E08A1E"/>
-                </a:solidFill>
-                <a:prstDash val="solid"/>
-                <a:round/>
-              </a:ln>
-              <a:effectLst/>
-            </c:spPr>
-          </c:marker>
-          <c:cat>
-            <c:multiLvlStrRef>
-              <c:f>Sheet1!$A$2:$A$27</c:f>
-              <c:multiLvlStrCache>
-                <c:ptCount val="26"/>
-                <c:lvl>
-                  <c:pt idx="0">
-                    <c:v>2000</c:v>
-                  </c:pt>
-                  <c:pt idx="1">
-                    <c:v>2001</c:v>
-                  </c:pt>
-                  <c:pt idx="2">
-                    <c:v>2002</c:v>
-                  </c:pt>
-                  <c:pt idx="3">
-                    <c:v>2003</c:v>
-                  </c:pt>
-                  <c:pt idx="4">
-                    <c:v>2004</c:v>
-                  </c:pt>
-                  <c:pt idx="5">
-                    <c:v>2005</c:v>
-                  </c:pt>
-                  <c:pt idx="6">
-                    <c:v>2006</c:v>
-                  </c:pt>
-                  <c:pt idx="7">
-                    <c:v>2007</c:v>
-                  </c:pt>
-                  <c:pt idx="8">
-                    <c:v>2008</c:v>
-                  </c:pt>
-                  <c:pt idx="9">
-                    <c:v>2009</c:v>
-                  </c:pt>
-                  <c:pt idx="10">
-                    <c:v>2010</c:v>
-                  </c:pt>
-                  <c:pt idx="11">
-                    <c:v>2011</c:v>
-                  </c:pt>
-                  <c:pt idx="12">
-                    <c:v>2012</c:v>
-                  </c:pt>
-                  <c:pt idx="13">
-                    <c:v>2013</c:v>
-                  </c:pt>
-                  <c:pt idx="14">
-                    <c:v>2014</c:v>
-                  </c:pt>
-                  <c:pt idx="15">
-                    <c:v>2015</c:v>
-                  </c:pt>
-                  <c:pt idx="16">
-                    <c:v>2016</c:v>
-                  </c:pt>
-                  <c:pt idx="17">
-                    <c:v>2017</c:v>
-                  </c:pt>
-                  <c:pt idx="18">
-                    <c:v>2018</c:v>
-                  </c:pt>
-                  <c:pt idx="19">
-                    <c:v>2019</c:v>
-                  </c:pt>
-                  <c:pt idx="20">
-                    <c:v>2020</c:v>
-                  </c:pt>
-                  <c:pt idx="21">
-                    <c:v>2021</c:v>
-                  </c:pt>
-                  <c:pt idx="22">
-                    <c:v>2022</c:v>
-                  </c:pt>
-                  <c:pt idx="23">
-                    <c:v>2023</c:v>
-                  </c:pt>
-                  <c:pt idx="24">
-                    <c:v>2024</c:v>
-                  </c:pt>
-                  <c:pt idx="25">
-                    <c:v>2025</c:v>
-                  </c:pt>
-                </c:lvl>
-              </c:multiLvlStrCache>
-            </c:multiLvlStrRef>
-          </c:cat>
-          <c:val>
-            <c:numRef>
-              <c:f>Sheet1!$C$2:$C$27</c:f>
-              <c:numCache>
-                <c:formatCode>General</c:formatCode>
-                <c:ptCount val="26"/>
-                <c:pt idx="0">
-                  <c:v>58.24</c:v>
-                </c:pt>
-                <c:pt idx="1">
-                  <c:v>58.64</c:v>
-                </c:pt>
-                <c:pt idx="2">
-                  <c:v>57.77</c:v>
-                </c:pt>
-                <c:pt idx="3">
-                  <c:v>56.44</c:v>
-                </c:pt>
-                <c:pt idx="4">
-                  <c:v>56.25</c:v>
-                </c:pt>
-                <c:pt idx="5">
-                  <c:v>56.4</c:v>
-                </c:pt>
-                <c:pt idx="6">
-                  <c:v>56.6</c:v>
-                </c:pt>
-                <c:pt idx="7">
-                  <c:v>56.9</c:v>
-                </c:pt>
-                <c:pt idx="8">
-                  <c:v>57</c:v>
-                </c:pt>
-                <c:pt idx="9">
-                  <c:v>56.8</c:v>
-                </c:pt>
-                <c:pt idx="10">
-                  <c:v>56.6</c:v>
-                </c:pt>
-                <c:pt idx="11">
-                  <c:v>56.1</c:v>
-                </c:pt>
-                <c:pt idx="12">
-                  <c:v>55.4</c:v>
-                </c:pt>
-                <c:pt idx="13">
-                  <c:v>55</c:v>
-                </c:pt>
-                <c:pt idx="14">
-                  <c:v>54.5</c:v>
-                </c:pt>
-                <c:pt idx="15">
-                  <c:v>53.8</c:v>
-                </c:pt>
-                <c:pt idx="16">
-                  <c:v>53.2</c:v>
-                </c:pt>
-                <c:pt idx="17">
-                  <c:v>52.8</c:v>
-                </c:pt>
-                <c:pt idx="18">
-                  <c:v>52.5</c:v>
-                </c:pt>
-                <c:pt idx="19">
-                  <c:v>53.2</c:v>
-                </c:pt>
-                <c:pt idx="20">
-                  <c:v>54</c:v>
-                </c:pt>
-                <c:pt idx="21">
-                  <c:v>53.6</c:v>
-                </c:pt>
-                <c:pt idx="22">
-                  <c:v>53.7</c:v>
-                </c:pt>
-                <c:pt idx="23">
-                  <c:v>54</c:v>
-                </c:pt>
-                <c:pt idx="24">
-                  <c:v>54.07</c:v>
-                </c:pt>
-                <c:pt idx="25">
-                  <c:v>54.46</c:v>
-                </c:pt>
-              </c:numCache>
-            </c:numRef>
-          </c:val>
-          <c:smooth val="0"/>
-        </c:ser>
-        <c:ser>
-          <c:idx val="2"/>
-          <c:order val="2"/>
-          <c:tx>
-            <c:strRef>
-              <c:f>Sheet1!$D$1</c:f>
-              <c:strCache>
-                <c:ptCount val="1"/>
-                <c:pt idx="0">
-                  <c:v>Non-violent weighted clearance rate</c:v>
-                </c:pt>
-              </c:strCache>
-            </c:strRef>
-          </c:tx>
-          <c:spPr>
-            <a:solidFill>
-              <a:srgbClr val="2F8F4C"/>
-            </a:solidFill>
-            <a:ln w="25400" cap="flat">
-              <a:solidFill>
-                <a:srgbClr val="2F8F4C"/>
-              </a:solidFill>
-              <a:prstDash val="solid"/>
-              <a:round/>
-            </a:ln>
-            <a:effectLst/>
-          </c:spPr>
-          <c:invertIfNegative val="0"/>
-          <c:dLbls>
-            <c:numFmt formatCode="#,##0" sourceLinked="0"/>
-            <c:txPr>
-              <a:bodyPr/>
-              <a:lstStyle/>
-              <a:p>
-                <a:pPr>
-                  <a:defRPr b="0" i="0" strike="noStrike" sz="1200" u="none">
-                    <a:solidFill>
-                      <a:srgbClr val="000000"/>
-                    </a:solidFill>
-                    <a:latin typeface="Arial"/>
-                  </a:defRPr>
-                </a:pPr>
-              </a:p>
-            </c:txPr>
-            <c:showLegendKey val="0"/>
-            <c:showVal val="0"/>
-            <c:showCatName val="0"/>
-            <c:showSerName val="0"/>
-            <c:showPercent val="0"/>
-            <c:showBubbleSize val="0"/>
-            <c:showLeaderLines val="0"/>
-          </c:dLbls>
-          <c:marker>
-            <c:symbol val="none"/>
-            <c:size val="6"/>
-            <c:spPr>
-              <a:solidFill>
-                <a:srgbClr val="2F8F4C"/>
-              </a:solidFill>
-              <a:ln w="9525" cap="flat">
-                <a:solidFill>
-                  <a:srgbClr val="2F8F4C"/>
-                </a:solidFill>
-                <a:prstDash val="solid"/>
-                <a:round/>
-              </a:ln>
-              <a:effectLst/>
-            </c:spPr>
-          </c:marker>
-          <c:cat>
-            <c:multiLvlStrRef>
-              <c:f>Sheet1!$A$2:$A$27</c:f>
-              <c:multiLvlStrCache>
-                <c:ptCount val="26"/>
-                <c:lvl>
-                  <c:pt idx="0">
-                    <c:v>2000</c:v>
-                  </c:pt>
-                  <c:pt idx="1">
-                    <c:v>2001</c:v>
-                  </c:pt>
-                  <c:pt idx="2">
-                    <c:v>2002</c:v>
-                  </c:pt>
-                  <c:pt idx="3">
-                    <c:v>2003</c:v>
-                  </c:pt>
-                  <c:pt idx="4">
-                    <c:v>2004</c:v>
-                  </c:pt>
-                  <c:pt idx="5">
-                    <c:v>2005</c:v>
-                  </c:pt>
-                  <c:pt idx="6">
-                    <c:v>2006</c:v>
-                  </c:pt>
-                  <c:pt idx="7">
-                    <c:v>2007</c:v>
-                  </c:pt>
-                  <c:pt idx="8">
-                    <c:v>2008</c:v>
-                  </c:pt>
-                  <c:pt idx="9">
-                    <c:v>2009</c:v>
-                  </c:pt>
-                  <c:pt idx="10">
-                    <c:v>2010</c:v>
-                  </c:pt>
-                  <c:pt idx="11">
-                    <c:v>2011</c:v>
-                  </c:pt>
-                  <c:pt idx="12">
-                    <c:v>2012</c:v>
-                  </c:pt>
-                  <c:pt idx="13">
-                    <c:v>2013</c:v>
-                  </c:pt>
-                  <c:pt idx="14">
-                    <c:v>2014</c:v>
-                  </c:pt>
-                  <c:pt idx="15">
-                    <c:v>2015</c:v>
-                  </c:pt>
-                  <c:pt idx="16">
-                    <c:v>2016</c:v>
-                  </c:pt>
-                  <c:pt idx="17">
-                    <c:v>2017</c:v>
-                  </c:pt>
-                  <c:pt idx="18">
-                    <c:v>2018</c:v>
-                  </c:pt>
-                  <c:pt idx="19">
-                    <c:v>2019</c:v>
-                  </c:pt>
-                  <c:pt idx="20">
-                    <c:v>2020</c:v>
-                  </c:pt>
-                  <c:pt idx="21">
-                    <c:v>2021</c:v>
-                  </c:pt>
-                  <c:pt idx="22">
-                    <c:v>2022</c:v>
-                  </c:pt>
-                  <c:pt idx="23">
-                    <c:v>2023</c:v>
-                  </c:pt>
-                  <c:pt idx="24">
-                    <c:v>2024</c:v>
-                  </c:pt>
-                  <c:pt idx="25">
-                    <c:v>2025</c:v>
-                  </c:pt>
-                </c:lvl>
-              </c:multiLvlStrCache>
-            </c:multiLvlStrRef>
-          </c:cat>
-          <c:val>
-            <c:numRef>
-              <c:f>Sheet1!$D$2:$D$27</c:f>
-              <c:numCache>
-                <c:formatCode>General</c:formatCode>
-                <c:ptCount val="26"/>
-                <c:pt idx="0">
-                  <c:v>27.75</c:v>
-                </c:pt>
-                <c:pt idx="1">
-                  <c:v>26.82</c:v>
-                </c:pt>
-                <c:pt idx="2">
-                  <c:v>26.51</c:v>
-                </c:pt>
-                <c:pt idx="3">
-                  <c:v>25.76</c:v>
-                </c:pt>
-                <c:pt idx="4">
-                  <c:v>25.77</c:v>
-                </c:pt>
-                <c:pt idx="5">
-                  <c:v>26</c:v>
-                </c:pt>
-                <c:pt idx="6">
-                  <c:v>26.3</c:v>
-                </c:pt>
-                <c:pt idx="7">
-                  <c:v>26.8</c:v>
-                </c:pt>
-                <c:pt idx="8">
-                  <c:v>27.1</c:v>
-                </c:pt>
-                <c:pt idx="9">
-                  <c:v>27.2</c:v>
-                </c:pt>
-                <c:pt idx="10">
-                  <c:v>27.3</c:v>
-                </c:pt>
-                <c:pt idx="11">
-                  <c:v>27.1</c:v>
-                </c:pt>
-                <c:pt idx="12">
-                  <c:v>26.6</c:v>
-                </c:pt>
-                <c:pt idx="13">
-                  <c:v>26</c:v>
-                </c:pt>
-                <c:pt idx="14">
-                  <c:v>25.6</c:v>
-                </c:pt>
-                <c:pt idx="15">
-                  <c:v>25.1</c:v>
-                </c:pt>
-                <c:pt idx="16">
-                  <c:v>24.6</c:v>
-                </c:pt>
-                <c:pt idx="17">
-                  <c:v>24.3</c:v>
-                </c:pt>
-                <c:pt idx="18">
-                  <c:v>24.1</c:v>
-                </c:pt>
-                <c:pt idx="19">
-                  <c:v>25</c:v>
-                </c:pt>
-                <c:pt idx="20">
-                  <c:v>26</c:v>
-                </c:pt>
-                <c:pt idx="21">
-                  <c:v>25.6</c:v>
-                </c:pt>
-                <c:pt idx="22">
-                  <c:v>25.8</c:v>
-                </c:pt>
-                <c:pt idx="23">
-                  <c:v>26</c:v>
-                </c:pt>
-                <c:pt idx="24">
-                  <c:v>25.3</c:v>
-                </c:pt>
-                <c:pt idx="25">
-                  <c:v>26.28</c:v>
-                </c:pt>
-              </c:numCache>
-            </c:numRef>
-          </c:val>
-          <c:smooth val="0"/>
-        </c:ser>
-        <c:dLbls>
-          <c:numFmt formatCode="#,##0" sourceLinked="0"/>
-          <c:txPr>
-            <a:bodyPr/>
-            <a:lstStyle/>
-            <a:p>
-              <a:pPr>
-                <a:defRPr b="0" i="0" strike="noStrike" sz="1200" u="none">
-                  <a:solidFill>
-                    <a:srgbClr val="000000"/>
-                  </a:solidFill>
-                  <a:latin typeface="Arial"/>
-                </a:defRPr>
-              </a:pPr>
-            </a:p>
-          </c:txPr>
-          <c:showLegendKey val="0"/>
-          <c:showVal val="0"/>
-          <c:showCatName val="0"/>
-          <c:showSerName val="0"/>
-          <c:showPercent val="0"/>
-          <c:showBubbleSize val="0"/>
-          <c:showLeaderLines val="0"/>
-        </c:dLbls>
-        <c:marker val="1"/>
-        <c:axId val="2094734554"/>
-        <c:axId val="2094734552"/>
-        <c:axId val="2094734556"/>
-      </c:lineChart>
-      <c:catAx>
-        <c:axId val="2094734554"/>
-        <c:scaling>
-          <c:orientation val="minMax"/>
-        </c:scaling>
-        <c:delete val="0"/>
-        <c:axPos val="b"/>
-        <c:numFmt formatCode="General" sourceLinked="1"/>
-        <c:majorTickMark val="out"/>
-        <c:minorTickMark val="none"/>
-        <c:tickLblPos val="low"/>
-        <c:spPr>
-          <a:ln w="12700" cap="flat">
-            <a:solidFill>
-              <a:srgbClr val="888888"/>
-            </a:solidFill>
-            <a:prstDash val="solid"/>
-            <a:round/>
-          </a:ln>
-        </c:spPr>
-        <c:txPr>
-          <a:bodyPr rot="-2700000"/>
-          <a:lstStyle/>
-          <a:p>
-            <a:pPr>
-              <a:defRPr sz="900" b="0" i="0" u="none" strike="noStrike">
-                <a:solidFill>
-                  <a:srgbClr val="5B6483"/>
-                </a:solidFill>
-                <a:latin typeface="Calibri"/>
-              </a:defRPr>
-            </a:pPr>
-            <a:endParaRPr lang="en-US"/>
-          </a:p>
-        </c:txPr>
-        <c:crossAx val="2094734552"/>
-        <c:crosses val="autoZero"/>
-        <c:auto val="1"/>
-        <c:lblAlgn val="ctr"/>
-        <c:noMultiLvlLbl val="1"/>
-      </c:catAx>
-      <c:valAx>
-        <c:axId val="2094734552"/>
-        <c:scaling>
-          <c:orientation val="minMax"/>
-          <c:max val="65"/>
-          <c:min val="20"/>
-        </c:scaling>
-        <c:delete val="0"/>
-        <c:axPos val="l"/>
-        <c:majorGridlines>
-          <c:spPr>
-            <a:ln w="6350" cap="flat">
-              <a:solidFill>
-                <a:srgbClr val="D7DBE8"/>
-              </a:solidFill>
-              <a:prstDash val="solid"/>
-              <a:round/>
-            </a:ln>
-          </c:spPr>
-        </c:majorGridlines>
-        <c:title>
-          <c:tx>
-            <c:rich>
-              <a:bodyPr/>
-              <a:lstStyle/>
-              <a:p>
-                <a:pPr>
-                  <a:defRPr sz="1000" b="0" i="0" u="none" strike="noStrike">
-                    <a:solidFill>
-                      <a:srgbClr val="5B6483"/>
-                    </a:solidFill>
-                    <a:latin typeface="Arial"/>
-                  </a:defRPr>
-                </a:pPr>
-                <a:r>
-                  <a:rPr sz="1000" b="0" i="0" u="none" strike="noStrike">
-                    <a:solidFill>
-                      <a:srgbClr val="5B6483"/>
-                    </a:solidFill>
-                    <a:latin typeface="Arial"/>
-                  </a:rPr>
-                  <a:t>Clearance rate (%)</a:t>
-                </a:r>
-              </a:p>
-            </c:rich>
-          </c:tx>
-          <c:layout/>
-          <c:overlay val="0"/>
-        </c:title>
-        <c:numFmt formatCode="General" sourceLinked="0"/>
-        <c:majorTickMark val="out"/>
-        <c:minorTickMark val="none"/>
-        <c:tickLblPos val="nextTo"/>
-        <c:spPr>
-          <a:ln w="12700" cap="flat">
-            <a:solidFill>
-              <a:srgbClr val="888888"/>
-            </a:solidFill>
-            <a:prstDash val="solid"/>
-            <a:round/>
-          </a:ln>
-        </c:spPr>
-        <c:txPr>
-          <a:bodyPr/>
-          <a:lstStyle/>
-          <a:p>
-            <a:pPr>
-              <a:defRPr sz="900" b="0" i="0" u="none" strike="noStrike">
-                <a:solidFill>
-                  <a:srgbClr val="5B6483"/>
-                </a:solidFill>
-                <a:latin typeface="Calibri"/>
-              </a:defRPr>
-            </a:pPr>
-            <a:endParaRPr lang="en-US"/>
-          </a:p>
-        </c:txPr>
-        <c:crossAx val="2094734554"/>
-        <c:crosses val="autoZero"/>
-        <c:crossBetween val="between"/>
-      </c:valAx>
-      <c:spPr>
-        <a:noFill/>
-        <a:ln>
-          <a:noFill/>
-        </a:ln>
-        <a:effectLst/>
-      </c:spPr>
-    </c:plotArea>
-    <c:legend>
-      <c:legendPos val="t"/>
-      <c:overlay val="0"/>
-      <c:txPr>
-        <a:bodyPr/>
-        <a:lstStyle/>
-        <a:p>
-          <a:pPr>
-            <a:defRPr sz="900">
-              <a:solidFill>
-                <a:srgbClr val="0F1A3D"/>
-              </a:solidFill>
-            </a:defRPr>
-          </a:pPr>
-          <a:endParaRPr lang="en-US"/>
-        </a:p>
-      </c:txPr>
-    </c:legend>
-    <c:plotVisOnly val="1"/>
-    <c:dispBlanksAs val="span"/>
-  </c:chart>
-  <c:spPr>
-    <a:noFill/>
-    <a:ln>
-      <a:noFill/>
-    </a:ln>
-    <a:effectLst/>
-  </c:spPr>
-  <c:externalData r:id="rId1">
-    <c:autoUpdate val="0"/>
-  </c:externalData>
-</c:chartSpace>
-</file>
-
-<file path=ppt/charts/chart4.xml><?xml version="1.0" encoding="utf-8"?>
-<c:chartSpace xmlns:c="http://schemas.openxmlformats.org/drawingml/2006/chart" xmlns:a="http://schemas.openxmlformats.org/drawingml/2006/main" xmlns:r="http://schemas.openxmlformats.org/officeDocument/2006/relationships">
-  <c:date1904 val="0"/>
-  <c:roundedCorners val="1"/>
-  <c:chart>
-    <c:title>
-      <c:tx>
-        <c:rich>
-          <a:bodyPr/>
-          <a:lstStyle/>
-          <a:p>
-            <a:pPr>
-              <a:defRPr sz="1200" b="0" i="0" u="none" strike="noStrike">
-                <a:solidFill>
-                  <a:srgbClr val="0F1A3D"/>
-                </a:solidFill>
-                <a:latin typeface="Calibri"/>
-              </a:defRPr>
-            </a:pPr>
-            <a:r>
-              <a:rPr sz="1200" b="0" i="0" u="none" strike="noStrike">
-                <a:solidFill>
-                  <a:srgbClr val="0F1A3D"/>
-                </a:solidFill>
-                <a:latin typeface="Calibri"/>
-              </a:rPr>
-              <a:t>Total Organized Crime Violations in Canada (2016–2025)</a:t>
-            </a:r>
-          </a:p>
-        </c:rich>
-      </c:tx>
-      <c:layout/>
-      <c:overlay val="0"/>
-    </c:title>
-    <c:autoTitleDeleted val="0"/>
-    <c:plotArea>
-      <c:layout/>
-      <c:lineChart>
-        <c:varyColors val="0"/>
-        <c:ser>
-          <c:idx val="0"/>
-          <c:order val="0"/>
-          <c:tx>
-            <c:strRef>
-              <c:f>Sheet1!$B$1</c:f>
-              <c:strCache>
-                <c:ptCount val="1"/>
-                <c:pt idx="0">
-                  <c:v>Organized crime violations</c:v>
-                </c:pt>
-              </c:strCache>
-            </c:strRef>
-          </c:tx>
-          <c:spPr>
-            <a:solidFill>
-              <a:srgbClr val="3771C8"/>
-            </a:solidFill>
-            <a:ln w="31750" cap="flat">
-              <a:solidFill>
-                <a:srgbClr val="3771C8"/>
-              </a:solidFill>
-              <a:prstDash val="solid"/>
-              <a:round/>
-            </a:ln>
-            <a:effectLst/>
-          </c:spPr>
-          <c:invertIfNegative val="0"/>
-          <c:dLbls>
-            <c:numFmt formatCode="#,##0" sourceLinked="0"/>
-            <c:txPr>
-              <a:bodyPr/>
-              <a:lstStyle/>
-              <a:p>
-                <a:pPr>
-                  <a:defRPr b="0" i="0" strike="noStrike" sz="900" u="none">
-                    <a:solidFill>
-                      <a:srgbClr val="0F1A3D"/>
-                    </a:solidFill>
-                    <a:latin typeface="Calibri"/>
-                  </a:defRPr>
-                </a:pPr>
-              </a:p>
-            </c:txPr>
-            <c:dLblPos val="t"/>
-            <c:showLegendKey val="0"/>
-            <c:showVal val="1"/>
-            <c:showCatName val="0"/>
-            <c:showSerName val="0"/>
-            <c:showPercent val="0"/>
-            <c:showBubbleSize val="0"/>
-            <c:showLeaderLines val="0"/>
-          </c:dLbls>
-          <c:marker>
-            <c:symbol val="circle"/>
-            <c:size val="6"/>
-            <c:spPr>
-              <a:solidFill>
-                <a:srgbClr val="3771C8"/>
-              </a:solidFill>
-              <a:ln w="9525" cap="flat">
-                <a:solidFill>
-                  <a:srgbClr val="3771C8"/>
-                </a:solidFill>
-                <a:prstDash val="solid"/>
-                <a:round/>
-              </a:ln>
-              <a:effectLst/>
-            </c:spPr>
-          </c:marker>
-          <c:cat>
-            <c:multiLvlStrRef>
-              <c:f>Sheet1!$A$2:$A$11</c:f>
-              <c:multiLvlStrCache>
-                <c:ptCount val="10"/>
-                <c:lvl>
-                  <c:pt idx="0">
-                    <c:v>2016</c:v>
-                  </c:pt>
-                  <c:pt idx="1">
-                    <c:v>2017</c:v>
-                  </c:pt>
-                  <c:pt idx="2">
-                    <c:v>2018</c:v>
-                  </c:pt>
-                  <c:pt idx="3">
-                    <c:v>2019</c:v>
-                  </c:pt>
-                  <c:pt idx="4">
-                    <c:v>2020</c:v>
-                  </c:pt>
-                  <c:pt idx="5">
-                    <c:v>2021</c:v>
-                  </c:pt>
-                  <c:pt idx="6">
-                    <c:v>2022</c:v>
-                  </c:pt>
-                  <c:pt idx="7">
-                    <c:v>2023</c:v>
-                  </c:pt>
-                  <c:pt idx="8">
-                    <c:v>2024</c:v>
-                  </c:pt>
-                  <c:pt idx="9">
-                    <c:v>2025</c:v>
-                  </c:pt>
-                </c:lvl>
-              </c:multiLvlStrCache>
-            </c:multiLvlStrRef>
-          </c:cat>
-          <c:val>
-            <c:numRef>
-              <c:f>Sheet1!$B$2:$B$11</c:f>
-              <c:numCache>
-                <c:formatCode>General</c:formatCode>
-                <c:ptCount val="10"/>
-                <c:pt idx="0">
-                  <c:v>4810</c:v>
-                </c:pt>
-                <c:pt idx="1">
-                  <c:v>6180</c:v>
-                </c:pt>
-                <c:pt idx="2">
-                  <c:v>6410</c:v>
-                </c:pt>
-                <c:pt idx="3">
-                  <c:v>8520</c:v>
-                </c:pt>
-                <c:pt idx="4">
-                  <c:v>10970</c:v>
-                </c:pt>
-                <c:pt idx="5">
-                  <c:v>10280</c:v>
-                </c:pt>
-                <c:pt idx="6">
-                  <c:v>11170</c:v>
-                </c:pt>
-                <c:pt idx="7">
-                  <c:v>13130</c:v>
-                </c:pt>
-                <c:pt idx="8">
-                  <c:v>14898</c:v>
-                </c:pt>
-                <c:pt idx="9">
-                  <c:v>14398</c:v>
-                </c:pt>
-              </c:numCache>
-            </c:numRef>
-          </c:val>
-          <c:smooth val="0"/>
-        </c:ser>
-        <c:dLbls>
-          <c:numFmt formatCode="#,##0" sourceLinked="0"/>
-          <c:txPr>
-            <a:bodyPr/>
-            <a:lstStyle/>
-            <a:p>
-              <a:pPr>
-                <a:defRPr b="0" i="0" strike="noStrike" sz="900" u="none">
-                  <a:solidFill>
-                    <a:srgbClr val="0F1A3D"/>
-                  </a:solidFill>
-                  <a:latin typeface="Calibri"/>
-                </a:defRPr>
-              </a:pPr>
-            </a:p>
-          </c:txPr>
-          <c:dLblPos val="t"/>
-          <c:showLegendKey val="0"/>
-          <c:showVal val="1"/>
-          <c:showCatName val="0"/>
-          <c:showSerName val="0"/>
-          <c:showPercent val="0"/>
-          <c:showBubbleSize val="0"/>
-          <c:showLeaderLines val="0"/>
-        </c:dLbls>
-        <c:marker val="1"/>
-        <c:axId val="2094734554"/>
-        <c:axId val="2094734552"/>
-        <c:axId val="2094734556"/>
-      </c:lineChart>
-      <c:catAx>
-        <c:axId val="2094734554"/>
-        <c:scaling>
-          <c:orientation val="minMax"/>
-        </c:scaling>
-        <c:delete val="0"/>
-        <c:axPos val="b"/>
-        <c:numFmt formatCode="General" sourceLinked="1"/>
-        <c:majorTickMark val="out"/>
-        <c:minorTickMark val="none"/>
-        <c:tickLblPos val="low"/>
-        <c:spPr>
-          <a:ln w="12700" cap="flat">
-            <a:solidFill>
-              <a:srgbClr val="888888"/>
-            </a:solidFill>
-            <a:prstDash val="solid"/>
-            <a:round/>
-          </a:ln>
-        </c:spPr>
-        <c:txPr>
-          <a:bodyPr/>
-          <a:lstStyle/>
-          <a:p>
-            <a:pPr>
-              <a:defRPr sz="1000" b="0" i="0" u="none" strike="noStrike">
-                <a:solidFill>
-                  <a:srgbClr val="5B6483"/>
-                </a:solidFill>
-                <a:latin typeface="Calibri"/>
-              </a:defRPr>
-            </a:pPr>
-            <a:endParaRPr lang="en-US"/>
-          </a:p>
-        </c:txPr>
-        <c:crossAx val="2094734552"/>
-        <c:crosses val="autoZero"/>
-        <c:auto val="1"/>
-        <c:lblAlgn val="ctr"/>
-        <c:noMultiLvlLbl val="1"/>
-      </c:catAx>
-      <c:valAx>
-        <c:axId val="2094734552"/>
-        <c:scaling>
-          <c:orientation val="minMax"/>
-          <c:max val="16000"/>
-          <c:min val="4000"/>
-        </c:scaling>
-        <c:delete val="0"/>
-        <c:axPos val="l"/>
-        <c:majorGridlines>
-          <c:spPr>
-            <a:ln w="6350" cap="flat">
-              <a:solidFill>
-                <a:srgbClr val="D7DBE8"/>
-              </a:solidFill>
-              <a:prstDash val="solid"/>
-              <a:round/>
-            </a:ln>
-          </c:spPr>
-        </c:majorGridlines>
-        <c:title>
-          <c:tx>
-            <c:rich>
-              <a:bodyPr/>
-              <a:lstStyle/>
-              <a:p>
-                <a:pPr>
-                  <a:defRPr sz="1000" b="0" i="0" u="none" strike="noStrike">
-                    <a:solidFill>
-                      <a:srgbClr val="5B6483"/>
-                    </a:solidFill>
-                    <a:latin typeface="Arial"/>
-                  </a:defRPr>
-                </a:pPr>
-                <a:r>
-                  <a:rPr sz="1000" b="0" i="0" u="none" strike="noStrike">
-                    <a:solidFill>
-                      <a:srgbClr val="5B6483"/>
-                    </a:solidFill>
-                    <a:latin typeface="Arial"/>
-                  </a:rPr>
-                  <a:t>Number of Violations</a:t>
-                </a:r>
-              </a:p>
-            </c:rich>
-          </c:tx>
-          <c:layout/>
-          <c:overlay val="0"/>
-        </c:title>
-        <c:numFmt formatCode="General" sourceLinked="0"/>
-        <c:majorTickMark val="out"/>
-        <c:minorTickMark val="none"/>
-        <c:tickLblPos val="nextTo"/>
-        <c:spPr>
-          <a:ln w="12700" cap="flat">
-            <a:solidFill>
-              <a:srgbClr val="888888"/>
-            </a:solidFill>
-            <a:prstDash val="solid"/>
-            <a:round/>
-          </a:ln>
-        </c:spPr>
-        <c:txPr>
-          <a:bodyPr/>
-          <a:lstStyle/>
-          <a:p>
-            <a:pPr>
-              <a:defRPr sz="1000" b="0" i="0" u="none" strike="noStrike">
-                <a:solidFill>
-                  <a:srgbClr val="5B6483"/>
-                </a:solidFill>
-                <a:latin typeface="Calibri"/>
-              </a:defRPr>
-            </a:pPr>
-            <a:endParaRPr lang="en-US"/>
-          </a:p>
-        </c:txPr>
-        <c:crossAx val="2094734554"/>
-        <c:crosses val="autoZero"/>
-        <c:crossBetween val="between"/>
-      </c:valAx>
-      <c:spPr>
-        <a:noFill/>
-        <a:ln>
-          <a:noFill/>
-        </a:ln>
-        <a:effectLst/>
-      </c:spPr>
-    </c:plotArea>
-    <c:plotVisOnly val="1"/>
-    <c:dispBlanksAs val="span"/>
-  </c:chart>
-  <c:spPr>
-    <a:noFill/>
-    <a:ln>
-      <a:noFill/>
-    </a:ln>
-    <a:effectLst/>
-  </c:spPr>
-  <c:externalData r:id="rId1">
-    <c:autoUpdate val="0"/>
-  </c:externalData>
-</c:chartSpace>
 </file>
 
 <file path=ppt/notesMasters/notesMaster1.xml><?xml version="1.0" encoding="utf-8"?>
@@ -4841,7 +2157,7 @@
                 <a:ea typeface="Cambria" pitchFamily="34" charset="-122"/>
                 <a:cs typeface="Cambria" pitchFamily="34" charset="-120"/>
               </a:rPr>
-              <a:t>Second straight annual decline — but CSI is still 14% above its 2014 low.</a:t>
+              <a:t>Second straight annual decline — CSI 75.01 in 2025 vs. 78.84 in 2024.</a:t>
             </a:r>
             <a:endParaRPr lang="en-US" sz="1100" dirty="0"/>
           </a:p>
@@ -5129,7 +2445,7 @@
                 <a:ea typeface="Cambria" pitchFamily="34" charset="-122"/>
                 <a:cs typeface="Cambria" pitchFamily="34" charset="-120"/>
               </a:rPr>
-              <a:t>Reversing a decade-long slide.</a:t>
+              <a:t>36.64% in 2025 — reversing recent declines.</a:t>
             </a:r>
             <a:endParaRPr lang="en-US" sz="1100" dirty="0"/>
           </a:p>
@@ -5531,22 +2847,29 @@
           </a:ln>
         </p:spPr>
       </p:sp>
-      <p:graphicFrame>
-        <p:nvGraphicFramePr>
-          <p:cNvPr id="5" name="Chart 0" descr=""/>
-          <p:cNvGraphicFramePr/>
-          <p:nvPr/>
-        </p:nvGraphicFramePr>
-        <p:xfrm>
-          <a:off x="640080" y="1965960"/>
-          <a:ext cx="7589520" cy="4206240"/>
-        </p:xfrm>
-        <a:graphic xmlns:a="http://schemas.openxmlformats.org/drawingml/2006/main">
-          <a:graphicData uri="http://schemas.openxmlformats.org/drawingml/2006/chart">
-            <c:chart xmlns:c="http://schemas.openxmlformats.org/drawingml/2006/chart" r:id="rId1"/>
-          </a:graphicData>
-        </a:graphic>
-      </p:graphicFrame>
+      <p:pic>
+        <p:nvPicPr>
+          <p:cNvPr id="5" name="Image 0" descr="preencoded.png">    </p:cNvPr>
+          <p:cNvPicPr>
+            <a:picLocks noChangeAspect="1"/>
+          </p:cNvPicPr>
+          <p:nvPr/>
+        </p:nvPicPr>
+        <p:blipFill>
+          <a:blip r:embed="rId1"/>
+          <a:srcRect l="0" r="0" t="0" b="0"/>
+          <a:stretch/>
+        </p:blipFill>
+        <p:spPr>
+          <a:xfrm>
+            <a:off x="640080" y="1965960"/>
+            <a:ext cx="7589520" cy="4206240"/>
+          </a:xfrm>
+          <a:prstGeom prst="rect">
+            <a:avLst/>
+          </a:prstGeom>
+        </p:spPr>
+      </p:pic>
       <p:sp>
         <p:nvSpPr>
           <p:cNvPr id="6" name="Shape 3"/>
@@ -5607,7 +2930,7 @@
                 <a:ea typeface="Calibri" pitchFamily="34" charset="-122"/>
                 <a:cs typeface="Calibri" pitchFamily="34" charset="-120"/>
               </a:rPr>
-              <a:t>What the line shows</a:t>
+              <a:t>The 2025 numbers</a:t>
             </a:r>
             <a:endParaRPr lang="en-US" sz="1200" dirty="0"/>
           </a:p>
@@ -5646,7 +2969,7 @@
                 <a:ea typeface="Calibri" pitchFamily="34" charset="-122"/>
                 <a:cs typeface="Calibri" pitchFamily="34" charset="-120"/>
               </a:rPr>
-              <a:t>Overall CSI fell from 106.7 in 2000 to 75.0 in 2025 — but it is still ~14% above the 2014 low of roughly 66.</a:t>
+              <a:t>CSI 75.01 (−4.86%). Non-violent CSI 66.78 (−5.26%). Violent CSI 97.19 (−4.17%).</a:t>
             </a:r>
             <a:endParaRPr lang="en-US" sz="1100" dirty="0"/>
           </a:p>
@@ -5802,7 +3125,7 @@
                 <a:ea typeface="Calibri" pitchFamily="34" charset="-122"/>
                 <a:cs typeface="Calibri" pitchFamily="34" charset="-120"/>
               </a:rPr>
-              <a:t>Non-violent CSI drives most of 2025's improvement — down 5.3% year over year.</a:t>
+              <a:t>Non-violent CSI drove most of the 2025 improvement — youth non-violent CSI fell −6.41%.</a:t>
             </a:r>
             <a:endParaRPr lang="en-US" sz="1100" dirty="0"/>
           </a:p>
@@ -7523,7 +4846,7 @@
                 <a:ea typeface="Calibri" pitchFamily="34" charset="-122"/>
                 <a:cs typeface="Calibri" pitchFamily="34" charset="-120"/>
               </a:rPr>
-              <a:t>Rate per 100,000 population · the most dangerous arson category rose against a falling overall trend.</a:t>
+              <a:t>Rate per 100,000 population — the most dangerous arson category rose against a falling overall trend.</a:t>
             </a:r>
             <a:endParaRPr lang="en-US" sz="1000" dirty="0"/>
           </a:p>
@@ -8024,7 +5347,7 @@
                 <a:ea typeface="Calibri" pitchFamily="34" charset="-122"/>
                 <a:cs typeface="Calibri" pitchFamily="34" charset="-120"/>
               </a:rPr>
-              <a:t>Now 501.6 per 100,000 — continues to run against the broader property-crime decline.</a:t>
+              <a:t>Now 501.64 per 100,000 — continues to run against the broader property-crime decline.</a:t>
             </a:r>
             <a:endParaRPr lang="en-US" sz="1000" dirty="0"/>
           </a:p>
@@ -8285,9 +5608,6 @@
           <a:lstStyle/>
           <a:p>
             <a:pPr indent="0" marL="0">
-              <a:spcAft>
-                <a:spcPts val="600"/>
-              </a:spcAft>
               <a:buNone/>
             </a:pPr>
             <a:r>
@@ -8302,9 +5622,6 @@
               <a:t>The overall picture is down, but </a:t>
             </a:r>
             <a:pPr indent="0" marL="0">
-              <a:spcAft>
-                <a:spcPts val="600"/>
-              </a:spcAft>
               <a:buNone/>
             </a:pPr>
             <a:r>
@@ -8319,9 +5636,6 @@
               <a:t>the headline masks pockets that got worse</a:t>
             </a:r>
             <a:pPr indent="0" marL="0">
-              <a:spcAft>
-                <a:spcPts val="600"/>
-              </a:spcAft>
               <a:buNone/>
             </a:pPr>
             <a:r>
@@ -8658,22 +5972,29 @@
           </a:ln>
         </p:spPr>
       </p:sp>
-      <p:graphicFrame>
-        <p:nvGraphicFramePr>
-          <p:cNvPr id="5" name="Chart 0" descr=""/>
-          <p:cNvGraphicFramePr/>
-          <p:nvPr/>
-        </p:nvGraphicFramePr>
-        <p:xfrm>
-          <a:off x="640080" y="1965960"/>
-          <a:ext cx="7589520" cy="4206240"/>
-        </p:xfrm>
-        <a:graphic xmlns:a="http://schemas.openxmlformats.org/drawingml/2006/main">
-          <a:graphicData uri="http://schemas.openxmlformats.org/drawingml/2006/chart">
-            <c:chart xmlns:c="http://schemas.openxmlformats.org/drawingml/2006/chart" r:id="rId1"/>
-          </a:graphicData>
-        </a:graphic>
-      </p:graphicFrame>
+      <p:pic>
+        <p:nvPicPr>
+          <p:cNvPr id="5" name="Image 0" descr="preencoded.png">    </p:cNvPr>
+          <p:cNvPicPr>
+            <a:picLocks noChangeAspect="1"/>
+          </p:cNvPicPr>
+          <p:nvPr/>
+        </p:nvPicPr>
+        <p:blipFill>
+          <a:blip r:embed="rId1"/>
+          <a:srcRect l="0" r="0" t="0" b="0"/>
+          <a:stretch/>
+        </p:blipFill>
+        <p:spPr>
+          <a:xfrm>
+            <a:off x="640080" y="1965960"/>
+            <a:ext cx="7589520" cy="4206240"/>
+          </a:xfrm>
+          <a:prstGeom prst="rect">
+            <a:avLst/>
+          </a:prstGeom>
+        </p:spPr>
+      </p:pic>
       <p:sp>
         <p:nvSpPr>
           <p:cNvPr id="6" name="Shape 3"/>
@@ -8734,7 +6055,7 @@
                 <a:ea typeface="Calibri" pitchFamily="34" charset="-122"/>
                 <a:cs typeface="Calibri" pitchFamily="34" charset="-120"/>
               </a:rPr>
-              <a:t>Main insight</a:t>
+              <a:t>The 2025 number</a:t>
             </a:r>
             <a:endParaRPr lang="en-US" sz="1200" dirty="0"/>
           </a:p>
@@ -8773,7 +6094,7 @@
                 <a:ea typeface="Calibri" pitchFamily="34" charset="-122"/>
                 <a:cs typeface="Calibri" pitchFamily="34" charset="-120"/>
               </a:rPr>
-              <a:t>After 8 years of near-continuous growth, cybercrime has cooled — 2025 marks the second straight annual decline from the 2023 peak.</a:t>
+              <a:t>90,643 cyber-related violations in 2025 — a second straight annual decline from the peak reached in 2023.</a:t>
             </a:r>
             <a:endParaRPr lang="en-US" sz="1100" dirty="0"/>
           </a:p>
@@ -8851,7 +6172,7 @@
                 <a:ea typeface="Calibri" pitchFamily="34" charset="-122"/>
                 <a:cs typeface="Calibri" pitchFamily="34" charset="-120"/>
               </a:rPr>
-              <a:t>90,643 violations in 2025 is still ~6× the 2014 baseline of 15,184. The plateau is high, not low.</a:t>
+              <a:t>Still ~6× the 2014 baseline of 15,184. The plateau is high, not low.</a:t>
             </a:r>
             <a:endParaRPr lang="en-US" sz="1100" dirty="0"/>
           </a:p>
@@ -9148,22 +6469,29 @@
           </a:ln>
         </p:spPr>
       </p:sp>
-      <p:graphicFrame>
-        <p:nvGraphicFramePr>
-          <p:cNvPr id="5" name="Chart 0" descr=""/>
-          <p:cNvGraphicFramePr/>
-          <p:nvPr/>
-        </p:nvGraphicFramePr>
-        <p:xfrm>
-          <a:off x="640080" y="1965960"/>
-          <a:ext cx="7589520" cy="4206240"/>
-        </p:xfrm>
-        <a:graphic xmlns:a="http://schemas.openxmlformats.org/drawingml/2006/main">
-          <a:graphicData uri="http://schemas.openxmlformats.org/drawingml/2006/chart">
-            <c:chart xmlns:c="http://schemas.openxmlformats.org/drawingml/2006/chart" r:id="rId1"/>
-          </a:graphicData>
-        </a:graphic>
-      </p:graphicFrame>
+      <p:pic>
+        <p:nvPicPr>
+          <p:cNvPr id="5" name="Image 0" descr="preencoded.png">    </p:cNvPr>
+          <p:cNvPicPr>
+            <a:picLocks noChangeAspect="1"/>
+          </p:cNvPicPr>
+          <p:nvPr/>
+        </p:nvPicPr>
+        <p:blipFill>
+          <a:blip r:embed="rId1"/>
+          <a:srcRect l="0" r="0" t="0" b="0"/>
+          <a:stretch/>
+        </p:blipFill>
+        <p:spPr>
+          <a:xfrm>
+            <a:off x="640080" y="1965960"/>
+            <a:ext cx="7589520" cy="4206240"/>
+          </a:xfrm>
+          <a:prstGeom prst="rect">
+            <a:avLst/>
+          </a:prstGeom>
+        </p:spPr>
+      </p:pic>
       <p:sp>
         <p:nvSpPr>
           <p:cNvPr id="6" name="Shape 3"/>
@@ -9224,7 +6552,7 @@
                 <a:ea typeface="Calibri" pitchFamily="34" charset="-122"/>
                 <a:cs typeface="Calibri" pitchFamily="34" charset="-120"/>
               </a:rPr>
-              <a:t>Main insight</a:t>
+              <a:t>The 2025 numbers</a:t>
             </a:r>
             <a:endParaRPr lang="en-US" sz="1200" dirty="0"/>
           </a:p>
@@ -9263,7 +6591,7 @@
                 <a:ea typeface="Calibri" pitchFamily="34" charset="-122"/>
                 <a:cs typeface="Calibri" pitchFamily="34" charset="-120"/>
               </a:rPr>
-              <a:t>36.64% of cases cleared in 2025 — up +2.35% from 2024. Reverses a decade-long slide, but still below the 2008 peak.</a:t>
+              <a:t>Overall weighted clearance rate 36.64% (+2.35%). Violent 54.46%. Non-violent 26.28%.</a:t>
             </a:r>
             <a:endParaRPr lang="en-US" sz="1100" dirty="0"/>
           </a:p>
@@ -9302,7 +6630,7 @@
                 <a:ea typeface="Calibri" pitchFamily="34" charset="-122"/>
                 <a:cs typeface="Calibri" pitchFamily="34" charset="-120"/>
               </a:rPr>
-              <a:t>Serious cases fare best</a:t>
+              <a:t>A reversal, but off a decade-long slide</a:t>
             </a:r>
             <a:endParaRPr lang="en-US" sz="1200" dirty="0"/>
           </a:p>
@@ -9341,7 +6669,7 @@
                 <a:ea typeface="Calibri" pitchFamily="34" charset="-122"/>
                 <a:cs typeface="Calibri" pitchFamily="34" charset="-120"/>
               </a:rPr>
-              <a:t>Violent clearance sits at 54.46% (roughly half solved); non-violent at just 26.28% (roughly three-quarters unsolved).</a:t>
+              <a:t>Clearance rates had trended down for years, especially for violent crime. 2025 is the first meaningful uptick.</a:t>
             </a:r>
             <a:endParaRPr lang="en-US" sz="1100" dirty="0"/>
           </a:p>
@@ -9419,7 +6747,7 @@
                 <a:ea typeface="Calibri" pitchFamily="34" charset="-122"/>
                 <a:cs typeface="Calibri" pitchFamily="34" charset="-120"/>
               </a:rPr>
-              <a:t>One year does not undo a decade. Track whether clearance holds above 36% in 2026 before calling it a durable turn.</a:t>
+              <a:t>Non-violent clearance at ~26% means roughly three-quarters of those cases still go unresolved.</a:t>
             </a:r>
             <a:endParaRPr lang="en-US" sz="1100" dirty="0"/>
           </a:p>
@@ -9737,7 +7065,7 @@
                 <a:ea typeface="Cambria" pitchFamily="34" charset="-122"/>
                 <a:cs typeface="Cambria" pitchFamily="34" charset="-120"/>
               </a:rPr>
-              <a:t>75.0 / 66</a:t>
+              <a:t>75.01</a:t>
             </a:r>
             <a:endParaRPr lang="en-US" sz="3000" dirty="0"/>
           </a:p>
@@ -9776,7 +7104,7 @@
                 <a:ea typeface="Calibri" pitchFamily="34" charset="-122"/>
                 <a:cs typeface="Calibri" pitchFamily="34" charset="-120"/>
               </a:rPr>
-              <a:t>2025 CSI of 75.0 vs. the 2014 low of roughly 66. Even after two years of decline, severity is still ~14% higher than a decade ago.</a:t>
+              <a:t>2025 CSI of 75.01 — down from 78.84 in 2024 but still well above the 2014 low visible on the CSI chart.</a:t>
             </a:r>
             <a:endParaRPr lang="en-US" sz="1100" dirty="0"/>
           </a:p>
@@ -9842,7 +7170,7 @@
                 <a:ea typeface="Calibri" pitchFamily="34" charset="-122"/>
                 <a:cs typeface="Calibri" pitchFamily="34" charset="-120"/>
               </a:rPr>
-              <a:t>THE DECADE THAT CAME BEFORE</a:t>
+              <a:t>VIOLENT CSI STAYS HIGH</a:t>
             </a:r>
             <a:endParaRPr lang="en-US" sz="1000" dirty="0"/>
           </a:p>
@@ -9881,7 +7209,7 @@
                 <a:ea typeface="Cambria" pitchFamily="34" charset="-122"/>
                 <a:cs typeface="Cambria" pitchFamily="34" charset="-120"/>
               </a:rPr>
-              <a:t>+22% 2014→2024</a:t>
+              <a:t>97.19</a:t>
             </a:r>
             <a:endParaRPr lang="en-US" sz="3000" dirty="0"/>
           </a:p>
@@ -9920,7 +7248,7 @@
                 <a:ea typeface="Calibri" pitchFamily="34" charset="-122"/>
                 <a:cs typeface="Calibri" pitchFamily="34" charset="-120"/>
               </a:rPr>
-              <a:t>Violent CSI climbed almost every year from 2014 through 2024. 2025's dip walks back only a fraction of that run-up.</a:t>
+              <a:t>Violent CSI fell 4.17% to 97.19 — barely off its 2024 peak of 101.42, and roughly where it sat in 2007.</a:t>
             </a:r>
             <a:endParaRPr lang="en-US" sz="1100" dirty="0"/>
           </a:p>
@@ -10064,7 +7392,7 @@
                 <a:ea typeface="Calibri" pitchFamily="34" charset="-122"/>
                 <a:cs typeface="Calibri" pitchFamily="34" charset="-120"/>
               </a:rPr>
-              <a:t>Overall crime rate fell 2.4% and CSI fell 4.86% — a modest improvement next to the 20%+ increase in severity accumulated over the prior decade.</a:t>
+              <a:t>Overall crime rate fell 2.4% and CSI fell 4.86% — modest next to the sustained rise since 2014.</a:t>
             </a:r>
             <a:endParaRPr lang="en-US" sz="1100" dirty="0"/>
           </a:p>
@@ -10507,22 +7835,29 @@
           </a:ln>
         </p:spPr>
       </p:sp>
-      <p:graphicFrame>
-        <p:nvGraphicFramePr>
-          <p:cNvPr id="5" name="Chart 0" descr=""/>
-          <p:cNvGraphicFramePr/>
-          <p:nvPr/>
-        </p:nvGraphicFramePr>
-        <p:xfrm>
-          <a:off x="640080" y="1965960"/>
-          <a:ext cx="7589520" cy="4206240"/>
-        </p:xfrm>
-        <a:graphic xmlns:a="http://schemas.openxmlformats.org/drawingml/2006/main">
-          <a:graphicData uri="http://schemas.openxmlformats.org/drawingml/2006/chart">
-            <c:chart xmlns:c="http://schemas.openxmlformats.org/drawingml/2006/chart" r:id="rId1"/>
-          </a:graphicData>
-        </a:graphic>
-      </p:graphicFrame>
+      <p:pic>
+        <p:nvPicPr>
+          <p:cNvPr id="5" name="Image 0" descr="preencoded.png">    </p:cNvPr>
+          <p:cNvPicPr>
+            <a:picLocks noChangeAspect="1"/>
+          </p:cNvPicPr>
+          <p:nvPr/>
+        </p:nvPicPr>
+        <p:blipFill>
+          <a:blip r:embed="rId1"/>
+          <a:srcRect l="0" r="0" t="0" b="0"/>
+          <a:stretch/>
+        </p:blipFill>
+        <p:spPr>
+          <a:xfrm>
+            <a:off x="640080" y="1965960"/>
+            <a:ext cx="7589520" cy="4206240"/>
+          </a:xfrm>
+          <a:prstGeom prst="rect">
+            <a:avLst/>
+          </a:prstGeom>
+        </p:spPr>
+      </p:pic>
       <p:sp>
         <p:nvSpPr>
           <p:cNvPr id="6" name="Shape 3"/>
@@ -10583,7 +7918,7 @@
                 <a:ea typeface="Calibri" pitchFamily="34" charset="-122"/>
                 <a:cs typeface="Calibri" pitchFamily="34" charset="-120"/>
               </a:rPr>
-              <a:t>What the line shows</a:t>
+              <a:t>The 2025 number</a:t>
             </a:r>
             <a:endParaRPr lang="en-US" sz="1200" dirty="0"/>
           </a:p>
@@ -10622,7 +7957,7 @@
                 <a:ea typeface="Calibri" pitchFamily="34" charset="-122"/>
                 <a:cs typeface="Calibri" pitchFamily="34" charset="-120"/>
               </a:rPr>
-              <a:t>Roughly tripled from 4,810 violations in 2016 to 14,898 in 2024.</a:t>
+              <a:t>14,398 organized-crime violations in 2025 — the first year-over-year decline since 2021 (down from 14,898 in 2024).</a:t>
             </a:r>
             <a:endParaRPr lang="en-US" sz="1100" dirty="0"/>
           </a:p>
@@ -10661,7 +7996,7 @@
                 <a:ea typeface="Calibri" pitchFamily="34" charset="-122"/>
                 <a:cs typeface="Calibri" pitchFamily="34" charset="-120"/>
               </a:rPr>
-              <a:t>First step down in five years</a:t>
+              <a:t>Still near the peak</a:t>
             </a:r>
             <a:endParaRPr lang="en-US" sz="1200" dirty="0"/>
           </a:p>
@@ -10700,7 +8035,7 @@
                 <a:ea typeface="Calibri" pitchFamily="34" charset="-122"/>
                 <a:cs typeface="Calibri" pitchFamily="34" charset="-120"/>
               </a:rPr>
-              <a:t>2025 dipped to 14,398 — the first year-over-year decline since 2021, but still nearly 3× the 2016 level.</a:t>
+              <a:t>Roughly tripled from 4,810 violations in 2016, so 2025 remains nearly 3× the 2016 level.</a:t>
             </a:r>
             <a:endParaRPr lang="en-US" sz="1100" dirty="0"/>
           </a:p>
@@ -10778,7 +8113,7 @@
                 <a:ea typeface="Calibri" pitchFamily="34" charset="-122"/>
                 <a:cs typeface="Calibri" pitchFamily="34" charset="-120"/>
               </a:rPr>
-              <a:t>Fraud (6,728) and motor-vehicle theft (1,475) remain the top two organized-crime charges.</a:t>
+              <a:t>Fraud (6,728) and motor-vehicle theft (1,475) remain the top two organized-crime charges in 2025.</a:t>
             </a:r>
             <a:endParaRPr lang="en-US" sz="1100" dirty="0"/>
           </a:p>

</xml_diff>